<commit_message>
Deck: add short explanatory bullets to slides 2-6 (claims asserted against data)
Co-Authored-By: Claude Sonnet 5.5 <noreply@anthropic.com>
Claude-Session: https://claude.ai/code/session_01J6v5JYXB5XucuZ66TGAjVJ
</commit_message>
<xml_diff>
--- a/site/deck/Colorbuds_to_Playfoam.pptx
+++ b/site/deck/Colorbuds_to_Playfoam.pptx
@@ -1114,7 +1114,7 @@
           <a:lstStyle/>
           <a:p>
             <a:r>
-              <a:t>Colorbuds earned about 28% of Q3 2022 profit and 13% of Q3 2023 profit; it is still our #1 profit toy, so it is fading, not dead. Playfoam launched in mid-August 2023; at its September pace (2,847 units x $7 profit per unit) it earns about $20K a month. Profit is estimated from current price and cost, not accounting figures.</a:t>
+              <a:t>Colorbuds earned about 28% of Q3 2022 profit and 13% of Q3 2023 profit; it is still our #1 profit toy, so it is fading, not dead. Playfoam launched in mid-August 2023; at its September pace (2,847 units x $7 profit per unit) it earns about $20K a month. Colorbuds' monthly profit is about $44K lower than in Jan 2022 ((8,110 - 2,594) units x $8). Profit is estimated from current price and cost, not accounting figures.</a:t>
             </a:r>
           </a:p>
         </p:txBody>
@@ -1184,7 +1184,7 @@
           <a:lstStyle/>
           <a:p>
             <a:r>
-              <a:t>Monthly Colorbuds units fell from 8,110 (Jan 2022) to 2,594 (Sep 2023), down 68%. The drop is steady and broad: 48 of 50 stores are down, in every store type. All 50 stores carry it and none is at zero stock, so this looks like a demand problem, not a stock problem. Some of the drop is seasonal (company-wide revenue in Sep is about 26% below its peak month) but not most of it. The data cannot say WHY demand fell; no price history, promotions or competitor data.</a:t>
+              <a:t>Monthly Colorbuds units fell from 8,110 (Jan 2022) to 2,594 (Sep 2023), down 68%. The drop is steady and broad: 48 of 50 stores are down (Jan-Sep 2023 vs Jan-Sep 2022), in every store type. All 50 stores carry it and none is at zero stock, so this looks like a demand problem, not a stock problem. Some of the drop is seasonal (company-wide revenue in Sep is about 26% below its peak month) but not most of it. The data cannot say WHY demand fell; no price history, promotions or competitor data.</a:t>
             </a:r>
           </a:p>
         </p:txBody>
@@ -1324,7 +1324,7 @@
           <a:lstStyle/>
           <a:p>
             <a:r>
-              <a:t>Playfoam launched Aug 17, 2023 and sold 4,158 units in about six weeks (1,311 in August from the 17th, 2,847 in September). It earns $7 per unit at a 64% margin, about $20K a month at the September pace. It is at zero stock in 13 stores; each store sells about 57 units a month, so empty shelves cost roughly $5K a month. Be honest: hot now, likely to cool (see the previous slide). Only six weeks of data; the $20K is a run-rate, not a forecast.</a:t>
+              <a:t>Playfoam launched Aug 17, 2023 and sold 4,158 units in about six weeks (1,311 in August from the 17th, 2,847 in September). It earns $7 per unit at a 64% margin, about $20K a month at the September pace. It is at zero stock in 13 stores; each store sells about 57 units a month, so empty shelves cost roughly $5K a month. It was the #5 profit toy in Q3 2023 despite only ~6 weeks on sale. Be honest: hot now, likely to cool (see the previous slide). Only six weeks of data; the $20K is a run-rate, not a forecast.</a:t>
             </a:r>
           </a:p>
         </p:txBody>
@@ -5802,12 +5802,12 @@
         </p:nvSpPr>
         <p:spPr>
           <a:xfrm>
-            <a:off x="640080" y="1783080"/>
-            <a:ext cx="5193792" cy="4114800"/>
+            <a:off x="640080" y="1645920"/>
+            <a:ext cx="5193792" cy="2606040"/>
           </a:xfrm>
           <a:prstGeom prst="roundRect">
             <a:avLst>
-              <a:gd name="adj" fmla="val 6000"/>
+              <a:gd name="adj" fmla="val 7000"/>
             </a:avLst>
           </a:prstGeom>
           <a:solidFill>
@@ -5848,8 +5848,8 @@
         </p:nvSpPr>
         <p:spPr>
           <a:xfrm>
-            <a:off x="1005840" y="2331720"/>
-            <a:ext cx="4480560" cy="1554480"/>
+            <a:off x="1005840" y="1828800"/>
+            <a:ext cx="4480560" cy="1051560"/>
           </a:xfrm>
           <a:prstGeom prst="rect">
             <a:avLst/>
@@ -5864,7 +5864,7 @@
           <a:p>
             <a:pPr algn="l"/>
             <a:r>
-              <a:rPr sz="6000" b="1">
+              <a:rPr sz="5400" b="1">
                 <a:solidFill>
                   <a:srgbClr val="E8457B"/>
                 </a:solidFill>
@@ -5883,8 +5883,8 @@
         </p:nvSpPr>
         <p:spPr>
           <a:xfrm>
-            <a:off x="1005840" y="4114800"/>
-            <a:ext cx="4480560" cy="457200"/>
+            <a:off x="1005840" y="3063240"/>
+            <a:ext cx="4480560" cy="411480"/>
           </a:xfrm>
           <a:prstGeom prst="rect">
             <a:avLst/>
@@ -5899,7 +5899,7 @@
           <a:p>
             <a:pPr algn="l"/>
             <a:r>
-              <a:rPr sz="2400" b="1">
+              <a:rPr sz="2200" b="1">
                 <a:solidFill>
                   <a:srgbClr val="1F1A17"/>
                 </a:solidFill>
@@ -5918,8 +5918,8 @@
         </p:nvSpPr>
         <p:spPr>
           <a:xfrm>
-            <a:off x="1005840" y="4663440"/>
-            <a:ext cx="4480560" cy="365760"/>
+            <a:off x="1005840" y="3566160"/>
+            <a:ext cx="4480560" cy="320040"/>
           </a:xfrm>
           <a:prstGeom prst="rect">
             <a:avLst/>
@@ -5934,7 +5934,7 @@
           <a:p>
             <a:pPr algn="l"/>
             <a:r>
-              <a:rPr sz="1600" b="0">
+              <a:rPr sz="1400" b="0">
                 <a:solidFill>
                   <a:srgbClr val="6B6560"/>
                 </a:solidFill>
@@ -5953,12 +5953,12 @@
         </p:nvSpPr>
         <p:spPr>
           <a:xfrm>
-            <a:off x="6355080" y="1783080"/>
-            <a:ext cx="5193792" cy="4114800"/>
+            <a:off x="6355080" y="1645920"/>
+            <a:ext cx="5193792" cy="2606040"/>
           </a:xfrm>
           <a:prstGeom prst="roundRect">
             <a:avLst>
-              <a:gd name="adj" fmla="val 6000"/>
+              <a:gd name="adj" fmla="val 7000"/>
             </a:avLst>
           </a:prstGeom>
           <a:solidFill>
@@ -5999,8 +5999,8 @@
         </p:nvSpPr>
         <p:spPr>
           <a:xfrm>
-            <a:off x="6720840" y="2331720"/>
-            <a:ext cx="4480560" cy="1554480"/>
+            <a:off x="6720840" y="1828800"/>
+            <a:ext cx="4480560" cy="1051560"/>
           </a:xfrm>
           <a:prstGeom prst="rect">
             <a:avLst/>
@@ -6015,7 +6015,7 @@
           <a:p>
             <a:pPr algn="l"/>
             <a:r>
-              <a:rPr sz="6000" b="1">
+              <a:rPr sz="5400" b="1">
                 <a:solidFill>
                   <a:srgbClr val="1BAF7A"/>
                 </a:solidFill>
@@ -6034,8 +6034,8 @@
         </p:nvSpPr>
         <p:spPr>
           <a:xfrm>
-            <a:off x="6720840" y="4114800"/>
-            <a:ext cx="4480560" cy="457200"/>
+            <a:off x="6720840" y="3063240"/>
+            <a:ext cx="4480560" cy="411480"/>
           </a:xfrm>
           <a:prstGeom prst="rect">
             <a:avLst/>
@@ -6050,7 +6050,7 @@
           <a:p>
             <a:pPr algn="l"/>
             <a:r>
-              <a:rPr sz="2400" b="1">
+              <a:rPr sz="2200" b="1">
                 <a:solidFill>
                   <a:srgbClr val="1F1A17"/>
                 </a:solidFill>
@@ -6069,8 +6069,8 @@
         </p:nvSpPr>
         <p:spPr>
           <a:xfrm>
-            <a:off x="6720840" y="4663440"/>
-            <a:ext cx="4480560" cy="365760"/>
+            <a:off x="6720840" y="3566160"/>
+            <a:ext cx="4480560" cy="320040"/>
           </a:xfrm>
           <a:prstGeom prst="rect">
             <a:avLst/>
@@ -6085,13 +6085,99 @@
           <a:p>
             <a:pPr algn="l"/>
             <a:r>
-              <a:rPr sz="1600" b="0">
+              <a:rPr sz="1400" b="0">
                 <a:solidFill>
                   <a:srgbClr val="6B6560"/>
                 </a:solidFill>
                 <a:latin typeface="Calibri"/>
               </a:rPr>
               <a:t>at its September pace</a:t>
+            </a:r>
+          </a:p>
+        </p:txBody>
+      </p:sp>
+      <p:sp>
+        <p:nvSpPr>
+          <p:cNvPr id="17" name="Key points"/>
+          <p:cNvSpPr txBox="1"/>
+          <p:nvPr/>
+        </p:nvSpPr>
+        <p:spPr>
+          <a:xfrm>
+            <a:off x="640080" y="4526280"/>
+            <a:ext cx="10881360" cy="1645920"/>
+          </a:xfrm>
+          <a:prstGeom prst="rect">
+            <a:avLst/>
+          </a:prstGeom>
+          <a:noFill/>
+        </p:spPr>
+        <p:txBody>
+          <a:bodyPr wrap="square" lIns="0" rIns="0" tIns="0" bIns="0">
+            <a:spAutoFit/>
+          </a:bodyPr>
+          <a:lstStyle/>
+          <a:p>
+            <a:pPr marL="285750" indent="-285750">
+              <a:spcAft>
+                <a:spcPts val="800"/>
+              </a:spcAft>
+              <a:buClr>
+                <a:srgbClr val="2A78D6"/>
+              </a:buClr>
+              <a:buFont typeface="Arial"/>
+              <a:buChar char="•"/>
+            </a:pPr>
+            <a:r>
+              <a:rPr sz="2000">
+                <a:solidFill>
+                  <a:srgbClr val="1F1A17"/>
+                </a:solidFill>
+                <a:latin typeface="Calibri"/>
+              </a:rPr>
+              <a:t>Colorbuds is still our #1 profit toy, but its share has more than halved</a:t>
+            </a:r>
+          </a:p>
+          <a:p>
+            <a:pPr marL="285750" indent="-285750">
+              <a:spcAft>
+                <a:spcPts val="800"/>
+              </a:spcAft>
+              <a:buClr>
+                <a:srgbClr val="2A78D6"/>
+              </a:buClr>
+              <a:buFont typeface="Arial"/>
+              <a:buChar char="•"/>
+            </a:pPr>
+            <a:r>
+              <a:rPr sz="2000">
+                <a:solidFill>
+                  <a:srgbClr val="1F1A17"/>
+                </a:solidFill>
+                <a:latin typeface="Calibri"/>
+              </a:rPr>
+              <a:t>Playfoam launched in mid-August and is already a top-5 profit toy</a:t>
+            </a:r>
+          </a:p>
+          <a:p>
+            <a:pPr marL="285750" indent="-285750">
+              <a:spcAft>
+                <a:spcPts val="800"/>
+              </a:spcAft>
+              <a:buClr>
+                <a:srgbClr val="2A78D6"/>
+              </a:buClr>
+              <a:buFont typeface="Arial"/>
+              <a:buChar char="•"/>
+            </a:pPr>
+            <a:r>
+              <a:rPr sz="2000">
+                <a:solidFill>
+                  <a:srgbClr val="1F1A17"/>
+                </a:solidFill>
+                <a:latin typeface="Calibri"/>
+              </a:rPr>
+              <a:t>Playfoam's September pace is nearly half of the $44K a month Colorbuds has lost</a:t>
             </a:r>
           </a:p>
         </p:txBody>
@@ -6410,7 +6496,7 @@
         </p:nvGraphicFramePr>
         <p:xfrm>
           <a:off x="640080" y="1874519"/>
-          <a:ext cx="10881360" cy="4297680"/>
+          <a:ext cx="7223760" cy="4297680"/>
         </p:xfrm>
         <a:graphic>
           <a:graphicData uri="http://schemas.openxmlformats.org/drawingml/2006/chart">
@@ -6426,7 +6512,7 @@
         </p:nvSpPr>
         <p:spPr>
           <a:xfrm>
-            <a:off x="640080" y="1417320"/>
+            <a:off x="640080" y="1554480"/>
             <a:ext cx="3657600" cy="274320"/>
           </a:xfrm>
           <a:prstGeom prst="rect">
@@ -6449,6 +6535,92 @@
                 <a:latin typeface="Calibri"/>
               </a:rPr>
               <a:t>units per month</a:t>
+            </a:r>
+          </a:p>
+        </p:txBody>
+      </p:sp>
+      <p:sp>
+        <p:nvSpPr>
+          <p:cNvPr id="11" name="Key points"/>
+          <p:cNvSpPr txBox="1"/>
+          <p:nvPr/>
+        </p:nvSpPr>
+        <p:spPr>
+          <a:xfrm>
+            <a:off x="8229600" y="2103120"/>
+            <a:ext cx="3383280" cy="3840480"/>
+          </a:xfrm>
+          <a:prstGeom prst="rect">
+            <a:avLst/>
+          </a:prstGeom>
+          <a:noFill/>
+        </p:spPr>
+        <p:txBody>
+          <a:bodyPr wrap="square" lIns="0" rIns="0" tIns="0" bIns="0">
+            <a:spAutoFit/>
+          </a:bodyPr>
+          <a:lstStyle/>
+          <a:p>
+            <a:pPr marL="285750" indent="-285750">
+              <a:spcAft>
+                <a:spcPts val="1400"/>
+              </a:spcAft>
+              <a:buClr>
+                <a:srgbClr val="2A78D6"/>
+              </a:buClr>
+              <a:buFont typeface="Arial"/>
+              <a:buChar char="•"/>
+            </a:pPr>
+            <a:r>
+              <a:rPr sz="2000">
+                <a:solidFill>
+                  <a:srgbClr val="1F1A17"/>
+                </a:solidFill>
+                <a:latin typeface="Calibri"/>
+              </a:rPr>
+              <a:t>Down in 48 of 50 stores, in every store type</a:t>
+            </a:r>
+          </a:p>
+          <a:p>
+            <a:pPr marL="285750" indent="-285750">
+              <a:spcAft>
+                <a:spcPts val="1400"/>
+              </a:spcAft>
+              <a:buClr>
+                <a:srgbClr val="2A78D6"/>
+              </a:buClr>
+              <a:buFont typeface="Arial"/>
+              <a:buChar char="•"/>
+            </a:pPr>
+            <a:r>
+              <a:rPr sz="2000">
+                <a:solidFill>
+                  <a:srgbClr val="1F1A17"/>
+                </a:solidFill>
+                <a:latin typeface="Calibri"/>
+              </a:rPr>
+              <a:t>Every store still carries it, so this is weaker demand, not empty shelves</a:t>
+            </a:r>
+          </a:p>
+          <a:p>
+            <a:pPr marL="285750" indent="-285750">
+              <a:spcAft>
+                <a:spcPts val="1400"/>
+              </a:spcAft>
+              <a:buClr>
+                <a:srgbClr val="2A78D6"/>
+              </a:buClr>
+              <a:buFont typeface="Arial"/>
+              <a:buChar char="•"/>
+            </a:pPr>
+            <a:r>
+              <a:rPr sz="2000">
+                <a:solidFill>
+                  <a:srgbClr val="1F1A17"/>
+                </a:solidFill>
+                <a:latin typeface="Calibri"/>
+              </a:rPr>
+              <a:t>Quarterly profit has roughly halved: $142K to $74K</a:t>
             </a:r>
           </a:p>
         </p:txBody>
@@ -6765,8 +6937,8 @@
         </p:nvSpPr>
         <p:spPr>
           <a:xfrm>
-            <a:off x="640080" y="1554480"/>
-            <a:ext cx="10881360" cy="2194560"/>
+            <a:off x="640080" y="1600200"/>
+            <a:ext cx="5852160" cy="1554480"/>
           </a:xfrm>
           <a:prstGeom prst="rect">
             <a:avLst/>
@@ -6779,9 +6951,9 @@
           </a:bodyPr>
           <a:lstStyle/>
           <a:p>
-            <a:pPr algn="ctr"/>
-            <a:r>
-              <a:rPr sz="14000" b="1">
+            <a:pPr algn="l"/>
+            <a:r>
+              <a:rPr sz="10000" b="1">
                 <a:solidFill>
                   <a:srgbClr val="EB6834"/>
                 </a:solidFill>
@@ -6800,8 +6972,8 @@
         </p:nvSpPr>
         <p:spPr>
           <a:xfrm>
-            <a:off x="640080" y="3794760"/>
-            <a:ext cx="10881360" cy="640080"/>
+            <a:off x="640080" y="3200400"/>
+            <a:ext cx="5852160" cy="822960"/>
           </a:xfrm>
           <a:prstGeom prst="rect">
             <a:avLst/>
@@ -6814,9 +6986,9 @@
           </a:bodyPr>
           <a:lstStyle/>
           <a:p>
-            <a:pPr algn="ctr"/>
-            <a:r>
-              <a:rPr sz="2800" b="0">
+            <a:pPr algn="l"/>
+            <a:r>
+              <a:rPr sz="2400" b="0">
                 <a:solidFill>
                   <a:srgbClr val="1F1A17"/>
                 </a:solidFill>
@@ -6835,8 +7007,8 @@
         </p:nvSpPr>
         <p:spPr>
           <a:xfrm>
-            <a:off x="1920240" y="4846320"/>
-            <a:ext cx="731520" cy="731520"/>
+            <a:off x="685800" y="4754880"/>
+            <a:ext cx="493776" cy="493776"/>
           </a:xfrm>
           <a:prstGeom prst="roundRect">
             <a:avLst>
@@ -6881,8 +7053,8 @@
         </p:nvSpPr>
         <p:spPr>
           <a:xfrm>
-            <a:off x="2121408" y="4754880"/>
-            <a:ext cx="329184" cy="164592"/>
+            <a:off x="813816" y="4681728"/>
+            <a:ext cx="237744" cy="128016"/>
           </a:xfrm>
           <a:prstGeom prst="ellipse">
             <a:avLst/>
@@ -6925,8 +7097,8 @@
         </p:nvSpPr>
         <p:spPr>
           <a:xfrm>
-            <a:off x="2770632" y="4846320"/>
-            <a:ext cx="731520" cy="731520"/>
+            <a:off x="1271016" y="4754880"/>
+            <a:ext cx="493776" cy="493776"/>
           </a:xfrm>
           <a:prstGeom prst="roundRect">
             <a:avLst>
@@ -6971,8 +7143,8 @@
         </p:nvSpPr>
         <p:spPr>
           <a:xfrm>
-            <a:off x="2971800" y="4754880"/>
-            <a:ext cx="329184" cy="164592"/>
+            <a:off x="1399032" y="4681728"/>
+            <a:ext cx="237744" cy="128016"/>
           </a:xfrm>
           <a:prstGeom prst="ellipse">
             <a:avLst/>
@@ -7015,8 +7187,8 @@
         </p:nvSpPr>
         <p:spPr>
           <a:xfrm>
-            <a:off x="3621024" y="4846320"/>
-            <a:ext cx="731520" cy="731520"/>
+            <a:off x="1856232" y="4754880"/>
+            <a:ext cx="493776" cy="493776"/>
           </a:xfrm>
           <a:prstGeom prst="roundRect">
             <a:avLst>
@@ -7061,8 +7233,8 @@
         </p:nvSpPr>
         <p:spPr>
           <a:xfrm>
-            <a:off x="3822191" y="4754880"/>
-            <a:ext cx="329184" cy="164592"/>
+            <a:off x="1984248" y="4681728"/>
+            <a:ext cx="237744" cy="128016"/>
           </a:xfrm>
           <a:prstGeom prst="ellipse">
             <a:avLst/>
@@ -7105,8 +7277,8 @@
         </p:nvSpPr>
         <p:spPr>
           <a:xfrm>
-            <a:off x="4471416" y="4846320"/>
-            <a:ext cx="731520" cy="731520"/>
+            <a:off x="2441448" y="4754880"/>
+            <a:ext cx="493776" cy="493776"/>
           </a:xfrm>
           <a:prstGeom prst="roundRect">
             <a:avLst>
@@ -7151,8 +7323,8 @@
         </p:nvSpPr>
         <p:spPr>
           <a:xfrm>
-            <a:off x="4672584" y="4754880"/>
-            <a:ext cx="329184" cy="164592"/>
+            <a:off x="2569464" y="4681728"/>
+            <a:ext cx="237744" cy="128016"/>
           </a:xfrm>
           <a:prstGeom prst="ellipse">
             <a:avLst/>
@@ -7195,8 +7367,8 @@
         </p:nvSpPr>
         <p:spPr>
           <a:xfrm>
-            <a:off x="5321808" y="4846320"/>
-            <a:ext cx="731520" cy="731520"/>
+            <a:off x="3026664" y="4754880"/>
+            <a:ext cx="493776" cy="493776"/>
           </a:xfrm>
           <a:prstGeom prst="roundRect">
             <a:avLst>
@@ -7241,8 +7413,8 @@
         </p:nvSpPr>
         <p:spPr>
           <a:xfrm>
-            <a:off x="5522976" y="4754880"/>
-            <a:ext cx="329184" cy="164592"/>
+            <a:off x="3154680" y="4681728"/>
+            <a:ext cx="237744" cy="128016"/>
           </a:xfrm>
           <a:prstGeom prst="ellipse">
             <a:avLst/>
@@ -7285,8 +7457,8 @@
         </p:nvSpPr>
         <p:spPr>
           <a:xfrm>
-            <a:off x="6172200" y="4846320"/>
-            <a:ext cx="731520" cy="731520"/>
+            <a:off x="3611880" y="4754880"/>
+            <a:ext cx="493776" cy="493776"/>
           </a:xfrm>
           <a:prstGeom prst="roundRect">
             <a:avLst>
@@ -7331,8 +7503,8 @@
         </p:nvSpPr>
         <p:spPr>
           <a:xfrm>
-            <a:off x="6373368" y="4754880"/>
-            <a:ext cx="329184" cy="164592"/>
+            <a:off x="3739896" y="4681728"/>
+            <a:ext cx="237744" cy="128016"/>
           </a:xfrm>
           <a:prstGeom prst="ellipse">
             <a:avLst/>
@@ -7375,8 +7547,8 @@
         </p:nvSpPr>
         <p:spPr>
           <a:xfrm>
-            <a:off x="7022592" y="4846320"/>
-            <a:ext cx="731520" cy="731520"/>
+            <a:off x="4197096" y="4754880"/>
+            <a:ext cx="493776" cy="493776"/>
           </a:xfrm>
           <a:prstGeom prst="roundRect">
             <a:avLst>
@@ -7421,8 +7593,8 @@
         </p:nvSpPr>
         <p:spPr>
           <a:xfrm>
-            <a:off x="7223759" y="4754880"/>
-            <a:ext cx="329184" cy="164592"/>
+            <a:off x="4325112" y="4681728"/>
+            <a:ext cx="237744" cy="128016"/>
           </a:xfrm>
           <a:prstGeom prst="ellipse">
             <a:avLst/>
@@ -7465,8 +7637,8 @@
         </p:nvSpPr>
         <p:spPr>
           <a:xfrm>
-            <a:off x="7872984" y="4846320"/>
-            <a:ext cx="731520" cy="731520"/>
+            <a:off x="4782312" y="4754880"/>
+            <a:ext cx="493776" cy="493776"/>
           </a:xfrm>
           <a:prstGeom prst="roundRect">
             <a:avLst>
@@ -7511,8 +7683,8 @@
         </p:nvSpPr>
         <p:spPr>
           <a:xfrm>
-            <a:off x="8074152" y="4754880"/>
-            <a:ext cx="329184" cy="164592"/>
+            <a:off x="4910328" y="4681728"/>
+            <a:ext cx="237744" cy="128016"/>
           </a:xfrm>
           <a:prstGeom prst="ellipse">
             <a:avLst/>
@@ -7555,8 +7727,8 @@
         </p:nvSpPr>
         <p:spPr>
           <a:xfrm>
-            <a:off x="8723376" y="4846320"/>
-            <a:ext cx="731520" cy="731520"/>
+            <a:off x="5367528" y="4754880"/>
+            <a:ext cx="493776" cy="493776"/>
           </a:xfrm>
           <a:prstGeom prst="roundRect">
             <a:avLst>
@@ -7601,8 +7773,8 @@
         </p:nvSpPr>
         <p:spPr>
           <a:xfrm>
-            <a:off x="8924544" y="4754880"/>
-            <a:ext cx="329184" cy="164592"/>
+            <a:off x="5495544" y="4681728"/>
+            <a:ext cx="237744" cy="128016"/>
           </a:xfrm>
           <a:prstGeom prst="ellipse">
             <a:avLst/>
@@ -7645,8 +7817,8 @@
         </p:nvSpPr>
         <p:spPr>
           <a:xfrm>
-            <a:off x="9573768" y="4846320"/>
-            <a:ext cx="731520" cy="731520"/>
+            <a:off x="5952744" y="4754880"/>
+            <a:ext cx="493776" cy="493776"/>
           </a:xfrm>
           <a:prstGeom prst="roundRect">
             <a:avLst>
@@ -7691,8 +7863,8 @@
         </p:nvSpPr>
         <p:spPr>
           <a:xfrm>
-            <a:off x="9774936" y="4754880"/>
-            <a:ext cx="329184" cy="164592"/>
+            <a:off x="6080759" y="4681728"/>
+            <a:ext cx="237744" cy="128016"/>
           </a:xfrm>
           <a:prstGeom prst="ellipse">
             <a:avLst/>
@@ -7724,6 +7896,113 @@
           <a:lstStyle/>
           <a:p>
             <a:pPr algn="ctr"/>
+          </a:p>
+        </p:txBody>
+      </p:sp>
+      <p:sp>
+        <p:nvSpPr>
+          <p:cNvPr id="31" name="Key points"/>
+          <p:cNvSpPr txBox="1"/>
+          <p:nvPr/>
+        </p:nvSpPr>
+        <p:spPr>
+          <a:xfrm>
+            <a:off x="6949440" y="1828800"/>
+            <a:ext cx="4572000" cy="4114800"/>
+          </a:xfrm>
+          <a:prstGeom prst="rect">
+            <a:avLst/>
+          </a:prstGeom>
+          <a:noFill/>
+        </p:spPr>
+        <p:txBody>
+          <a:bodyPr wrap="square" lIns="0" rIns="0" tIns="0" bIns="0">
+            <a:spAutoFit/>
+          </a:bodyPr>
+          <a:lstStyle/>
+          <a:p>
+            <a:pPr marL="285750" indent="-285750">
+              <a:spcAft>
+                <a:spcPts val="1400"/>
+              </a:spcAft>
+              <a:buClr>
+                <a:srgbClr val="2A78D6"/>
+              </a:buClr>
+              <a:buFont typeface="Arial"/>
+              <a:buChar char="•"/>
+            </a:pPr>
+            <a:r>
+              <a:rPr sz="2000">
+                <a:solidFill>
+                  <a:srgbClr val="1F1A17"/>
+                </a:solidFill>
+                <a:latin typeface="Calibri"/>
+              </a:rPr>
+              <a:t>Jenga peaked in Jul 2022 and is now down 92%</a:t>
+            </a:r>
+          </a:p>
+          <a:p>
+            <a:pPr marL="285750" indent="-285750">
+              <a:spcAft>
+                <a:spcPts val="1400"/>
+              </a:spcAft>
+              <a:buClr>
+                <a:srgbClr val="2A78D6"/>
+              </a:buClr>
+              <a:buFont typeface="Arial"/>
+              <a:buChar char="•"/>
+            </a:pPr>
+            <a:r>
+              <a:rPr sz="2000">
+                <a:solidFill>
+                  <a:srgbClr val="1F1A17"/>
+                </a:solidFill>
+                <a:latin typeface="Calibri"/>
+              </a:rPr>
+              <a:t>Etch A Sketch peaked its second month and is down 56%</a:t>
+            </a:r>
+          </a:p>
+          <a:p>
+            <a:pPr marL="285750" indent="-285750">
+              <a:spcAft>
+                <a:spcPts val="1400"/>
+              </a:spcAft>
+              <a:buClr>
+                <a:srgbClr val="2A78D6"/>
+              </a:buClr>
+              <a:buFont typeface="Arial"/>
+              <a:buChar char="•"/>
+            </a:pPr>
+            <a:r>
+              <a:rPr sz="2000">
+                <a:solidFill>
+                  <a:srgbClr val="1F1A17"/>
+                </a:solidFill>
+                <a:latin typeface="Calibri"/>
+              </a:rPr>
+              <a:t>Hot Wheels is the lone exception, down just 9%</a:t>
+            </a:r>
+          </a:p>
+          <a:p>
+            <a:pPr marL="285750" indent="-285750">
+              <a:spcAft>
+                <a:spcPts val="1400"/>
+              </a:spcAft>
+              <a:buClr>
+                <a:srgbClr val="2A78D6"/>
+              </a:buClr>
+              <a:buFont typeface="Arial"/>
+              <a:buChar char="•"/>
+            </a:pPr>
+            <a:r>
+              <a:rPr sz="2000">
+                <a:solidFill>
+                  <a:srgbClr val="1F1A17"/>
+                </a:solidFill>
+                <a:latin typeface="Calibri"/>
+              </a:rPr>
+              <a:t>Colorbuds follows the same pattern</a:t>
+            </a:r>
           </a:p>
         </p:txBody>
       </p:sp>
@@ -8041,7 +8320,7 @@
         </p:nvGraphicFramePr>
         <p:xfrm>
           <a:off x="640080" y="1874519"/>
-          <a:ext cx="6675120" cy="4251960"/>
+          <a:ext cx="5852160" cy="4251960"/>
         </p:xfrm>
         <a:graphic>
           <a:graphicData uri="http://schemas.openxmlformats.org/drawingml/2006/chart">
@@ -8092,12 +8371,12 @@
         </p:nvSpPr>
         <p:spPr>
           <a:xfrm>
-            <a:off x="7772400" y="2011680"/>
-            <a:ext cx="3749039" cy="1783080"/>
+            <a:off x="6949440" y="1737360"/>
+            <a:ext cx="4572000" cy="1280160"/>
           </a:xfrm>
           <a:prstGeom prst="roundRect">
             <a:avLst>
-              <a:gd name="adj" fmla="val 8000"/>
+              <a:gd name="adj" fmla="val 10000"/>
             </a:avLst>
           </a:prstGeom>
           <a:solidFill>
@@ -8138,8 +8417,8 @@
         </p:nvSpPr>
         <p:spPr>
           <a:xfrm>
-            <a:off x="8046720" y="2194560"/>
-            <a:ext cx="3200400" cy="914400"/>
+            <a:off x="7223760" y="1920240"/>
+            <a:ext cx="4114800" cy="548640"/>
           </a:xfrm>
           <a:prstGeom prst="rect">
             <a:avLst/>
@@ -8147,7 +8426,7 @@
           <a:noFill/>
         </p:spPr>
         <p:txBody>
-          <a:bodyPr wrap="square" lIns="0" rIns="0" tIns="0" bIns="0" anchor="t">
+          <a:bodyPr wrap="square" lIns="0" rIns="0" tIns="0" bIns="0" anchor="ctr">
             <a:spAutoFit/>
           </a:bodyPr>
           <a:lstStyle/>
@@ -8173,8 +8452,8 @@
         </p:nvSpPr>
         <p:spPr>
           <a:xfrm>
-            <a:off x="8046720" y="2788920"/>
-            <a:ext cx="3200400" cy="365760"/>
+            <a:off x="7223760" y="2560320"/>
+            <a:ext cx="4114800" cy="365760"/>
           </a:xfrm>
           <a:prstGeom prst="rect">
             <a:avLst/>
@@ -8208,12 +8487,12 @@
         </p:nvSpPr>
         <p:spPr>
           <a:xfrm>
-            <a:off x="7772400" y="4069080"/>
-            <a:ext cx="3749039" cy="1783080"/>
+            <a:off x="6949440" y="3246120"/>
+            <a:ext cx="4572000" cy="1280160"/>
           </a:xfrm>
           <a:prstGeom prst="roundRect">
             <a:avLst>
-              <a:gd name="adj" fmla="val 8000"/>
+              <a:gd name="adj" fmla="val 10000"/>
             </a:avLst>
           </a:prstGeom>
           <a:solidFill>
@@ -8254,8 +8533,8 @@
         </p:nvSpPr>
         <p:spPr>
           <a:xfrm>
-            <a:off x="8046720" y="4251960"/>
-            <a:ext cx="3200400" cy="914400"/>
+            <a:off x="7223760" y="3429000"/>
+            <a:ext cx="4114800" cy="548640"/>
           </a:xfrm>
           <a:prstGeom prst="rect">
             <a:avLst/>
@@ -8263,7 +8542,7 @@
           <a:noFill/>
         </p:spPr>
         <p:txBody>
-          <a:bodyPr wrap="square" lIns="0" rIns="0" tIns="0" bIns="0" anchor="t">
+          <a:bodyPr wrap="square" lIns="0" rIns="0" tIns="0" bIns="0" anchor="ctr">
             <a:spAutoFit/>
           </a:bodyPr>
           <a:lstStyle/>
@@ -8276,7 +8555,7 @@
                 </a:solidFill>
                 <a:latin typeface="Trebuchet MS"/>
               </a:rPr>
-              <a:t>13 stores are out of stock</a:t>
+              <a:t>13 stores out of stock</a:t>
             </a:r>
           </a:p>
         </p:txBody>
@@ -8289,8 +8568,8 @@
         </p:nvSpPr>
         <p:spPr>
           <a:xfrm>
-            <a:off x="8046720" y="5257800"/>
-            <a:ext cx="3200400" cy="365760"/>
+            <a:off x="7223760" y="4069080"/>
+            <a:ext cx="4114800" cy="365760"/>
           </a:xfrm>
           <a:prstGeom prst="rect">
             <a:avLst/>
@@ -8312,6 +8591,71 @@
                 <a:latin typeface="Calibri"/>
               </a:rPr>
               <a:t>about $5K a month left on the table</a:t>
+            </a:r>
+          </a:p>
+        </p:txBody>
+      </p:sp>
+      <p:sp>
+        <p:nvSpPr>
+          <p:cNvPr id="17" name="Key points"/>
+          <p:cNvSpPr txBox="1"/>
+          <p:nvPr/>
+        </p:nvSpPr>
+        <p:spPr>
+          <a:xfrm>
+            <a:off x="6949440" y="4754880"/>
+            <a:ext cx="4572000" cy="1371600"/>
+          </a:xfrm>
+          <a:prstGeom prst="rect">
+            <a:avLst/>
+          </a:prstGeom>
+          <a:noFill/>
+        </p:spPr>
+        <p:txBody>
+          <a:bodyPr wrap="square" lIns="0" rIns="0" tIns="0" bIns="0">
+            <a:spAutoFit/>
+          </a:bodyPr>
+          <a:lstStyle/>
+          <a:p>
+            <a:pPr marL="285750" indent="-285750">
+              <a:spcAft>
+                <a:spcPts val="1000"/>
+              </a:spcAft>
+              <a:buClr>
+                <a:srgbClr val="2A78D6"/>
+              </a:buClr>
+              <a:buFont typeface="Arial"/>
+              <a:buChar char="•"/>
+            </a:pPr>
+            <a:r>
+              <a:rPr sz="1800">
+                <a:solidFill>
+                  <a:srgbClr val="1F1A17"/>
+                </a:solidFill>
+                <a:latin typeface="Calibri"/>
+              </a:rPr>
+              <a:t>Launched Aug 17 and already a top-5 profit toy</a:t>
+            </a:r>
+          </a:p>
+          <a:p>
+            <a:pPr marL="285750" indent="-285750">
+              <a:spcAft>
+                <a:spcPts val="1000"/>
+              </a:spcAft>
+              <a:buClr>
+                <a:srgbClr val="2A78D6"/>
+              </a:buClr>
+              <a:buFont typeface="Arial"/>
+              <a:buChar char="•"/>
+            </a:pPr>
+            <a:r>
+              <a:rPr sz="1800">
+                <a:solidFill>
+                  <a:srgbClr val="1F1A17"/>
+                </a:solidFill>
+                <a:latin typeface="Calibri"/>
+              </a:rPr>
+              <a:t>New toys often cool off, so the window to act is short</a:t>
             </a:r>
           </a:p>
         </p:txBody>
@@ -8628,12 +8972,12 @@
         </p:nvSpPr>
         <p:spPr>
           <a:xfrm>
-            <a:off x="640080" y="2103120"/>
-            <a:ext cx="3383280" cy="3383280"/>
+            <a:off x="640080" y="1783080"/>
+            <a:ext cx="3383280" cy="4160520"/>
           </a:xfrm>
           <a:prstGeom prst="roundRect">
             <a:avLst>
-              <a:gd name="adj" fmla="val 7000"/>
+              <a:gd name="adj" fmla="val 6000"/>
             </a:avLst>
           </a:prstGeom>
           <a:solidFill>
@@ -8674,8 +9018,8 @@
         </p:nvSpPr>
         <p:spPr>
           <a:xfrm>
-            <a:off x="1005840" y="2423160"/>
-            <a:ext cx="914400" cy="914400"/>
+            <a:off x="1005840" y="2103120"/>
+            <a:ext cx="822960" cy="822960"/>
           </a:xfrm>
           <a:prstGeom prst="ellipse">
             <a:avLst/>
@@ -8708,7 +9052,7 @@
           <a:p>
             <a:pPr algn="ctr"/>
             <a:r>
-              <a:rPr sz="3600" b="1">
+              <a:rPr sz="3200" b="1">
                 <a:solidFill>
                   <a:srgbClr val="FFFFFF"/>
                 </a:solidFill>
@@ -8727,8 +9071,8 @@
         </p:nvSpPr>
         <p:spPr>
           <a:xfrm>
-            <a:off x="1005840" y="3611880"/>
-            <a:ext cx="2651760" cy="1645920"/>
+            <a:off x="1005840" y="3154680"/>
+            <a:ext cx="2697480" cy="1097280"/>
           </a:xfrm>
           <a:prstGeom prst="rect">
             <a:avLst/>
@@ -8743,7 +9087,7 @@
           <a:p>
             <a:pPr algn="l"/>
             <a:r>
-              <a:rPr sz="3000" b="1">
+              <a:rPr sz="2600" b="1">
                 <a:solidFill>
                   <a:srgbClr val="1F1A17"/>
                 </a:solidFill>
@@ -8756,18 +9100,83 @@
       </p:sp>
       <p:sp>
         <p:nvSpPr>
-          <p:cNvPr id="12" name="Card 2"/>
+          <p:cNvPr id="12" name="Step 1 details"/>
+          <p:cNvSpPr txBox="1"/>
+          <p:nvPr/>
+        </p:nvSpPr>
+        <p:spPr>
+          <a:xfrm>
+            <a:off x="1005840" y="4389120"/>
+            <a:ext cx="2697480" cy="1463040"/>
+          </a:xfrm>
+          <a:prstGeom prst="rect">
+            <a:avLst/>
+          </a:prstGeom>
+          <a:noFill/>
+        </p:spPr>
+        <p:txBody>
+          <a:bodyPr wrap="square" lIns="0" rIns="0" tIns="0" bIns="0">
+            <a:spAutoFit/>
+          </a:bodyPr>
+          <a:lstStyle/>
+          <a:p>
+            <a:pPr marL="285750" indent="-285750">
+              <a:spcAft>
+                <a:spcPts val="800"/>
+              </a:spcAft>
+              <a:buClr>
+                <a:srgbClr val="2A78D6"/>
+              </a:buClr>
+              <a:buFont typeface="Arial"/>
+              <a:buChar char="•"/>
+            </a:pPr>
+            <a:r>
+              <a:rPr sz="1600">
+                <a:solidFill>
+                  <a:srgbClr val="1F1A17"/>
+                </a:solidFill>
+                <a:latin typeface="Calibri"/>
+              </a:rPr>
+              <a:t>Refill the 13 empty stores</a:t>
+            </a:r>
+          </a:p>
+          <a:p>
+            <a:pPr marL="285750" indent="-285750">
+              <a:spcAft>
+                <a:spcPts val="800"/>
+              </a:spcAft>
+              <a:buClr>
+                <a:srgbClr val="2A78D6"/>
+              </a:buClr>
+              <a:buFont typeface="Arial"/>
+              <a:buChar char="•"/>
+            </a:pPr>
+            <a:r>
+              <a:rPr sz="1600">
+                <a:solidFill>
+                  <a:srgbClr val="1F1A17"/>
+                </a:solidFill>
+                <a:latin typeface="Calibri"/>
+              </a:rPr>
+              <a:t>Check weekly; worth about $5K a month</a:t>
+            </a:r>
+          </a:p>
+        </p:txBody>
+      </p:sp>
+      <p:sp>
+        <p:nvSpPr>
+          <p:cNvPr id="13" name="Card 2"/>
           <p:cNvSpPr/>
           <p:nvPr/>
         </p:nvSpPr>
         <p:spPr>
           <a:xfrm>
-            <a:off x="4389120" y="2103120"/>
-            <a:ext cx="3383280" cy="3383280"/>
+            <a:off x="4389120" y="1783080"/>
+            <a:ext cx="3383280" cy="4160520"/>
           </a:xfrm>
           <a:prstGeom prst="roundRect">
             <a:avLst>
-              <a:gd name="adj" fmla="val 7000"/>
+              <a:gd name="adj" fmla="val 6000"/>
             </a:avLst>
           </a:prstGeom>
           <a:solidFill>
@@ -8802,14 +9211,14 @@
       </p:sp>
       <p:sp>
         <p:nvSpPr>
-          <p:cNvPr id="13" name="Number badge 2"/>
+          <p:cNvPr id="14" name="Number badge 2"/>
           <p:cNvSpPr/>
           <p:nvPr/>
         </p:nvSpPr>
         <p:spPr>
           <a:xfrm>
-            <a:off x="4754880" y="2423160"/>
-            <a:ext cx="914400" cy="914400"/>
+            <a:off x="4754880" y="2103120"/>
+            <a:ext cx="822960" cy="822960"/>
           </a:xfrm>
           <a:prstGeom prst="ellipse">
             <a:avLst/>
@@ -8842,7 +9251,7 @@
           <a:p>
             <a:pPr algn="ctr"/>
             <a:r>
-              <a:rPr sz="3600" b="1">
+              <a:rPr sz="3200" b="1">
                 <a:solidFill>
                   <a:srgbClr val="FFFFFF"/>
                 </a:solidFill>
@@ -8855,14 +9264,14 @@
       </p:sp>
       <p:sp>
         <p:nvSpPr>
-          <p:cNvPr id="14" name="Step 2"/>
+          <p:cNvPr id="15" name="Step 2"/>
           <p:cNvSpPr txBox="1"/>
           <p:nvPr/>
         </p:nvSpPr>
         <p:spPr>
           <a:xfrm>
-            <a:off x="4754880" y="3611880"/>
-            <a:ext cx="2651760" cy="1645920"/>
+            <a:off x="4754880" y="3154680"/>
+            <a:ext cx="2697480" cy="1097280"/>
           </a:xfrm>
           <a:prstGeom prst="rect">
             <a:avLst/>
@@ -8877,7 +9286,7 @@
           <a:p>
             <a:pPr algn="l"/>
             <a:r>
-              <a:rPr sz="3000" b="1">
+              <a:rPr sz="2600" b="1">
                 <a:solidFill>
                   <a:srgbClr val="1F1A17"/>
                 </a:solidFill>
@@ -8890,18 +9299,83 @@
       </p:sp>
       <p:sp>
         <p:nvSpPr>
-          <p:cNvPr id="15" name="Card 3"/>
+          <p:cNvPr id="16" name="Step 2 details"/>
+          <p:cNvSpPr txBox="1"/>
+          <p:nvPr/>
+        </p:nvSpPr>
+        <p:spPr>
+          <a:xfrm>
+            <a:off x="4754880" y="4389120"/>
+            <a:ext cx="2697480" cy="1463040"/>
+          </a:xfrm>
+          <a:prstGeom prst="rect">
+            <a:avLst/>
+          </a:prstGeom>
+          <a:noFill/>
+        </p:spPr>
+        <p:txBody>
+          <a:bodyPr wrap="square" lIns="0" rIns="0" tIns="0" bIns="0">
+            <a:spAutoFit/>
+          </a:bodyPr>
+          <a:lstStyle/>
+          <a:p>
+            <a:pPr marL="285750" indent="-285750">
+              <a:spcAft>
+                <a:spcPts val="800"/>
+              </a:spcAft>
+              <a:buClr>
+                <a:srgbClr val="2A78D6"/>
+              </a:buClr>
+              <a:buFont typeface="Arial"/>
+              <a:buChar char="•"/>
+            </a:pPr>
+            <a:r>
+              <a:rPr sz="1600">
+                <a:solidFill>
+                  <a:srgbClr val="1F1A17"/>
+                </a:solidFill>
+                <a:latin typeface="Calibri"/>
+              </a:rPr>
+              <a:t>10 test stores vs 10 similar ones</a:t>
+            </a:r>
+          </a:p>
+          <a:p>
+            <a:pPr marL="285750" indent="-285750">
+              <a:spcAft>
+                <a:spcPts val="800"/>
+              </a:spcAft>
+              <a:buClr>
+                <a:srgbClr val="2A78D6"/>
+              </a:buClr>
+              <a:buFont typeface="Arial"/>
+              <a:buChar char="•"/>
+            </a:pPr>
+            <a:r>
+              <a:rPr sz="1600">
+                <a:solidFill>
+                  <a:srgbClr val="1F1A17"/>
+                </a:solidFill>
+                <a:latin typeface="Calibri"/>
+              </a:rPr>
+              <a:t>Up to about $11K a month if it works</a:t>
+            </a:r>
+          </a:p>
+        </p:txBody>
+      </p:sp>
+      <p:sp>
+        <p:nvSpPr>
+          <p:cNvPr id="17" name="Card 3"/>
           <p:cNvSpPr/>
           <p:nvPr/>
         </p:nvSpPr>
         <p:spPr>
           <a:xfrm>
-            <a:off x="8138159" y="2103120"/>
-            <a:ext cx="3383280" cy="3383280"/>
+            <a:off x="8138159" y="1783080"/>
+            <a:ext cx="3383280" cy="4160520"/>
           </a:xfrm>
           <a:prstGeom prst="roundRect">
             <a:avLst>
-              <a:gd name="adj" fmla="val 7000"/>
+              <a:gd name="adj" fmla="val 6000"/>
             </a:avLst>
           </a:prstGeom>
           <a:solidFill>
@@ -8936,14 +9410,14 @@
       </p:sp>
       <p:sp>
         <p:nvSpPr>
-          <p:cNvPr id="16" name="Number badge 3"/>
+          <p:cNvPr id="18" name="Number badge 3"/>
           <p:cNvSpPr/>
           <p:nvPr/>
         </p:nvSpPr>
         <p:spPr>
           <a:xfrm>
-            <a:off x="8503919" y="2423160"/>
-            <a:ext cx="914400" cy="914400"/>
+            <a:off x="8503919" y="2103120"/>
+            <a:ext cx="822960" cy="822960"/>
           </a:xfrm>
           <a:prstGeom prst="ellipse">
             <a:avLst/>
@@ -8976,7 +9450,7 @@
           <a:p>
             <a:pPr algn="ctr"/>
             <a:r>
-              <a:rPr sz="3600" b="1">
+              <a:rPr sz="3200" b="1">
                 <a:solidFill>
                   <a:srgbClr val="FFFFFF"/>
                 </a:solidFill>
@@ -8989,14 +9463,14 @@
       </p:sp>
       <p:sp>
         <p:nvSpPr>
-          <p:cNvPr id="17" name="Step 3"/>
+          <p:cNvPr id="19" name="Step 3"/>
           <p:cNvSpPr txBox="1"/>
           <p:nvPr/>
         </p:nvSpPr>
         <p:spPr>
           <a:xfrm>
-            <a:off x="8503919" y="3611880"/>
-            <a:ext cx="2651760" cy="1645920"/>
+            <a:off x="8503919" y="3154680"/>
+            <a:ext cx="2697480" cy="1097280"/>
           </a:xfrm>
           <a:prstGeom prst="rect">
             <a:avLst/>
@@ -9011,13 +9485,78 @@
           <a:p>
             <a:pPr algn="l"/>
             <a:r>
-              <a:rPr sz="3000" b="1">
+              <a:rPr sz="2600" b="1">
                 <a:solidFill>
                   <a:srgbClr val="1F1A17"/>
                 </a:solidFill>
                 <a:latin typeface="Trebuchet MS"/>
               </a:rPr>
               <a:t>Review in 8 weeks</a:t>
+            </a:r>
+          </a:p>
+        </p:txBody>
+      </p:sp>
+      <p:sp>
+        <p:nvSpPr>
+          <p:cNvPr id="20" name="Step 3 details"/>
+          <p:cNvSpPr txBox="1"/>
+          <p:nvPr/>
+        </p:nvSpPr>
+        <p:spPr>
+          <a:xfrm>
+            <a:off x="8503919" y="4389120"/>
+            <a:ext cx="2697480" cy="1463040"/>
+          </a:xfrm>
+          <a:prstGeom prst="rect">
+            <a:avLst/>
+          </a:prstGeom>
+          <a:noFill/>
+        </p:spPr>
+        <p:txBody>
+          <a:bodyPr wrap="square" lIns="0" rIns="0" tIns="0" bIns="0">
+            <a:spAutoFit/>
+          </a:bodyPr>
+          <a:lstStyle/>
+          <a:p>
+            <a:pPr marL="285750" indent="-285750">
+              <a:spcAft>
+                <a:spcPts val="800"/>
+              </a:spcAft>
+              <a:buClr>
+                <a:srgbClr val="2A78D6"/>
+              </a:buClr>
+              <a:buFont typeface="Arial"/>
+              <a:buChar char="•"/>
+            </a:pPr>
+            <a:r>
+              <a:rPr sz="1600">
+                <a:solidFill>
+                  <a:srgbClr val="1F1A17"/>
+                </a:solidFill>
+                <a:latin typeface="Calibri"/>
+              </a:rPr>
+              <a:t>Scale what works, stop what doesn't</a:t>
+            </a:r>
+          </a:p>
+          <a:p>
+            <a:pPr marL="285750" indent="-285750">
+              <a:spcAft>
+                <a:spcPts val="800"/>
+              </a:spcAft>
+              <a:buClr>
+                <a:srgbClr val="2A78D6"/>
+              </a:buClr>
+              <a:buFont typeface="Arial"/>
+              <a:buChar char="•"/>
+            </a:pPr>
+            <a:r>
+              <a:rPr sz="1600">
+                <a:solidFill>
+                  <a:srgbClr val="1F1A17"/>
+                </a:solidFill>
+                <a:latin typeface="Calibri"/>
+              </a:rPr>
+              <a:t>Pick the next higher-margin toy</a:t>
             </a:r>
           </a:p>
         </p:txBody>

</xml_diff>

<commit_message>
Deck: semantic toy colours (Colorbuds pink, Playfoam mint), colourful cover, site palette
Co-Authored-By: Claude Sonnet 5.5 <noreply@anthropic.com>
Claude-Session: https://claude.ai/code/session_01J6v5JYXB5XucuZ66TGAjVJ
</commit_message>
<xml_diff>
--- a/site/deck/Colorbuds_to_Playfoam.pptx
+++ b/site/deck/Colorbuds_to_Playfoam.pptx
@@ -138,7 +138,7 @@
           <c:spPr>
             <a:ln w="44450">
               <a:solidFill>
-                <a:srgbClr val="051C2C"/>
+                <a:srgbClr val="E8457B"/>
               </a:solidFill>
             </a:ln>
           </c:spPr>
@@ -152,7 +152,7 @@
               <c:size val="11"/>
               <c:spPr>
                 <a:solidFill>
-                  <a:srgbClr val="2251FF"/>
+                  <a:srgbClr val="E8457B"/>
                 </a:solidFill>
                 <a:ln>
                   <a:solidFill>
@@ -169,7 +169,7 @@
               <c:size val="11"/>
               <c:spPr>
                 <a:solidFill>
-                  <a:srgbClr val="2251FF"/>
+                  <a:srgbClr val="E8457B"/>
                 </a:solidFill>
                 <a:ln>
                   <a:solidFill>
@@ -190,7 +190,7 @@
                     <a:r>
                       <a:rPr sz="2200" b="1">
                         <a:solidFill>
-                          <a:srgbClr val="2251FF"/>
+                          <a:srgbClr val="D6336C"/>
                         </a:solidFill>
                         <a:latin typeface="Cambria"/>
                       </a:rPr>
@@ -228,7 +228,7 @@
                     <a:r>
                       <a:rPr sz="2200" b="1">
                         <a:solidFill>
-                          <a:srgbClr val="2251FF"/>
+                          <a:srgbClr val="D6336C"/>
                         </a:solidFill>
                         <a:latin typeface="Cambria"/>
                       </a:rPr>
@@ -516,14 +516,14 @@
           </c:tx>
           <c:spPr>
             <a:solidFill>
-              <a:srgbClr val="2251FF"/>
+              <a:srgbClr val="1BAF7A"/>
             </a:solidFill>
           </c:spPr>
           <c:dPt>
             <c:idx val="0"/>
             <c:spPr>
               <a:solidFill>
-                <a:srgbClr val="A9BCFF"/>
+                <a:srgbClr val="A5E3CC"/>
               </a:solidFill>
             </c:spPr>
           </c:dPt>
@@ -4433,7 +4433,7 @@
             <a:avLst/>
           </a:prstGeom>
           <a:solidFill>
-            <a:srgbClr val="2251FF"/>
+            <a:srgbClr val="E8457B"/>
           </a:solidFill>
           <a:ln>
             <a:noFill/>
@@ -4477,7 +4477,7 @@
             <a:avLst/>
           </a:prstGeom>
           <a:solidFill>
-            <a:srgbClr val="00A9F4"/>
+            <a:srgbClr val="F2B400"/>
           </a:solidFill>
           <a:ln>
             <a:noFill/>
@@ -4521,7 +4521,7 @@
             <a:avLst/>
           </a:prstGeom>
           <a:solidFill>
-            <a:srgbClr val="FFFFFF"/>
+            <a:srgbClr val="1BAF7A"/>
           </a:solidFill>
           <a:ln>
             <a:noFill/>
@@ -4587,14 +4587,454 @@
       </p:sp>
       <p:sp>
         <p:nvSpPr>
-          <p:cNvPr id="6" name="Title"/>
+          <p:cNvPr id="6" name="Block r0c0"/>
+          <p:cNvSpPr/>
+          <p:nvPr/>
+        </p:nvSpPr>
+        <p:spPr>
+          <a:xfrm>
+            <a:off x="7818120" y="5623560"/>
+            <a:ext cx="822960" cy="822960"/>
+          </a:xfrm>
+          <a:prstGeom prst="rect">
+            <a:avLst/>
+          </a:prstGeom>
+          <a:solidFill>
+            <a:srgbClr val="2A78D6"/>
+          </a:solidFill>
+          <a:ln>
+            <a:noFill/>
+          </a:ln>
+          <a:effectLst/>
+        </p:spPr>
+        <p:style>
+          <a:lnRef idx="1">
+            <a:schemeClr val="accent1"/>
+          </a:lnRef>
+          <a:fillRef idx="3">
+            <a:schemeClr val="accent1"/>
+          </a:fillRef>
+          <a:effectRef idx="0">
+            <a:schemeClr val="accent1"/>
+          </a:effectRef>
+          <a:fontRef idx="minor">
+            <a:schemeClr val="lt1"/>
+          </a:fontRef>
+        </p:style>
+        <p:txBody>
+          <a:bodyPr rtlCol="0" anchor="ctr"/>
+          <a:lstStyle/>
+          <a:p>
+            <a:pPr algn="ctr"/>
+          </a:p>
+        </p:txBody>
+      </p:sp>
+      <p:sp>
+        <p:nvSpPr>
+          <p:cNvPr id="7" name="Block r0c1"/>
+          <p:cNvSpPr/>
+          <p:nvPr/>
+        </p:nvSpPr>
+        <p:spPr>
+          <a:xfrm>
+            <a:off x="8732520" y="5623560"/>
+            <a:ext cx="822960" cy="822960"/>
+          </a:xfrm>
+          <a:prstGeom prst="rect">
+            <a:avLst/>
+          </a:prstGeom>
+          <a:solidFill>
+            <a:srgbClr val="EB6834"/>
+          </a:solidFill>
+          <a:ln>
+            <a:noFill/>
+          </a:ln>
+          <a:effectLst/>
+        </p:spPr>
+        <p:style>
+          <a:lnRef idx="1">
+            <a:schemeClr val="accent1"/>
+          </a:lnRef>
+          <a:fillRef idx="3">
+            <a:schemeClr val="accent1"/>
+          </a:fillRef>
+          <a:effectRef idx="0">
+            <a:schemeClr val="accent1"/>
+          </a:effectRef>
+          <a:fontRef idx="minor">
+            <a:schemeClr val="lt1"/>
+          </a:fontRef>
+        </p:style>
+        <p:txBody>
+          <a:bodyPr rtlCol="0" anchor="ctr"/>
+          <a:lstStyle/>
+          <a:p>
+            <a:pPr algn="ctr"/>
+          </a:p>
+        </p:txBody>
+      </p:sp>
+      <p:sp>
+        <p:nvSpPr>
+          <p:cNvPr id="8" name="Block r0c2"/>
+          <p:cNvSpPr/>
+          <p:nvPr/>
+        </p:nvSpPr>
+        <p:spPr>
+          <a:xfrm>
+            <a:off x="9646920" y="5623560"/>
+            <a:ext cx="822960" cy="822960"/>
+          </a:xfrm>
+          <a:prstGeom prst="rect">
+            <a:avLst/>
+          </a:prstGeom>
+          <a:solidFill>
+            <a:srgbClr val="E8457B"/>
+          </a:solidFill>
+          <a:ln>
+            <a:noFill/>
+          </a:ln>
+          <a:effectLst/>
+        </p:spPr>
+        <p:style>
+          <a:lnRef idx="1">
+            <a:schemeClr val="accent1"/>
+          </a:lnRef>
+          <a:fillRef idx="3">
+            <a:schemeClr val="accent1"/>
+          </a:fillRef>
+          <a:effectRef idx="0">
+            <a:schemeClr val="accent1"/>
+          </a:effectRef>
+          <a:fontRef idx="minor">
+            <a:schemeClr val="lt1"/>
+          </a:fontRef>
+        </p:style>
+        <p:txBody>
+          <a:bodyPr rtlCol="0" anchor="ctr"/>
+          <a:lstStyle/>
+          <a:p>
+            <a:pPr algn="ctr"/>
+          </a:p>
+        </p:txBody>
+      </p:sp>
+      <p:sp>
+        <p:nvSpPr>
+          <p:cNvPr id="9" name="Block r0c3"/>
+          <p:cNvSpPr/>
+          <p:nvPr/>
+        </p:nvSpPr>
+        <p:spPr>
+          <a:xfrm>
+            <a:off x="10561320" y="5623560"/>
+            <a:ext cx="822960" cy="822960"/>
+          </a:xfrm>
+          <a:prstGeom prst="rect">
+            <a:avLst/>
+          </a:prstGeom>
+          <a:solidFill>
+            <a:srgbClr val="F2B400"/>
+          </a:solidFill>
+          <a:ln>
+            <a:noFill/>
+          </a:ln>
+          <a:effectLst/>
+        </p:spPr>
+        <p:style>
+          <a:lnRef idx="1">
+            <a:schemeClr val="accent1"/>
+          </a:lnRef>
+          <a:fillRef idx="3">
+            <a:schemeClr val="accent1"/>
+          </a:fillRef>
+          <a:effectRef idx="0">
+            <a:schemeClr val="accent1"/>
+          </a:effectRef>
+          <a:fontRef idx="minor">
+            <a:schemeClr val="lt1"/>
+          </a:fontRef>
+        </p:style>
+        <p:txBody>
+          <a:bodyPr rtlCol="0" anchor="ctr"/>
+          <a:lstStyle/>
+          <a:p>
+            <a:pPr algn="ctr"/>
+          </a:p>
+        </p:txBody>
+      </p:sp>
+      <p:sp>
+        <p:nvSpPr>
+          <p:cNvPr id="10" name="Block r1c0"/>
+          <p:cNvSpPr/>
+          <p:nvPr/>
+        </p:nvSpPr>
+        <p:spPr>
+          <a:xfrm>
+            <a:off x="8275320" y="4709160"/>
+            <a:ext cx="822960" cy="822960"/>
+          </a:xfrm>
+          <a:prstGeom prst="rect">
+            <a:avLst/>
+          </a:prstGeom>
+          <a:solidFill>
+            <a:srgbClr val="1BAF7A"/>
+          </a:solidFill>
+          <a:ln>
+            <a:noFill/>
+          </a:ln>
+          <a:effectLst/>
+        </p:spPr>
+        <p:style>
+          <a:lnRef idx="1">
+            <a:schemeClr val="accent1"/>
+          </a:lnRef>
+          <a:fillRef idx="3">
+            <a:schemeClr val="accent1"/>
+          </a:fillRef>
+          <a:effectRef idx="0">
+            <a:schemeClr val="accent1"/>
+          </a:effectRef>
+          <a:fontRef idx="minor">
+            <a:schemeClr val="lt1"/>
+          </a:fontRef>
+        </p:style>
+        <p:txBody>
+          <a:bodyPr rtlCol="0" anchor="ctr"/>
+          <a:lstStyle/>
+          <a:p>
+            <a:pPr algn="ctr"/>
+          </a:p>
+        </p:txBody>
+      </p:sp>
+      <p:sp>
+        <p:nvSpPr>
+          <p:cNvPr id="11" name="Block r1c1"/>
+          <p:cNvSpPr/>
+          <p:nvPr/>
+        </p:nvSpPr>
+        <p:spPr>
+          <a:xfrm>
+            <a:off x="9189720" y="4709160"/>
+            <a:ext cx="822960" cy="822960"/>
+          </a:xfrm>
+          <a:prstGeom prst="rect">
+            <a:avLst/>
+          </a:prstGeom>
+          <a:solidFill>
+            <a:srgbClr val="2A78D6"/>
+          </a:solidFill>
+          <a:ln>
+            <a:noFill/>
+          </a:ln>
+          <a:effectLst/>
+        </p:spPr>
+        <p:style>
+          <a:lnRef idx="1">
+            <a:schemeClr val="accent1"/>
+          </a:lnRef>
+          <a:fillRef idx="3">
+            <a:schemeClr val="accent1"/>
+          </a:fillRef>
+          <a:effectRef idx="0">
+            <a:schemeClr val="accent1"/>
+          </a:effectRef>
+          <a:fontRef idx="minor">
+            <a:schemeClr val="lt1"/>
+          </a:fontRef>
+        </p:style>
+        <p:txBody>
+          <a:bodyPr rtlCol="0" anchor="ctr"/>
+          <a:lstStyle/>
+          <a:p>
+            <a:pPr algn="ctr"/>
+          </a:p>
+        </p:txBody>
+      </p:sp>
+      <p:sp>
+        <p:nvSpPr>
+          <p:cNvPr id="12" name="Block r1c2"/>
+          <p:cNvSpPr/>
+          <p:nvPr/>
+        </p:nvSpPr>
+        <p:spPr>
+          <a:xfrm>
+            <a:off x="10104120" y="4709160"/>
+            <a:ext cx="822960" cy="822960"/>
+          </a:xfrm>
+          <a:prstGeom prst="rect">
+            <a:avLst/>
+          </a:prstGeom>
+          <a:solidFill>
+            <a:srgbClr val="EB6834"/>
+          </a:solidFill>
+          <a:ln>
+            <a:noFill/>
+          </a:ln>
+          <a:effectLst/>
+        </p:spPr>
+        <p:style>
+          <a:lnRef idx="1">
+            <a:schemeClr val="accent1"/>
+          </a:lnRef>
+          <a:fillRef idx="3">
+            <a:schemeClr val="accent1"/>
+          </a:fillRef>
+          <a:effectRef idx="0">
+            <a:schemeClr val="accent1"/>
+          </a:effectRef>
+          <a:fontRef idx="minor">
+            <a:schemeClr val="lt1"/>
+          </a:fontRef>
+        </p:style>
+        <p:txBody>
+          <a:bodyPr rtlCol="0" anchor="ctr"/>
+          <a:lstStyle/>
+          <a:p>
+            <a:pPr algn="ctr"/>
+          </a:p>
+        </p:txBody>
+      </p:sp>
+      <p:sp>
+        <p:nvSpPr>
+          <p:cNvPr id="13" name="Block r2c0"/>
+          <p:cNvSpPr/>
+          <p:nvPr/>
+        </p:nvSpPr>
+        <p:spPr>
+          <a:xfrm>
+            <a:off x="8732520" y="3794760"/>
+            <a:ext cx="822960" cy="822960"/>
+          </a:xfrm>
+          <a:prstGeom prst="rect">
+            <a:avLst/>
+          </a:prstGeom>
+          <a:solidFill>
+            <a:srgbClr val="E8457B"/>
+          </a:solidFill>
+          <a:ln>
+            <a:noFill/>
+          </a:ln>
+          <a:effectLst/>
+        </p:spPr>
+        <p:style>
+          <a:lnRef idx="1">
+            <a:schemeClr val="accent1"/>
+          </a:lnRef>
+          <a:fillRef idx="3">
+            <a:schemeClr val="accent1"/>
+          </a:fillRef>
+          <a:effectRef idx="0">
+            <a:schemeClr val="accent1"/>
+          </a:effectRef>
+          <a:fontRef idx="minor">
+            <a:schemeClr val="lt1"/>
+          </a:fontRef>
+        </p:style>
+        <p:txBody>
+          <a:bodyPr rtlCol="0" anchor="ctr"/>
+          <a:lstStyle/>
+          <a:p>
+            <a:pPr algn="ctr"/>
+          </a:p>
+        </p:txBody>
+      </p:sp>
+      <p:sp>
+        <p:nvSpPr>
+          <p:cNvPr id="14" name="Block r2c1"/>
+          <p:cNvSpPr/>
+          <p:nvPr/>
+        </p:nvSpPr>
+        <p:spPr>
+          <a:xfrm>
+            <a:off x="9646920" y="3794760"/>
+            <a:ext cx="822960" cy="822960"/>
+          </a:xfrm>
+          <a:prstGeom prst="rect">
+            <a:avLst/>
+          </a:prstGeom>
+          <a:solidFill>
+            <a:srgbClr val="1BAF7A"/>
+          </a:solidFill>
+          <a:ln>
+            <a:noFill/>
+          </a:ln>
+          <a:effectLst/>
+        </p:spPr>
+        <p:style>
+          <a:lnRef idx="1">
+            <a:schemeClr val="accent1"/>
+          </a:lnRef>
+          <a:fillRef idx="3">
+            <a:schemeClr val="accent1"/>
+          </a:fillRef>
+          <a:effectRef idx="0">
+            <a:schemeClr val="accent1"/>
+          </a:effectRef>
+          <a:fontRef idx="minor">
+            <a:schemeClr val="lt1"/>
+          </a:fontRef>
+        </p:style>
+        <p:txBody>
+          <a:bodyPr rtlCol="0" anchor="ctr"/>
+          <a:lstStyle/>
+          <a:p>
+            <a:pPr algn="ctr"/>
+          </a:p>
+        </p:txBody>
+      </p:sp>
+      <p:sp>
+        <p:nvSpPr>
+          <p:cNvPr id="15" name="Block r3c0"/>
+          <p:cNvSpPr/>
+          <p:nvPr/>
+        </p:nvSpPr>
+        <p:spPr>
+          <a:xfrm>
+            <a:off x="9189720" y="2880360"/>
+            <a:ext cx="822960" cy="822960"/>
+          </a:xfrm>
+          <a:prstGeom prst="rect">
+            <a:avLst/>
+          </a:prstGeom>
+          <a:solidFill>
+            <a:srgbClr val="F2B400"/>
+          </a:solidFill>
+          <a:ln>
+            <a:noFill/>
+          </a:ln>
+          <a:effectLst/>
+        </p:spPr>
+        <p:style>
+          <a:lnRef idx="1">
+            <a:schemeClr val="accent1"/>
+          </a:lnRef>
+          <a:fillRef idx="3">
+            <a:schemeClr val="accent1"/>
+          </a:fillRef>
+          <a:effectRef idx="0">
+            <a:schemeClr val="accent1"/>
+          </a:effectRef>
+          <a:fontRef idx="minor">
+            <a:schemeClr val="lt1"/>
+          </a:fontRef>
+        </p:style>
+        <p:txBody>
+          <a:bodyPr rtlCol="0" anchor="ctr"/>
+          <a:lstStyle/>
+          <a:p>
+            <a:pPr algn="ctr"/>
+          </a:p>
+        </p:txBody>
+      </p:sp>
+      <p:sp>
+        <p:nvSpPr>
+          <p:cNvPr id="16" name="Title"/>
           <p:cNvSpPr txBox="1"/>
           <p:nvPr/>
         </p:nvSpPr>
         <p:spPr>
           <a:xfrm>
-            <a:off x="548640" y="2331720"/>
-            <a:ext cx="9601200" cy="1737360"/>
+            <a:off x="548640" y="1737360"/>
+            <a:ext cx="6949440" cy="2331720"/>
           </a:xfrm>
           <a:prstGeom prst="rect">
             <a:avLst/>
@@ -4615,14 +5055,24 @@
                 </a:solidFill>
                 <a:latin typeface="Cambria"/>
               </a:rPr>
-              <a:t>Colorbuds is fading: what to do next</a:t>
-            </a:r>
-          </a:p>
-        </p:txBody>
-      </p:sp>
-      <p:sp>
-        <p:nvSpPr>
-          <p:cNvPr id="7" name="Subtitle"/>
+              <a:t>Colorbuds is fading:</a:t>
+            </a:r>
+            <a:br/>
+            <a:r>
+              <a:rPr sz="4400" b="1">
+                <a:solidFill>
+                  <a:srgbClr val="FFFFFF"/>
+                </a:solidFill>
+                <a:latin typeface="Cambria"/>
+              </a:rPr>
+              <a:t>what to do next</a:t>
+            </a:r>
+          </a:p>
+        </p:txBody>
+      </p:sp>
+      <p:sp>
+        <p:nvSpPr>
+          <p:cNvPr id="17" name="Subtitle"/>
           <p:cNvSpPr txBox="1"/>
           <p:nvPr/>
         </p:nvSpPr>
@@ -4891,7 +5341,7 @@
             <a:r>
               <a:rPr sz="5600" b="1">
                 <a:solidFill>
-                  <a:srgbClr val="2251FF"/>
+                  <a:srgbClr val="D6336C"/>
                 </a:solidFill>
                 <a:latin typeface="Cambria"/>
               </a:rPr>
@@ -5040,7 +5490,7 @@
             <a:r>
               <a:rPr sz="5600" b="1">
                 <a:solidFill>
-                  <a:srgbClr val="2251FF"/>
+                  <a:srgbClr val="0E8F63"/>
                 </a:solidFill>
                 <a:latin typeface="Cambria"/>
               </a:rPr>
@@ -5111,7 +5561,7 @@
                 <a:spcPts val="1000"/>
               </a:spcAft>
               <a:buClr>
-                <a:srgbClr val="2251FF"/>
+                <a:srgbClr val="2A78D6"/>
               </a:buClr>
               <a:buFont typeface="Arial"/>
               <a:buChar char="•"/>
@@ -5132,7 +5582,7 @@
                 <a:spcPts val="1000"/>
               </a:spcAft>
               <a:buClr>
-                <a:srgbClr val="2251FF"/>
+                <a:srgbClr val="2A78D6"/>
               </a:buClr>
               <a:buFont typeface="Arial"/>
               <a:buChar char="•"/>
@@ -5153,7 +5603,7 @@
                 <a:spcPts val="1000"/>
               </a:spcAft>
               <a:buClr>
-                <a:srgbClr val="2251FF"/>
+                <a:srgbClr val="2A78D6"/>
               </a:buClr>
               <a:buFont typeface="Arial"/>
               <a:buChar char="•"/>
@@ -5460,7 +5910,7 @@
                 <a:spcPts val="1400"/>
               </a:spcAft>
               <a:buClr>
-                <a:srgbClr val="2251FF"/>
+                <a:srgbClr val="2A78D6"/>
               </a:buClr>
               <a:buFont typeface="Arial"/>
               <a:buChar char="•"/>
@@ -5481,7 +5931,7 @@
                 <a:spcPts val="1400"/>
               </a:spcAft>
               <a:buClr>
-                <a:srgbClr val="2251FF"/>
+                <a:srgbClr val="2A78D6"/>
               </a:buClr>
               <a:buFont typeface="Arial"/>
               <a:buChar char="•"/>
@@ -5502,7 +5952,7 @@
                 <a:spcPts val="1400"/>
               </a:spcAft>
               <a:buClr>
-                <a:srgbClr val="2251FF"/>
+                <a:srgbClr val="2A78D6"/>
               </a:buClr>
               <a:buFont typeface="Arial"/>
               <a:buChar char="•"/>
@@ -5720,7 +6170,7 @@
             <a:r>
               <a:rPr sz="8800" b="1">
                 <a:solidFill>
-                  <a:srgbClr val="2251FF"/>
+                  <a:srgbClr val="D9531E"/>
                 </a:solidFill>
                 <a:latin typeface="Cambria"/>
               </a:rPr>
@@ -5779,7 +6229,7 @@
             <a:avLst/>
           </a:prstGeom>
           <a:solidFill>
-            <a:srgbClr val="051C2C"/>
+            <a:srgbClr val="EB6834"/>
           </a:solidFill>
           <a:ln>
             <a:noFill/>
@@ -5823,7 +6273,7 @@
             <a:avLst/>
           </a:prstGeom>
           <a:solidFill>
-            <a:srgbClr val="051C2C"/>
+            <a:srgbClr val="EB6834"/>
           </a:solidFill>
           <a:ln>
             <a:noFill/>
@@ -5867,7 +6317,7 @@
             <a:avLst/>
           </a:prstGeom>
           <a:solidFill>
-            <a:srgbClr val="051C2C"/>
+            <a:srgbClr val="EB6834"/>
           </a:solidFill>
           <a:ln>
             <a:noFill/>
@@ -5911,7 +6361,7 @@
             <a:avLst/>
           </a:prstGeom>
           <a:solidFill>
-            <a:srgbClr val="051C2C"/>
+            <a:srgbClr val="EB6834"/>
           </a:solidFill>
           <a:ln>
             <a:noFill/>
@@ -5955,7 +6405,7 @@
             <a:avLst/>
           </a:prstGeom>
           <a:solidFill>
-            <a:srgbClr val="051C2C"/>
+            <a:srgbClr val="EB6834"/>
           </a:solidFill>
           <a:ln>
             <a:noFill/>
@@ -5999,7 +6449,7 @@
             <a:avLst/>
           </a:prstGeom>
           <a:solidFill>
-            <a:srgbClr val="051C2C"/>
+            <a:srgbClr val="EB6834"/>
           </a:solidFill>
           <a:ln>
             <a:noFill/>
@@ -6043,7 +6493,7 @@
             <a:avLst/>
           </a:prstGeom>
           <a:solidFill>
-            <a:srgbClr val="051C2C"/>
+            <a:srgbClr val="EB6834"/>
           </a:solidFill>
           <a:ln>
             <a:noFill/>
@@ -6087,7 +6537,7 @@
             <a:avLst/>
           </a:prstGeom>
           <a:solidFill>
-            <a:srgbClr val="051C2C"/>
+            <a:srgbClr val="EB6834"/>
           </a:solidFill>
           <a:ln>
             <a:noFill/>
@@ -6131,7 +6581,7 @@
             <a:avLst/>
           </a:prstGeom>
           <a:solidFill>
-            <a:srgbClr val="051C2C"/>
+            <a:srgbClr val="EB6834"/>
           </a:solidFill>
           <a:ln>
             <a:noFill/>
@@ -6266,7 +6716,7 @@
                 <a:spcPts val="1600"/>
               </a:spcAft>
               <a:buClr>
-                <a:srgbClr val="2251FF"/>
+                <a:srgbClr val="2A78D6"/>
               </a:buClr>
               <a:buFont typeface="Arial"/>
               <a:buChar char="•"/>
@@ -6287,7 +6737,7 @@
                 <a:spcPts val="1600"/>
               </a:spcAft>
               <a:buClr>
-                <a:srgbClr val="2251FF"/>
+                <a:srgbClr val="2A78D6"/>
               </a:buClr>
               <a:buFont typeface="Arial"/>
               <a:buChar char="•"/>
@@ -6308,7 +6758,7 @@
                 <a:spcPts val="1600"/>
               </a:spcAft>
               <a:buClr>
-                <a:srgbClr val="2251FF"/>
+                <a:srgbClr val="2A78D6"/>
               </a:buClr>
               <a:buFont typeface="Arial"/>
               <a:buChar char="•"/>
@@ -6329,7 +6779,7 @@
                 <a:spcPts val="1600"/>
               </a:spcAft>
               <a:buClr>
-                <a:srgbClr val="2251FF"/>
+                <a:srgbClr val="2A78D6"/>
               </a:buClr>
               <a:buFont typeface="Arial"/>
               <a:buChar char="•"/>
@@ -6600,7 +7050,7 @@
             <a:r>
               <a:rPr sz="2600" b="1">
                 <a:solidFill>
-                  <a:srgbClr val="2251FF"/>
+                  <a:srgbClr val="0E8F63"/>
                 </a:solidFill>
                 <a:latin typeface="Cambria"/>
               </a:rPr>
@@ -6714,7 +7164,7 @@
             <a:r>
               <a:rPr sz="2600" b="1">
                 <a:solidFill>
-                  <a:srgbClr val="2251FF"/>
+                  <a:srgbClr val="D9531E"/>
                 </a:solidFill>
                 <a:latin typeface="Cambria"/>
               </a:rPr>
@@ -6785,7 +7235,7 @@
                 <a:spcPts val="1000"/>
               </a:spcAft>
               <a:buClr>
-                <a:srgbClr val="2251FF"/>
+                <a:srgbClr val="2A78D6"/>
               </a:buClr>
               <a:buFont typeface="Arial"/>
               <a:buChar char="•"/>
@@ -6806,7 +7256,7 @@
                 <a:spcPts val="1000"/>
               </a:spcAft>
               <a:buClr>
-                <a:srgbClr val="2251FF"/>
+                <a:srgbClr val="2A78D6"/>
               </a:buClr>
               <a:buFont typeface="Arial"/>
               <a:buChar char="•"/>
@@ -7013,7 +7463,7 @@
             <a:avLst/>
           </a:prstGeom>
           <a:solidFill>
-            <a:srgbClr val="051C2C"/>
+            <a:srgbClr val="0E8F63"/>
           </a:solidFill>
           <a:ln>
             <a:noFill/>
@@ -7113,7 +7563,7 @@
                 <a:spcPts val="1000"/>
               </a:spcAft>
               <a:buClr>
-                <a:srgbClr val="2251FF"/>
+                <a:srgbClr val="2A78D6"/>
               </a:buClr>
               <a:buFont typeface="Arial"/>
               <a:buChar char="•"/>
@@ -7134,7 +7584,7 @@
                 <a:spcPts val="1000"/>
               </a:spcAft>
               <a:buClr>
-                <a:srgbClr val="2251FF"/>
+                <a:srgbClr val="2A78D6"/>
               </a:buClr>
               <a:buFont typeface="Arial"/>
               <a:buChar char="•"/>
@@ -7210,7 +7660,7 @@
             <a:avLst/>
           </a:prstGeom>
           <a:solidFill>
-            <a:srgbClr val="051C2C"/>
+            <a:srgbClr val="D6336C"/>
           </a:solidFill>
           <a:ln>
             <a:noFill/>
@@ -7310,7 +7760,7 @@
                 <a:spcPts val="1000"/>
               </a:spcAft>
               <a:buClr>
-                <a:srgbClr val="2251FF"/>
+                <a:srgbClr val="2A78D6"/>
               </a:buClr>
               <a:buFont typeface="Arial"/>
               <a:buChar char="•"/>
@@ -7331,7 +7781,7 @@
                 <a:spcPts val="1000"/>
               </a:spcAft>
               <a:buClr>
-                <a:srgbClr val="2251FF"/>
+                <a:srgbClr val="2A78D6"/>
               </a:buClr>
               <a:buFont typeface="Arial"/>
               <a:buChar char="•"/>
@@ -7407,7 +7857,7 @@
             <a:avLst/>
           </a:prstGeom>
           <a:solidFill>
-            <a:srgbClr val="051C2C"/>
+            <a:srgbClr val="2A78D6"/>
           </a:solidFill>
           <a:ln>
             <a:noFill/>
@@ -7507,7 +7957,7 @@
                 <a:spcPts val="1000"/>
               </a:spcAft>
               <a:buClr>
-                <a:srgbClr val="2251FF"/>
+                <a:srgbClr val="2A78D6"/>
               </a:buClr>
               <a:buFont typeface="Arial"/>
               <a:buChar char="•"/>
@@ -7528,7 +7978,7 @@
                 <a:spcPts val="1000"/>
               </a:spcAft>
               <a:buClr>
-                <a:srgbClr val="2251FF"/>
+                <a:srgbClr val="2A78D6"/>
               </a:buClr>
               <a:buFont typeface="Arial"/>
               <a:buChar char="•"/>

</xml_diff>

<commit_message>
Deck: clearer title that explains Colorbuds; bold only the key phrases in bullets
Co-Authored-By: Claude Sonnet 5.5 <noreply@anthropic.com>
Claude-Session: https://claude.ai/code/session_01J6v5JYXB5XucuZ66TGAjVJ
</commit_message>
<xml_diff>
--- a/site/deck/Colorbuds_to_Playfoam.pptx
+++ b/site/deck/Colorbuds_to_Playfoam.pptx
@@ -1054,7 +1054,7 @@
           <a:lstStyle/>
           <a:p>
             <a:r>
-              <a:t>Open with the one-line answer: Colorbuds, our top profit toy, is fading. The plan is simple: back newer, higher-margin toys, test one cheap fix for Colorbuds, and review in 8 weeks. Keep the intro under 20 seconds.</a:t>
+              <a:t>Open with the one-line answer: Colorbuds (our line of kids' wireless earbuds), our #1 profit toy, is in decline. The plan is simple: back newer, higher-margin toys, test one cheap fix for Colorbuds, and review in 8 weeks. Keep the intro under 20 seconds.</a:t>
             </a:r>
           </a:p>
         </p:txBody>
@@ -5033,8 +5033,8 @@
         </p:nvSpPr>
         <p:spPr>
           <a:xfrm>
-            <a:off x="548640" y="1737360"/>
-            <a:ext cx="6949440" cy="2331720"/>
+            <a:off x="548640" y="1463040"/>
+            <a:ext cx="7223760" cy="2468880"/>
           </a:xfrm>
           <a:prstGeom prst="rect">
             <a:avLst/>
@@ -5049,23 +5049,23 @@
           <a:p>
             <a:pPr algn="l"/>
             <a:r>
-              <a:rPr sz="4400" b="1">
+              <a:rPr sz="4000" b="1">
                 <a:solidFill>
                   <a:srgbClr val="FFFFFF"/>
                 </a:solidFill>
                 <a:latin typeface="Cambria"/>
               </a:rPr>
-              <a:t>Colorbuds is fading:</a:t>
+              <a:t>Colorbuds, our #1 profit toy,</a:t>
             </a:r>
             <a:br/>
             <a:r>
-              <a:rPr sz="4400" b="1">
+              <a:rPr sz="4000" b="1">
                 <a:solidFill>
                   <a:srgbClr val="FFFFFF"/>
                 </a:solidFill>
                 <a:latin typeface="Cambria"/>
               </a:rPr>
-              <a:t>what to do next</a:t>
+              <a:t>is in decline</a:t>
             </a:r>
           </a:p>
         </p:txBody>
@@ -5078,8 +5078,8 @@
         </p:nvSpPr>
         <p:spPr>
           <a:xfrm>
-            <a:off x="548640" y="4343400"/>
-            <a:ext cx="9144000" cy="457200"/>
+            <a:off x="548640" y="4160520"/>
+            <a:ext cx="6949440" cy="822960"/>
           </a:xfrm>
           <a:prstGeom prst="rect">
             <a:avLst/>
@@ -5094,7 +5094,77 @@
           <a:p>
             <a:pPr algn="l"/>
             <a:r>
-              <a:rPr sz="2000" b="0">
+              <a:rPr sz="2200" b="0">
+                <a:solidFill>
+                  <a:srgbClr val="D6E0EE"/>
+                </a:solidFill>
+                <a:latin typeface="Calibri"/>
+              </a:rPr>
+              <a:t>A plan to protect profit by backing newer, higher-margin toys</a:t>
+            </a:r>
+          </a:p>
+        </p:txBody>
+      </p:sp>
+      <p:sp>
+        <p:nvSpPr>
+          <p:cNvPr id="18" name="Descriptor"/>
+          <p:cNvSpPr txBox="1"/>
+          <p:nvPr/>
+        </p:nvSpPr>
+        <p:spPr>
+          <a:xfrm>
+            <a:off x="548640" y="5074920"/>
+            <a:ext cx="6949440" cy="365760"/>
+          </a:xfrm>
+          <a:prstGeom prst="rect">
+            <a:avLst/>
+          </a:prstGeom>
+          <a:noFill/>
+        </p:spPr>
+        <p:txBody>
+          <a:bodyPr wrap="square" lIns="0" rIns="0" tIns="0" bIns="0" anchor="t">
+            <a:spAutoFit/>
+          </a:bodyPr>
+          <a:lstStyle/>
+          <a:p>
+            <a:pPr algn="l"/>
+            <a:r>
+              <a:rPr sz="1400" b="0">
+                <a:solidFill>
+                  <a:srgbClr val="A9B8CC"/>
+                </a:solidFill>
+                <a:latin typeface="Calibri"/>
+              </a:rPr>
+              <a:t>Colorbuds are our line of kids' wireless earbuds</a:t>
+            </a:r>
+          </a:p>
+        </p:txBody>
+      </p:sp>
+      <p:sp>
+        <p:nvSpPr>
+          <p:cNvPr id="19" name="Date line"/>
+          <p:cNvSpPr txBox="1"/>
+          <p:nvPr/>
+        </p:nvSpPr>
+        <p:spPr>
+          <a:xfrm>
+            <a:off x="548640" y="6172200"/>
+            <a:ext cx="7315200" cy="365760"/>
+          </a:xfrm>
+          <a:prstGeom prst="rect">
+            <a:avLst/>
+          </a:prstGeom>
+          <a:noFill/>
+        </p:spPr>
+        <p:txBody>
+          <a:bodyPr wrap="square" lIns="0" rIns="0" tIns="0" bIns="0" anchor="t">
+            <a:spAutoFit/>
+          </a:bodyPr>
+          <a:lstStyle/>
+          <a:p>
+            <a:pPr algn="l"/>
+            <a:r>
+              <a:rPr sz="1400" b="0">
                 <a:solidFill>
                   <a:srgbClr val="A9B8CC"/>
                 </a:solidFill>
@@ -5567,13 +5637,40 @@
               <a:buChar char="•"/>
             </a:pPr>
             <a:r>
-              <a:rPr sz="2000">
+              <a:rPr sz="2000" b="0">
                 <a:solidFill>
                   <a:srgbClr val="1B2733"/>
                 </a:solidFill>
                 <a:latin typeface="Calibri"/>
               </a:rPr>
-              <a:t>Colorbuds is still our #1 profit toy, but its share has more than halved</a:t>
+              <a:t>Colorbuds is still our </a:t>
+            </a:r>
+            <a:r>
+              <a:rPr sz="2000" b="1">
+                <a:solidFill>
+                  <a:srgbClr val="1B2733"/>
+                </a:solidFill>
+                <a:latin typeface="Calibri"/>
+              </a:rPr>
+              <a:t>#1 profit toy</a:t>
+            </a:r>
+            <a:r>
+              <a:rPr sz="2000" b="0">
+                <a:solidFill>
+                  <a:srgbClr val="1B2733"/>
+                </a:solidFill>
+                <a:latin typeface="Calibri"/>
+              </a:rPr>
+              <a:t>, but its share has </a:t>
+            </a:r>
+            <a:r>
+              <a:rPr sz="2000" b="1">
+                <a:solidFill>
+                  <a:srgbClr val="1B2733"/>
+                </a:solidFill>
+                <a:latin typeface="Calibri"/>
+              </a:rPr>
+              <a:t>more than halved</a:t>
             </a:r>
           </a:p>
           <a:p>
@@ -5588,13 +5685,22 @@
               <a:buChar char="•"/>
             </a:pPr>
             <a:r>
-              <a:rPr sz="2000">
+              <a:rPr sz="2000" b="0">
                 <a:solidFill>
                   <a:srgbClr val="1B2733"/>
                 </a:solidFill>
                 <a:latin typeface="Calibri"/>
               </a:rPr>
-              <a:t>Playfoam launched in mid-August and is already a top-5 profit toy</a:t>
+              <a:t>Playfoam launched in mid-August and is already a </a:t>
+            </a:r>
+            <a:r>
+              <a:rPr sz="2000" b="1">
+                <a:solidFill>
+                  <a:srgbClr val="1B2733"/>
+                </a:solidFill>
+                <a:latin typeface="Calibri"/>
+              </a:rPr>
+              <a:t>top-5 profit toy</a:t>
             </a:r>
           </a:p>
           <a:p>
@@ -5609,13 +5715,31 @@
               <a:buChar char="•"/>
             </a:pPr>
             <a:r>
-              <a:rPr sz="2000">
+              <a:rPr sz="2000" b="0">
                 <a:solidFill>
                   <a:srgbClr val="1B2733"/>
                 </a:solidFill>
                 <a:latin typeface="Calibri"/>
               </a:rPr>
-              <a:t>Playfoam's September pace is nearly half of the $44K a month Colorbuds has lost</a:t>
+              <a:t>Playfoam's September pace is </a:t>
+            </a:r>
+            <a:r>
+              <a:rPr sz="2000" b="1">
+                <a:solidFill>
+                  <a:srgbClr val="1B2733"/>
+                </a:solidFill>
+                <a:latin typeface="Calibri"/>
+              </a:rPr>
+              <a:t>nearly half</a:t>
+            </a:r>
+            <a:r>
+              <a:rPr sz="2000" b="0">
+                <a:solidFill>
+                  <a:srgbClr val="1B2733"/>
+                </a:solidFill>
+                <a:latin typeface="Calibri"/>
+              </a:rPr>
+              <a:t> of the $44K a month Colorbuds has lost</a:t>
             </a:r>
           </a:p>
         </p:txBody>
@@ -5916,13 +6040,31 @@
               <a:buChar char="•"/>
             </a:pPr>
             <a:r>
-              <a:rPr sz="1800">
+              <a:rPr sz="1800" b="0">
                 <a:solidFill>
                   <a:srgbClr val="1B2733"/>
                 </a:solidFill>
                 <a:latin typeface="Calibri"/>
               </a:rPr>
-              <a:t>Down in 48 of 50 stores, in every store type</a:t>
+              <a:t>Down in </a:t>
+            </a:r>
+            <a:r>
+              <a:rPr sz="1800" b="1">
+                <a:solidFill>
+                  <a:srgbClr val="1B2733"/>
+                </a:solidFill>
+                <a:latin typeface="Calibri"/>
+              </a:rPr>
+              <a:t>48 of 50 stores</a:t>
+            </a:r>
+            <a:r>
+              <a:rPr sz="1800" b="0">
+                <a:solidFill>
+                  <a:srgbClr val="1B2733"/>
+                </a:solidFill>
+                <a:latin typeface="Calibri"/>
+              </a:rPr>
+              <a:t>, in every store type</a:t>
             </a:r>
           </a:p>
           <a:p>
@@ -5937,13 +6079,22 @@
               <a:buChar char="•"/>
             </a:pPr>
             <a:r>
-              <a:rPr sz="1800">
+              <a:rPr sz="1800" b="0">
                 <a:solidFill>
                   <a:srgbClr val="1B2733"/>
                 </a:solidFill>
                 <a:latin typeface="Calibri"/>
               </a:rPr>
-              <a:t>Every store still carries it, so this is weaker demand, not empty shelves</a:t>
+              <a:t>Every store still carries it, so this is </a:t>
+            </a:r>
+            <a:r>
+              <a:rPr sz="1800" b="1">
+                <a:solidFill>
+                  <a:srgbClr val="1B2733"/>
+                </a:solidFill>
+                <a:latin typeface="Calibri"/>
+              </a:rPr>
+              <a:t>weaker demand, not empty shelves</a:t>
             </a:r>
           </a:p>
           <a:p>
@@ -5958,13 +6109,31 @@
               <a:buChar char="•"/>
             </a:pPr>
             <a:r>
-              <a:rPr sz="1800">
+              <a:rPr sz="1800" b="0">
                 <a:solidFill>
                   <a:srgbClr val="1B2733"/>
                 </a:solidFill>
                 <a:latin typeface="Calibri"/>
               </a:rPr>
-              <a:t>Quarterly profit has roughly halved: $142K to $74K</a:t>
+              <a:t>Quarterly profit has </a:t>
+            </a:r>
+            <a:r>
+              <a:rPr sz="1800" b="1">
+                <a:solidFill>
+                  <a:srgbClr val="1B2733"/>
+                </a:solidFill>
+                <a:latin typeface="Calibri"/>
+              </a:rPr>
+              <a:t>roughly halved</a:t>
+            </a:r>
+            <a:r>
+              <a:rPr sz="1800" b="0">
+                <a:solidFill>
+                  <a:srgbClr val="1B2733"/>
+                </a:solidFill>
+                <a:latin typeface="Calibri"/>
+              </a:rPr>
+              <a:t>: $142K to $74K</a:t>
             </a:r>
           </a:p>
         </p:txBody>
@@ -6722,13 +6891,22 @@
               <a:buChar char="•"/>
             </a:pPr>
             <a:r>
-              <a:rPr sz="2000">
+              <a:rPr sz="2000" b="0">
                 <a:solidFill>
                   <a:srgbClr val="1B2733"/>
                 </a:solidFill>
                 <a:latin typeface="Calibri"/>
               </a:rPr>
-              <a:t>Jenga peaked in Jul 2022 and is now down 92%</a:t>
+              <a:t>Jenga peaked in Jul 2022 and is now </a:t>
+            </a:r>
+            <a:r>
+              <a:rPr sz="2000" b="1">
+                <a:solidFill>
+                  <a:srgbClr val="1B2733"/>
+                </a:solidFill>
+                <a:latin typeface="Calibri"/>
+              </a:rPr>
+              <a:t>down 92%</a:t>
             </a:r>
           </a:p>
           <a:p>
@@ -6743,13 +6921,22 @@
               <a:buChar char="•"/>
             </a:pPr>
             <a:r>
-              <a:rPr sz="2000">
+              <a:rPr sz="2000" b="0">
                 <a:solidFill>
                   <a:srgbClr val="1B2733"/>
                 </a:solidFill>
                 <a:latin typeface="Calibri"/>
               </a:rPr>
-              <a:t>Etch A Sketch peaked its second month and is down 56%</a:t>
+              <a:t>Etch A Sketch peaked its second month and is </a:t>
+            </a:r>
+            <a:r>
+              <a:rPr sz="2000" b="1">
+                <a:solidFill>
+                  <a:srgbClr val="1B2733"/>
+                </a:solidFill>
+                <a:latin typeface="Calibri"/>
+              </a:rPr>
+              <a:t>down 56%</a:t>
             </a:r>
           </a:p>
           <a:p>
@@ -6764,13 +6951,31 @@
               <a:buChar char="•"/>
             </a:pPr>
             <a:r>
-              <a:rPr sz="2000">
+              <a:rPr sz="2000" b="0">
                 <a:solidFill>
                   <a:srgbClr val="1B2733"/>
                 </a:solidFill>
                 <a:latin typeface="Calibri"/>
               </a:rPr>
-              <a:t>Hot Wheels is the lone exception, down just 9%</a:t>
+              <a:t>Hot Wheels is the </a:t>
+            </a:r>
+            <a:r>
+              <a:rPr sz="2000" b="1">
+                <a:solidFill>
+                  <a:srgbClr val="1B2733"/>
+                </a:solidFill>
+                <a:latin typeface="Calibri"/>
+              </a:rPr>
+              <a:t>lone exception</a:t>
+            </a:r>
+            <a:r>
+              <a:rPr sz="2000" b="0">
+                <a:solidFill>
+                  <a:srgbClr val="1B2733"/>
+                </a:solidFill>
+                <a:latin typeface="Calibri"/>
+              </a:rPr>
+              <a:t>, down just 9%</a:t>
             </a:r>
           </a:p>
           <a:p>
@@ -6785,13 +6990,22 @@
               <a:buChar char="•"/>
             </a:pPr>
             <a:r>
-              <a:rPr sz="2000">
+              <a:rPr sz="2000" b="0">
                 <a:solidFill>
                   <a:srgbClr val="1B2733"/>
                 </a:solidFill>
                 <a:latin typeface="Calibri"/>
               </a:rPr>
-              <a:t>Colorbuds follows the same pattern</a:t>
+              <a:t>Colorbuds follows the </a:t>
+            </a:r>
+            <a:r>
+              <a:rPr sz="2000" b="1">
+                <a:solidFill>
+                  <a:srgbClr val="1B2733"/>
+                </a:solidFill>
+                <a:latin typeface="Calibri"/>
+              </a:rPr>
+              <a:t>same pattern</a:t>
             </a:r>
           </a:p>
         </p:txBody>
@@ -7241,13 +7455,22 @@
               <a:buChar char="•"/>
             </a:pPr>
             <a:r>
-              <a:rPr sz="1800">
+              <a:rPr sz="1800" b="0">
                 <a:solidFill>
                   <a:srgbClr val="1B2733"/>
                 </a:solidFill>
                 <a:latin typeface="Calibri"/>
               </a:rPr>
-              <a:t>Launched Aug 17 and already a top-5 profit toy</a:t>
+              <a:t>Launched Aug 17 and already a </a:t>
+            </a:r>
+            <a:r>
+              <a:rPr sz="1800" b="1">
+                <a:solidFill>
+                  <a:srgbClr val="1B2733"/>
+                </a:solidFill>
+                <a:latin typeface="Calibri"/>
+              </a:rPr>
+              <a:t>top-5 profit toy</a:t>
             </a:r>
           </a:p>
           <a:p>
@@ -7262,13 +7485,22 @@
               <a:buChar char="•"/>
             </a:pPr>
             <a:r>
-              <a:rPr sz="1800">
+              <a:rPr sz="1800" b="0">
                 <a:solidFill>
                   <a:srgbClr val="1B2733"/>
                 </a:solidFill>
                 <a:latin typeface="Calibri"/>
               </a:rPr>
-              <a:t>New toys often cool off, so the window to act is short</a:t>
+              <a:t>New toys often cool off, so </a:t>
+            </a:r>
+            <a:r>
+              <a:rPr sz="1800" b="1">
+                <a:solidFill>
+                  <a:srgbClr val="1B2733"/>
+                </a:solidFill>
+                <a:latin typeface="Calibri"/>
+              </a:rPr>
+              <a:t>the window to act is short</a:t>
             </a:r>
           </a:p>
         </p:txBody>
@@ -7569,13 +7801,22 @@
               <a:buChar char="•"/>
             </a:pPr>
             <a:r>
-              <a:rPr sz="1700">
+              <a:rPr sz="1700" b="0">
                 <a:solidFill>
                   <a:srgbClr val="1B2733"/>
                 </a:solidFill>
                 <a:latin typeface="Calibri"/>
               </a:rPr>
-              <a:t>Refill the 13 empty stores</a:t>
+              <a:t>Refill the </a:t>
+            </a:r>
+            <a:r>
+              <a:rPr sz="1700" b="1">
+                <a:solidFill>
+                  <a:srgbClr val="1B2733"/>
+                </a:solidFill>
+                <a:latin typeface="Calibri"/>
+              </a:rPr>
+              <a:t>13 empty stores</a:t>
             </a:r>
           </a:p>
           <a:p>
@@ -7590,13 +7831,22 @@
               <a:buChar char="•"/>
             </a:pPr>
             <a:r>
-              <a:rPr sz="1700">
+              <a:rPr sz="1700" b="0">
                 <a:solidFill>
                   <a:srgbClr val="1B2733"/>
                 </a:solidFill>
                 <a:latin typeface="Calibri"/>
               </a:rPr>
-              <a:t>Check weekly; worth about $5K a month</a:t>
+              <a:t>Check weekly; worth about </a:t>
+            </a:r>
+            <a:r>
+              <a:rPr sz="1700" b="1">
+                <a:solidFill>
+                  <a:srgbClr val="1B2733"/>
+                </a:solidFill>
+                <a:latin typeface="Calibri"/>
+              </a:rPr>
+              <a:t>$5K a month</a:t>
             </a:r>
           </a:p>
         </p:txBody>
@@ -7766,13 +8016,22 @@
               <a:buChar char="•"/>
             </a:pPr>
             <a:r>
-              <a:rPr sz="1700">
+              <a:rPr sz="1700" b="1">
                 <a:solidFill>
                   <a:srgbClr val="1B2733"/>
                 </a:solidFill>
                 <a:latin typeface="Calibri"/>
               </a:rPr>
-              <a:t>10 test stores vs 10 similar ones</a:t>
+              <a:t>10 test stores</a:t>
+            </a:r>
+            <a:r>
+              <a:rPr sz="1700" b="0">
+                <a:solidFill>
+                  <a:srgbClr val="1B2733"/>
+                </a:solidFill>
+                <a:latin typeface="Calibri"/>
+              </a:rPr>
+              <a:t> vs 10 similar ones</a:t>
             </a:r>
           </a:p>
           <a:p>
@@ -7787,13 +8046,31 @@
               <a:buChar char="•"/>
             </a:pPr>
             <a:r>
-              <a:rPr sz="1700">
+              <a:rPr sz="1700" b="0">
                 <a:solidFill>
                   <a:srgbClr val="1B2733"/>
                 </a:solidFill>
                 <a:latin typeface="Calibri"/>
               </a:rPr>
-              <a:t>Up to about $11K a month if it works</a:t>
+              <a:t>Up to about </a:t>
+            </a:r>
+            <a:r>
+              <a:rPr sz="1700" b="1">
+                <a:solidFill>
+                  <a:srgbClr val="1B2733"/>
+                </a:solidFill>
+                <a:latin typeface="Calibri"/>
+              </a:rPr>
+              <a:t>$11K a month</a:t>
+            </a:r>
+            <a:r>
+              <a:rPr sz="1700" b="0">
+                <a:solidFill>
+                  <a:srgbClr val="1B2733"/>
+                </a:solidFill>
+                <a:latin typeface="Calibri"/>
+              </a:rPr>
+              <a:t> if it works</a:t>
             </a:r>
           </a:p>
         </p:txBody>
@@ -7963,13 +8240,22 @@
               <a:buChar char="•"/>
             </a:pPr>
             <a:r>
-              <a:rPr sz="1700">
+              <a:rPr sz="1700" b="1">
                 <a:solidFill>
                   <a:srgbClr val="1B2733"/>
                 </a:solidFill>
                 <a:latin typeface="Calibri"/>
               </a:rPr>
-              <a:t>Scale what works, stop what doesn't</a:t>
+              <a:t>Scale what works</a:t>
+            </a:r>
+            <a:r>
+              <a:rPr sz="1700" b="0">
+                <a:solidFill>
+                  <a:srgbClr val="1B2733"/>
+                </a:solidFill>
+                <a:latin typeface="Calibri"/>
+              </a:rPr>
+              <a:t>, stop what doesn't</a:t>
             </a:r>
           </a:p>
           <a:p>
@@ -7984,13 +8270,22 @@
               <a:buChar char="•"/>
             </a:pPr>
             <a:r>
-              <a:rPr sz="1700">
+              <a:rPr sz="1700" b="0">
                 <a:solidFill>
                   <a:srgbClr val="1B2733"/>
                 </a:solidFill>
                 <a:latin typeface="Calibri"/>
               </a:rPr>
-              <a:t>Pick the next higher-margin toy</a:t>
+              <a:t>Pick the next </a:t>
+            </a:r>
+            <a:r>
+              <a:rPr sz="1700" b="1">
+                <a:solidFill>
+                  <a:srgbClr val="1B2733"/>
+                </a:solidFill>
+                <a:latin typeface="Calibri"/>
+              </a:rPr>
+              <a:t>higher-margin toy</a:t>
             </a:r>
           </a:p>
         </p:txBody>

</xml_diff>

<commit_message>
Deck: Colorbuds illustration on the cover, cleaner slide 4, and a concrete Colorbuds refresh on slide 6
Co-Authored-By: Claude Sonnet 5.5 <noreply@anthropic.com>
Claude-Session: https://claude.ai/code/session_01J6v5JYXB5XucuZ66TGAjVJ
</commit_message>
<xml_diff>
--- a/site/deck/Colorbuds_to_Playfoam.pptx
+++ b/site/deck/Colorbuds_to_Playfoam.pptx
@@ -1404,7 +1404,7 @@
           <a:lstStyle/>
           <a:p>
             <a:r>
-              <a:t>1) Keep Playfoam in stock: refill the 13 stores at zero and keep every store above about two weeks of sales (roughly 26 units a store); check weekly. Worth about $5K a month now. 2) Test one cheap Colorbuds fix: refresh, bundle with Gamer Headphones, or better shelf placement in about 10 stores against 10 similar control stores for six weeks. Winning back a quarter of the lost sales is worth up to about $11K a month. 3) Review at week 8: if the test stores sold about 15% more Colorbuds, scale the fix; if not, stop. Pick the next newer, higher-margin toy to back at the same review. The 15% threshold is a suggestion to agree on in advance, not something from the data. Sizes are estimates; the data cannot show why Colorbuds fell.</a:t>
+              <a:t>1) Keep Playfoam in stock: refill the 13 stores at zero and keep every store above about two weeks of sales (roughly 26 units a store); check weekly. Worth about $5K a month now. 2) Test a Colorbuds refresh: the options to try are new colors, a bundle with Gamer Headphones, or a better shelf spot, in about 10 stores against 10 similar control stores for six weeks. Winning back a quarter of the lost sales is worth up to about $11K a month. 3) Review at week 8: if the test stores sold about 15% more Colorbuds, scale the fix; if not, stop. Pick the next newer, higher-margin toy to back at the same review. The 15% threshold is a suggestion to agree on in advance, not something from the data. Sizes are estimates; the data cannot show why Colorbuds fell.</a:t>
             </a:r>
           </a:p>
         </p:txBody>
@@ -4587,20 +4587,20 @@
       </p:sp>
       <p:sp>
         <p:nvSpPr>
-          <p:cNvPr id="6" name="Block r0c0"/>
+          <p:cNvPr id="6" name="Image panel"/>
           <p:cNvSpPr/>
           <p:nvPr/>
         </p:nvSpPr>
         <p:spPr>
           <a:xfrm>
-            <a:off x="7818120" y="5623560"/>
-            <a:ext cx="822960" cy="822960"/>
+            <a:off x="7772400" y="1371600"/>
+            <a:ext cx="3867912" cy="3867912"/>
           </a:xfrm>
           <a:prstGeom prst="rect">
             <a:avLst/>
           </a:prstGeom>
           <a:solidFill>
-            <a:srgbClr val="2A78D6"/>
+            <a:srgbClr val="FFFFFF"/>
           </a:solidFill>
           <a:ln>
             <a:noFill/>
@@ -4629,405 +4629,33 @@
           </a:p>
         </p:txBody>
       </p:sp>
-      <p:sp>
-        <p:nvSpPr>
-          <p:cNvPr id="7" name="Block r0c1"/>
-          <p:cNvSpPr/>
+      <p:pic>
+        <p:nvPicPr>
+          <p:cNvPr id="7" name="Colorbuds illustration" descr="Illustration of Colorbuds: two colorful earbuds in an open charging case with a heart"/>
+          <p:cNvPicPr>
+            <a:picLocks noChangeAspect="1"/>
+          </p:cNvPicPr>
           <p:nvPr/>
-        </p:nvSpPr>
-        <p:spPr>
-          <a:xfrm>
-            <a:off x="8732520" y="5623560"/>
-            <a:ext cx="822960" cy="822960"/>
+        </p:nvPicPr>
+        <p:blipFill>
+          <a:blip r:embed="rId2"/>
+          <a:stretch>
+            <a:fillRect/>
+          </a:stretch>
+        </p:blipFill>
+        <p:spPr>
+          <a:xfrm>
+            <a:off x="7955279" y="1554480"/>
+            <a:ext cx="3502152" cy="3502152"/>
           </a:xfrm>
           <a:prstGeom prst="rect">
             <a:avLst/>
           </a:prstGeom>
-          <a:solidFill>
-            <a:srgbClr val="EB6834"/>
-          </a:solidFill>
-          <a:ln>
-            <a:noFill/>
-          </a:ln>
-          <a:effectLst/>
-        </p:spPr>
-        <p:style>
-          <a:lnRef idx="1">
-            <a:schemeClr val="accent1"/>
-          </a:lnRef>
-          <a:fillRef idx="3">
-            <a:schemeClr val="accent1"/>
-          </a:fillRef>
-          <a:effectRef idx="0">
-            <a:schemeClr val="accent1"/>
-          </a:effectRef>
-          <a:fontRef idx="minor">
-            <a:schemeClr val="lt1"/>
-          </a:fontRef>
-        </p:style>
-        <p:txBody>
-          <a:bodyPr rtlCol="0" anchor="ctr"/>
-          <a:lstStyle/>
-          <a:p>
-            <a:pPr algn="ctr"/>
-          </a:p>
-        </p:txBody>
-      </p:sp>
-      <p:sp>
-        <p:nvSpPr>
-          <p:cNvPr id="8" name="Block r0c2"/>
-          <p:cNvSpPr/>
-          <p:nvPr/>
-        </p:nvSpPr>
-        <p:spPr>
-          <a:xfrm>
-            <a:off x="9646920" y="5623560"/>
-            <a:ext cx="822960" cy="822960"/>
-          </a:xfrm>
-          <a:prstGeom prst="rect">
-            <a:avLst/>
-          </a:prstGeom>
-          <a:solidFill>
-            <a:srgbClr val="E8457B"/>
-          </a:solidFill>
-          <a:ln>
-            <a:noFill/>
-          </a:ln>
-          <a:effectLst/>
-        </p:spPr>
-        <p:style>
-          <a:lnRef idx="1">
-            <a:schemeClr val="accent1"/>
-          </a:lnRef>
-          <a:fillRef idx="3">
-            <a:schemeClr val="accent1"/>
-          </a:fillRef>
-          <a:effectRef idx="0">
-            <a:schemeClr val="accent1"/>
-          </a:effectRef>
-          <a:fontRef idx="minor">
-            <a:schemeClr val="lt1"/>
-          </a:fontRef>
-        </p:style>
-        <p:txBody>
-          <a:bodyPr rtlCol="0" anchor="ctr"/>
-          <a:lstStyle/>
-          <a:p>
-            <a:pPr algn="ctr"/>
-          </a:p>
-        </p:txBody>
-      </p:sp>
-      <p:sp>
-        <p:nvSpPr>
-          <p:cNvPr id="9" name="Block r0c3"/>
-          <p:cNvSpPr/>
-          <p:nvPr/>
-        </p:nvSpPr>
-        <p:spPr>
-          <a:xfrm>
-            <a:off x="10561320" y="5623560"/>
-            <a:ext cx="822960" cy="822960"/>
-          </a:xfrm>
-          <a:prstGeom prst="rect">
-            <a:avLst/>
-          </a:prstGeom>
-          <a:solidFill>
-            <a:srgbClr val="F2B400"/>
-          </a:solidFill>
-          <a:ln>
-            <a:noFill/>
-          </a:ln>
-          <a:effectLst/>
-        </p:spPr>
-        <p:style>
-          <a:lnRef idx="1">
-            <a:schemeClr val="accent1"/>
-          </a:lnRef>
-          <a:fillRef idx="3">
-            <a:schemeClr val="accent1"/>
-          </a:fillRef>
-          <a:effectRef idx="0">
-            <a:schemeClr val="accent1"/>
-          </a:effectRef>
-          <a:fontRef idx="minor">
-            <a:schemeClr val="lt1"/>
-          </a:fontRef>
-        </p:style>
-        <p:txBody>
-          <a:bodyPr rtlCol="0" anchor="ctr"/>
-          <a:lstStyle/>
-          <a:p>
-            <a:pPr algn="ctr"/>
-          </a:p>
-        </p:txBody>
-      </p:sp>
-      <p:sp>
-        <p:nvSpPr>
-          <p:cNvPr id="10" name="Block r1c0"/>
-          <p:cNvSpPr/>
-          <p:nvPr/>
-        </p:nvSpPr>
-        <p:spPr>
-          <a:xfrm>
-            <a:off x="8275320" y="4709160"/>
-            <a:ext cx="822960" cy="822960"/>
-          </a:xfrm>
-          <a:prstGeom prst="rect">
-            <a:avLst/>
-          </a:prstGeom>
-          <a:solidFill>
-            <a:srgbClr val="1BAF7A"/>
-          </a:solidFill>
-          <a:ln>
-            <a:noFill/>
-          </a:ln>
-          <a:effectLst/>
-        </p:spPr>
-        <p:style>
-          <a:lnRef idx="1">
-            <a:schemeClr val="accent1"/>
-          </a:lnRef>
-          <a:fillRef idx="3">
-            <a:schemeClr val="accent1"/>
-          </a:fillRef>
-          <a:effectRef idx="0">
-            <a:schemeClr val="accent1"/>
-          </a:effectRef>
-          <a:fontRef idx="minor">
-            <a:schemeClr val="lt1"/>
-          </a:fontRef>
-        </p:style>
-        <p:txBody>
-          <a:bodyPr rtlCol="0" anchor="ctr"/>
-          <a:lstStyle/>
-          <a:p>
-            <a:pPr algn="ctr"/>
-          </a:p>
-        </p:txBody>
-      </p:sp>
-      <p:sp>
-        <p:nvSpPr>
-          <p:cNvPr id="11" name="Block r1c1"/>
-          <p:cNvSpPr/>
-          <p:nvPr/>
-        </p:nvSpPr>
-        <p:spPr>
-          <a:xfrm>
-            <a:off x="9189720" y="4709160"/>
-            <a:ext cx="822960" cy="822960"/>
-          </a:xfrm>
-          <a:prstGeom prst="rect">
-            <a:avLst/>
-          </a:prstGeom>
-          <a:solidFill>
-            <a:srgbClr val="2A78D6"/>
-          </a:solidFill>
-          <a:ln>
-            <a:noFill/>
-          </a:ln>
-          <a:effectLst/>
-        </p:spPr>
-        <p:style>
-          <a:lnRef idx="1">
-            <a:schemeClr val="accent1"/>
-          </a:lnRef>
-          <a:fillRef idx="3">
-            <a:schemeClr val="accent1"/>
-          </a:fillRef>
-          <a:effectRef idx="0">
-            <a:schemeClr val="accent1"/>
-          </a:effectRef>
-          <a:fontRef idx="minor">
-            <a:schemeClr val="lt1"/>
-          </a:fontRef>
-        </p:style>
-        <p:txBody>
-          <a:bodyPr rtlCol="0" anchor="ctr"/>
-          <a:lstStyle/>
-          <a:p>
-            <a:pPr algn="ctr"/>
-          </a:p>
-        </p:txBody>
-      </p:sp>
-      <p:sp>
-        <p:nvSpPr>
-          <p:cNvPr id="12" name="Block r1c2"/>
-          <p:cNvSpPr/>
-          <p:nvPr/>
-        </p:nvSpPr>
-        <p:spPr>
-          <a:xfrm>
-            <a:off x="10104120" y="4709160"/>
-            <a:ext cx="822960" cy="822960"/>
-          </a:xfrm>
-          <a:prstGeom prst="rect">
-            <a:avLst/>
-          </a:prstGeom>
-          <a:solidFill>
-            <a:srgbClr val="EB6834"/>
-          </a:solidFill>
-          <a:ln>
-            <a:noFill/>
-          </a:ln>
-          <a:effectLst/>
-        </p:spPr>
-        <p:style>
-          <a:lnRef idx="1">
-            <a:schemeClr val="accent1"/>
-          </a:lnRef>
-          <a:fillRef idx="3">
-            <a:schemeClr val="accent1"/>
-          </a:fillRef>
-          <a:effectRef idx="0">
-            <a:schemeClr val="accent1"/>
-          </a:effectRef>
-          <a:fontRef idx="minor">
-            <a:schemeClr val="lt1"/>
-          </a:fontRef>
-        </p:style>
-        <p:txBody>
-          <a:bodyPr rtlCol="0" anchor="ctr"/>
-          <a:lstStyle/>
-          <a:p>
-            <a:pPr algn="ctr"/>
-          </a:p>
-        </p:txBody>
-      </p:sp>
-      <p:sp>
-        <p:nvSpPr>
-          <p:cNvPr id="13" name="Block r2c0"/>
-          <p:cNvSpPr/>
-          <p:nvPr/>
-        </p:nvSpPr>
-        <p:spPr>
-          <a:xfrm>
-            <a:off x="8732520" y="3794760"/>
-            <a:ext cx="822960" cy="822960"/>
-          </a:xfrm>
-          <a:prstGeom prst="rect">
-            <a:avLst/>
-          </a:prstGeom>
-          <a:solidFill>
-            <a:srgbClr val="E8457B"/>
-          </a:solidFill>
-          <a:ln>
-            <a:noFill/>
-          </a:ln>
-          <a:effectLst/>
-        </p:spPr>
-        <p:style>
-          <a:lnRef idx="1">
-            <a:schemeClr val="accent1"/>
-          </a:lnRef>
-          <a:fillRef idx="3">
-            <a:schemeClr val="accent1"/>
-          </a:fillRef>
-          <a:effectRef idx="0">
-            <a:schemeClr val="accent1"/>
-          </a:effectRef>
-          <a:fontRef idx="minor">
-            <a:schemeClr val="lt1"/>
-          </a:fontRef>
-        </p:style>
-        <p:txBody>
-          <a:bodyPr rtlCol="0" anchor="ctr"/>
-          <a:lstStyle/>
-          <a:p>
-            <a:pPr algn="ctr"/>
-          </a:p>
-        </p:txBody>
-      </p:sp>
-      <p:sp>
-        <p:nvSpPr>
-          <p:cNvPr id="14" name="Block r2c1"/>
-          <p:cNvSpPr/>
-          <p:nvPr/>
-        </p:nvSpPr>
-        <p:spPr>
-          <a:xfrm>
-            <a:off x="9646920" y="3794760"/>
-            <a:ext cx="822960" cy="822960"/>
-          </a:xfrm>
-          <a:prstGeom prst="rect">
-            <a:avLst/>
-          </a:prstGeom>
-          <a:solidFill>
-            <a:srgbClr val="1BAF7A"/>
-          </a:solidFill>
-          <a:ln>
-            <a:noFill/>
-          </a:ln>
-          <a:effectLst/>
-        </p:spPr>
-        <p:style>
-          <a:lnRef idx="1">
-            <a:schemeClr val="accent1"/>
-          </a:lnRef>
-          <a:fillRef idx="3">
-            <a:schemeClr val="accent1"/>
-          </a:fillRef>
-          <a:effectRef idx="0">
-            <a:schemeClr val="accent1"/>
-          </a:effectRef>
-          <a:fontRef idx="minor">
-            <a:schemeClr val="lt1"/>
-          </a:fontRef>
-        </p:style>
-        <p:txBody>
-          <a:bodyPr rtlCol="0" anchor="ctr"/>
-          <a:lstStyle/>
-          <a:p>
-            <a:pPr algn="ctr"/>
-          </a:p>
-        </p:txBody>
-      </p:sp>
-      <p:sp>
-        <p:nvSpPr>
-          <p:cNvPr id="15" name="Block r3c0"/>
-          <p:cNvSpPr/>
-          <p:nvPr/>
-        </p:nvSpPr>
-        <p:spPr>
-          <a:xfrm>
-            <a:off x="9189720" y="2880360"/>
-            <a:ext cx="822960" cy="822960"/>
-          </a:xfrm>
-          <a:prstGeom prst="rect">
-            <a:avLst/>
-          </a:prstGeom>
-          <a:solidFill>
-            <a:srgbClr val="F2B400"/>
-          </a:solidFill>
-          <a:ln>
-            <a:noFill/>
-          </a:ln>
-          <a:effectLst/>
-        </p:spPr>
-        <p:style>
-          <a:lnRef idx="1">
-            <a:schemeClr val="accent1"/>
-          </a:lnRef>
-          <a:fillRef idx="3">
-            <a:schemeClr val="accent1"/>
-          </a:fillRef>
-          <a:effectRef idx="0">
-            <a:schemeClr val="accent1"/>
-          </a:effectRef>
-          <a:fontRef idx="minor">
-            <a:schemeClr val="lt1"/>
-          </a:fontRef>
-        </p:style>
-        <p:txBody>
-          <a:bodyPr rtlCol="0" anchor="ctr"/>
-          <a:lstStyle/>
-          <a:p>
-            <a:pPr algn="ctr"/>
-          </a:p>
-        </p:txBody>
-      </p:sp>
-      <p:sp>
-        <p:nvSpPr>
-          <p:cNvPr id="16" name="Title"/>
+        </p:spPr>
+      </p:pic>
+      <p:sp>
+        <p:nvSpPr>
+          <p:cNvPr id="8" name="Title"/>
           <p:cNvSpPr txBox="1"/>
           <p:nvPr/>
         </p:nvSpPr>
@@ -5072,7 +4700,7 @@
       </p:sp>
       <p:sp>
         <p:nvSpPr>
-          <p:cNvPr id="17" name="Subtitle"/>
+          <p:cNvPr id="9" name="Subtitle"/>
           <p:cNvSpPr txBox="1"/>
           <p:nvPr/>
         </p:nvSpPr>
@@ -5107,42 +4735,7 @@
       </p:sp>
       <p:sp>
         <p:nvSpPr>
-          <p:cNvPr id="18" name="Descriptor"/>
-          <p:cNvSpPr txBox="1"/>
-          <p:nvPr/>
-        </p:nvSpPr>
-        <p:spPr>
-          <a:xfrm>
-            <a:off x="548640" y="5074920"/>
-            <a:ext cx="6949440" cy="365760"/>
-          </a:xfrm>
-          <a:prstGeom prst="rect">
-            <a:avLst/>
-          </a:prstGeom>
-          <a:noFill/>
-        </p:spPr>
-        <p:txBody>
-          <a:bodyPr wrap="square" lIns="0" rIns="0" tIns="0" bIns="0" anchor="t">
-            <a:spAutoFit/>
-          </a:bodyPr>
-          <a:lstStyle/>
-          <a:p>
-            <a:pPr algn="l"/>
-            <a:r>
-              <a:rPr sz="1400" b="0">
-                <a:solidFill>
-                  <a:srgbClr val="A9B8CC"/>
-                </a:solidFill>
-                <a:latin typeface="Calibri"/>
-              </a:rPr>
-              <a:t>Colorbuds are our line of kids' wireless earbuds</a:t>
-            </a:r>
-          </a:p>
-        </p:txBody>
-      </p:sp>
-      <p:sp>
-        <p:nvSpPr>
-          <p:cNvPr id="19" name="Date line"/>
+          <p:cNvPr id="10" name="Date line"/>
           <p:cNvSpPr txBox="1"/>
           <p:nvPr/>
         </p:nvSpPr>
@@ -6378,7 +5971,16 @@
                 </a:solidFill>
                 <a:latin typeface="Calibri"/>
               </a:rPr>
-              <a:t>recent launches are 40%+ below their peak month</a:t>
+              <a:t>recent launches are </a:t>
+            </a:r>
+            <a:r>
+              <a:rPr sz="2200" b="1">
+                <a:solidFill>
+                  <a:srgbClr val="051C2C"/>
+                </a:solidFill>
+                <a:latin typeface="Calibri"/>
+              </a:rPr>
+              <a:t>40%+ below their peak month</a:t>
             </a:r>
           </a:p>
         </p:txBody>
@@ -6897,16 +6499,7 @@
                 </a:solidFill>
                 <a:latin typeface="Calibri"/>
               </a:rPr>
-              <a:t>Jenga peaked in Jul 2022 and is now </a:t>
-            </a:r>
-            <a:r>
-              <a:rPr sz="2000" b="1">
-                <a:solidFill>
-                  <a:srgbClr val="1B2733"/>
-                </a:solidFill>
-                <a:latin typeface="Calibri"/>
-              </a:rPr>
-              <a:t>down 92%</a:t>
+              <a:t>Jenga peaked in Jul 2022 and is now down 92%</a:t>
             </a:r>
           </a:p>
           <a:p>
@@ -6927,16 +6520,7 @@
                 </a:solidFill>
                 <a:latin typeface="Calibri"/>
               </a:rPr>
-              <a:t>Etch A Sketch peaked its second month and is </a:t>
-            </a:r>
-            <a:r>
-              <a:rPr sz="2000" b="1">
-                <a:solidFill>
-                  <a:srgbClr val="1B2733"/>
-                </a:solidFill>
-                <a:latin typeface="Calibri"/>
-              </a:rPr>
-              <a:t>down 56%</a:t>
+              <a:t>Etch A Sketch peaked its second month and is down 56%</a:t>
             </a:r>
           </a:p>
           <a:p>
@@ -6957,25 +6541,7 @@
                 </a:solidFill>
                 <a:latin typeface="Calibri"/>
               </a:rPr>
-              <a:t>Hot Wheels is the </a:t>
-            </a:r>
-            <a:r>
-              <a:rPr sz="2000" b="1">
-                <a:solidFill>
-                  <a:srgbClr val="1B2733"/>
-                </a:solidFill>
-                <a:latin typeface="Calibri"/>
-              </a:rPr>
-              <a:t>lone exception</a:t>
-            </a:r>
-            <a:r>
-              <a:rPr sz="2000" b="0">
-                <a:solidFill>
-                  <a:srgbClr val="1B2733"/>
-                </a:solidFill>
-                <a:latin typeface="Calibri"/>
-              </a:rPr>
-              <a:t>, down just 9%</a:t>
+              <a:t>Mr. Potatohead peaked in Nov 2022 and is now down 65%</a:t>
             </a:r>
           </a:p>
           <a:p>
@@ -6990,22 +6556,13 @@
               <a:buChar char="•"/>
             </a:pPr>
             <a:r>
-              <a:rPr sz="2000" b="0">
+              <a:rPr sz="2000" b="1">
                 <a:solidFill>
                   <a:srgbClr val="1B2733"/>
                 </a:solidFill>
                 <a:latin typeface="Calibri"/>
               </a:rPr>
-              <a:t>Colorbuds follows the </a:t>
-            </a:r>
-            <a:r>
-              <a:rPr sz="2000" b="1">
-                <a:solidFill>
-                  <a:srgbClr val="1B2733"/>
-                </a:solidFill>
-                <a:latin typeface="Calibri"/>
-              </a:rPr>
-              <a:t>same pattern</a:t>
+              <a:t>Colorbuds is following the same trend</a:t>
             </a:r>
           </a:p>
         </p:txBody>
@@ -7561,7 +7118,7 @@
                 </a:solidFill>
                 <a:latin typeface="Cambria"/>
               </a:rPr>
-              <a:t>We recommend three moves: back newer, higher-margin toys, test one Colorbuds fix, and review in 8 weeks</a:t>
+              <a:t>We recommend three moves: back newer, higher-margin toys, test a Colorbuds refresh, and review in 8 weeks</a:t>
             </a:r>
           </a:p>
         </p:txBody>
@@ -7776,7 +7333,7 @@
         </p:nvSpPr>
         <p:spPr>
           <a:xfrm>
-            <a:off x="914400" y="4206240"/>
+            <a:off x="914400" y="4114800"/>
             <a:ext cx="2783738" cy="1737360"/>
           </a:xfrm>
           <a:prstGeom prst="rect">
@@ -7792,7 +7349,7 @@
           <a:p>
             <a:pPr marL="285750" indent="-285750">
               <a:spcAft>
-                <a:spcPts val="1000"/>
+                <a:spcPts val="800"/>
               </a:spcAft>
               <a:buClr>
                 <a:srgbClr val="2A78D6"/>
@@ -7801,7 +7358,7 @@
               <a:buChar char="•"/>
             </a:pPr>
             <a:r>
-              <a:rPr sz="1700" b="0">
+              <a:rPr sz="1600" b="0">
                 <a:solidFill>
                   <a:srgbClr val="1B2733"/>
                 </a:solidFill>
@@ -7810,7 +7367,7 @@
               <a:t>Refill the </a:t>
             </a:r>
             <a:r>
-              <a:rPr sz="1700" b="1">
+              <a:rPr sz="1600" b="1">
                 <a:solidFill>
                   <a:srgbClr val="1B2733"/>
                 </a:solidFill>
@@ -7822,7 +7379,7 @@
           <a:p>
             <a:pPr marL="285750" indent="-285750">
               <a:spcAft>
-                <a:spcPts val="1000"/>
+                <a:spcPts val="800"/>
               </a:spcAft>
               <a:buClr>
                 <a:srgbClr val="2A78D6"/>
@@ -7831,7 +7388,7 @@
               <a:buChar char="•"/>
             </a:pPr>
             <a:r>
-              <a:rPr sz="1700" b="0">
+              <a:rPr sz="1600" b="0">
                 <a:solidFill>
                   <a:srgbClr val="1B2733"/>
                 </a:solidFill>
@@ -7840,7 +7397,7 @@
               <a:t>Check weekly; worth about </a:t>
             </a:r>
             <a:r>
-              <a:rPr sz="1700" b="1">
+              <a:rPr sz="1600" b="1">
                 <a:solidFill>
                   <a:srgbClr val="1B2733"/>
                 </a:solidFill>
@@ -7978,7 +7535,7 @@
                 </a:solidFill>
                 <a:latin typeface="Cambria"/>
               </a:rPr>
-              <a:t>Test one Colorbuds fix</a:t>
+              <a:t>Test a Colorbuds refresh</a:t>
             </a:r>
           </a:p>
         </p:txBody>
@@ -7991,7 +7548,7 @@
         </p:nvSpPr>
         <p:spPr>
           <a:xfrm>
-            <a:off x="4703978" y="4206240"/>
+            <a:off x="4703978" y="4114800"/>
             <a:ext cx="2783738" cy="1737360"/>
           </a:xfrm>
           <a:prstGeom prst="rect">
@@ -8007,7 +7564,7 @@
           <a:p>
             <a:pPr marL="285750" indent="-285750">
               <a:spcAft>
-                <a:spcPts val="1000"/>
+                <a:spcPts val="800"/>
               </a:spcAft>
               <a:buClr>
                 <a:srgbClr val="2A78D6"/>
@@ -8016,28 +7573,37 @@
               <a:buChar char="•"/>
             </a:pPr>
             <a:r>
-              <a:rPr sz="1700" b="1">
+              <a:rPr sz="1600" b="0">
                 <a:solidFill>
                   <a:srgbClr val="1B2733"/>
                 </a:solidFill>
                 <a:latin typeface="Calibri"/>
               </a:rPr>
-              <a:t>10 test stores</a:t>
-            </a:r>
-            <a:r>
-              <a:rPr sz="1700" b="0">
+              <a:t>Try </a:t>
+            </a:r>
+            <a:r>
+              <a:rPr sz="1600" b="1">
                 <a:solidFill>
                   <a:srgbClr val="1B2733"/>
                 </a:solidFill>
                 <a:latin typeface="Calibri"/>
               </a:rPr>
-              <a:t> vs 10 similar ones</a:t>
+              <a:t>new colors, a bundle with Gamer Headphones</a:t>
+            </a:r>
+            <a:r>
+              <a:rPr sz="1600" b="0">
+                <a:solidFill>
+                  <a:srgbClr val="1B2733"/>
+                </a:solidFill>
+                <a:latin typeface="Calibri"/>
+              </a:rPr>
+              <a:t>, or a better shelf spot</a:t>
             </a:r>
           </a:p>
           <a:p>
             <a:pPr marL="285750" indent="-285750">
               <a:spcAft>
-                <a:spcPts val="1000"/>
+                <a:spcPts val="800"/>
               </a:spcAft>
               <a:buClr>
                 <a:srgbClr val="2A78D6"/>
@@ -8046,31 +7612,31 @@
               <a:buChar char="•"/>
             </a:pPr>
             <a:r>
-              <a:rPr sz="1700" b="0">
+              <a:rPr sz="1600" b="1">
                 <a:solidFill>
                   <a:srgbClr val="1B2733"/>
                 </a:solidFill>
                 <a:latin typeface="Calibri"/>
               </a:rPr>
-              <a:t>Up to about </a:t>
-            </a:r>
-            <a:r>
-              <a:rPr sz="1700" b="1">
+              <a:t>10 test stores</a:t>
+            </a:r>
+            <a:r>
+              <a:rPr sz="1600" b="0">
+                <a:solidFill>
+                  <a:srgbClr val="1B2733"/>
+                </a:solidFill>
+                <a:latin typeface="Calibri"/>
+              </a:rPr>
+              <a:t> vs 10 similar; up to about </a:t>
+            </a:r>
+            <a:r>
+              <a:rPr sz="1600" b="1">
                 <a:solidFill>
                   <a:srgbClr val="1B2733"/>
                 </a:solidFill>
                 <a:latin typeface="Calibri"/>
               </a:rPr>
               <a:t>$11K a month</a:t>
-            </a:r>
-            <a:r>
-              <a:rPr sz="1700" b="0">
-                <a:solidFill>
-                  <a:srgbClr val="1B2733"/>
-                </a:solidFill>
-                <a:latin typeface="Calibri"/>
-              </a:rPr>
-              <a:t> if it works</a:t>
             </a:r>
           </a:p>
         </p:txBody>
@@ -8215,7 +7781,7 @@
         </p:nvSpPr>
         <p:spPr>
           <a:xfrm>
-            <a:off x="8493556" y="4206240"/>
+            <a:off x="8493556" y="4114800"/>
             <a:ext cx="2783738" cy="1737360"/>
           </a:xfrm>
           <a:prstGeom prst="rect">
@@ -8231,7 +7797,7 @@
           <a:p>
             <a:pPr marL="285750" indent="-285750">
               <a:spcAft>
-                <a:spcPts val="1000"/>
+                <a:spcPts val="800"/>
               </a:spcAft>
               <a:buClr>
                 <a:srgbClr val="2A78D6"/>
@@ -8240,7 +7806,7 @@
               <a:buChar char="•"/>
             </a:pPr>
             <a:r>
-              <a:rPr sz="1700" b="1">
+              <a:rPr sz="1600" b="1">
                 <a:solidFill>
                   <a:srgbClr val="1B2733"/>
                 </a:solidFill>
@@ -8249,7 +7815,7 @@
               <a:t>Scale what works</a:t>
             </a:r>
             <a:r>
-              <a:rPr sz="1700" b="0">
+              <a:rPr sz="1600" b="0">
                 <a:solidFill>
                   <a:srgbClr val="1B2733"/>
                 </a:solidFill>
@@ -8261,7 +7827,7 @@
           <a:p>
             <a:pPr marL="285750" indent="-285750">
               <a:spcAft>
-                <a:spcPts val="1000"/>
+                <a:spcPts val="800"/>
               </a:spcAft>
               <a:buClr>
                 <a:srgbClr val="2A78D6"/>
@@ -8270,7 +7836,7 @@
               <a:buChar char="•"/>
             </a:pPr>
             <a:r>
-              <a:rPr sz="1700" b="0">
+              <a:rPr sz="1600" b="0">
                 <a:solidFill>
                   <a:srgbClr val="1B2733"/>
                 </a:solidFill>
@@ -8279,7 +7845,7 @@
               <a:t>Pick the next </a:t>
             </a:r>
             <a:r>
-              <a:rPr sz="1700" b="1">
+              <a:rPr sz="1600" b="1">
                 <a:solidFill>
                   <a:srgbClr val="1B2733"/>
                 </a:solidFill>

</xml_diff>

<commit_message>
Deck slide 2: show Playfoam's rise ($9K to $20K profit, 1,311 to 2,847 units)
Co-Authored-By: Claude Sonnet 5.5 <noreply@anthropic.com>
Claude-Session: https://claude.ai/code/session_01J6v5JYXB5XucuZ66TGAjVJ
</commit_message>
<xml_diff>
--- a/site/deck/Colorbuds_to_Playfoam.pptx
+++ b/site/deck/Colorbuds_to_Playfoam.pptx
@@ -1124,7 +1124,7 @@
           <a:lstStyle/>
           <a:p>
             <a:r>
-              <a:t>Colorbuds earned about 28% of Q3 2022 profit and 13% of Q3 2023 profit; it is still our #1 profit toy, so it is fading, not dead. Playfoam launched in mid-August 2023; at its September pace (2,847 units x $7 profit per unit) it earns about $20K a month. Colorbuds' monthly profit is about $44K lower than in Jan 2022 ((8,110 - 2,594) units x $8). Profit is estimated from current price and cost, not accounting figures.</a:t>
+              <a:t>Colorbuds earned about 28% of Q3 2022 profit and 13% of Q3 2023 profit; it is still our #1 profit toy, so it is fading, not dead. Playfoam launched in mid-August 2023; at its September pace (2,847 units x $7 profit per unit) it earns about $20K a month. August covers only the 17th onward, so the rise is partly a longer month. Colorbuds' monthly profit is about $44K lower than in Jan 2022 ((8,110 - 2,594) units x $8). Profit is estimated from current price and cost, not accounting figures.</a:t>
             </a:r>
           </a:p>
         </p:txBody>
@@ -5157,7 +5157,7 @@
                 </a:solidFill>
                 <a:latin typeface="Cambria"/>
               </a:rPr>
-              <a:t>$20K</a:t>
+              <a:t>$9K → $20K</a:t>
             </a:r>
           </a:p>
         </p:txBody>
@@ -5192,7 +5192,7 @@
                 </a:solidFill>
                 <a:latin typeface="Calibri"/>
               </a:rPr>
-              <a:t>At its September pace</a:t>
+              <a:t>1,311 → 2,847 units sold  |  Aug (from the 17th) to Sep</a:t>
             </a:r>
           </a:p>
         </p:txBody>

</xml_diff>

<commit_message>
Deck: Playfoam weekly units chart (steady since launch); slide 2 no longer implies a monthly jump
Co-Authored-By: Claude Sonnet 5.5 <noreply@anthropic.com>
Claude-Session: https://claude.ai/code/session_01J6v5JYXB5XucuZ66TGAjVJ
</commit_message>
<xml_diff>
--- a/site/deck/Colorbuds_to_Playfoam.pptx
+++ b/site/deck/Colorbuds_to_Playfoam.pptx
@@ -519,39 +519,55 @@
               <a:srgbClr val="1BAF7A"/>
             </a:solidFill>
           </c:spPr>
-          <c:dPt>
-            <c:idx val="0"/>
-            <c:spPr>
-              <a:solidFill>
-                <a:srgbClr val="A5E3CC"/>
-              </a:solidFill>
-            </c:spPr>
-          </c:dPt>
           <c:cat>
             <c:strRef>
-              <c:f>Sheet1!$A$2:$A$3</c:f>
+              <c:f>Sheet1!$A$2:$A$7</c:f>
               <c:strCache>
-                <c:ptCount val="2"/>
+                <c:ptCount val="6"/>
                 <c:pt idx="0">
-                  <c:v>Aug (from the 17th)</c:v>
+                  <c:v>Aug 20</c:v>
                 </c:pt>
                 <c:pt idx="1">
-                  <c:v>Sep</c:v>
+                  <c:v>Aug 27</c:v>
+                </c:pt>
+                <c:pt idx="2">
+                  <c:v>Sep 3</c:v>
+                </c:pt>
+                <c:pt idx="3">
+                  <c:v>Sep 10</c:v>
+                </c:pt>
+                <c:pt idx="4">
+                  <c:v>Sep 17</c:v>
+                </c:pt>
+                <c:pt idx="5">
+                  <c:v>Sep 24</c:v>
                 </c:pt>
               </c:strCache>
             </c:strRef>
           </c:cat>
           <c:val>
             <c:numRef>
-              <c:f>Sheet1!$B$2:$B$3</c:f>
+              <c:f>Sheet1!$B$2:$B$7</c:f>
               <c:numCache>
                 <c:formatCode>General</c:formatCode>
-                <c:ptCount val="2"/>
+                <c:ptCount val="6"/>
                 <c:pt idx="0">
-                  <c:v>1311</c:v>
+                  <c:v>718</c:v>
                 </c:pt>
                 <c:pt idx="1">
-                  <c:v>2847</c:v>
+                  <c:v>722</c:v>
+                </c:pt>
+                <c:pt idx="2">
+                  <c:v>646</c:v>
+                </c:pt>
+                <c:pt idx="3">
+                  <c:v>688</c:v>
+                </c:pt>
+                <c:pt idx="4">
+                  <c:v>679</c:v>
+                </c:pt>
+                <c:pt idx="5">
+                  <c:v>601</c:v>
                 </c:pt>
               </c:numCache>
             </c:numRef>
@@ -564,7 +580,7 @@
             <a:lstStyle/>
             <a:p>
               <a:pPr>
-                <a:defRPr sz="2600" b="1">
+                <a:defRPr sz="2000" b="1">
                   <a:solidFill>
                     <a:srgbClr val="051C2C"/>
                   </a:solidFill>
@@ -582,7 +598,7 @@
           <c:showBubbleSize val="0"/>
           <c:showLeaderLines val="1"/>
         </c:dLbls>
-        <c:gapWidth val="80"/>
+        <c:gapWidth val="45"/>
         <c:axId val="-2068027336"/>
         <c:axId val="-2113994440"/>
       </c:barChart>
@@ -608,7 +624,7 @@
           <a:lstStyle/>
           <a:p>
             <a:pPr>
-              <a:defRPr sz="1500">
+              <a:defRPr sz="1400">
                 <a:solidFill>
                   <a:srgbClr val="5B6470"/>
                 </a:solidFill>
@@ -627,7 +643,7 @@
       <c:valAx>
         <c:axId val="-2113994440"/>
         <c:scaling>
-          <c:max val="3400.0"/>
+          <c:max val="880.0"/>
           <c:min val="0.0"/>
         </c:scaling>
         <c:delete/>
@@ -1124,7 +1140,7 @@
           <a:lstStyle/>
           <a:p>
             <a:r>
-              <a:t>Colorbuds earned about 28% of Q3 2022 profit and 13% of Q3 2023 profit; it is still our #1 profit toy, so it is fading, not dead. Playfoam launched in mid-August 2023; at its September pace (2,847 units x $7 profit per unit) it earns about $20K a month. August covers only the 17th onward, so the rise is partly a longer month. Colorbuds' monthly profit is about $44K lower than in Jan 2022 ((8,110 - 2,594) units x $8). Profit is estimated from current price and cost, not accounting figures.</a:t>
+              <a:t>Colorbuds earned about 28% of Q3 2022 profit and 13% of Q3 2023 profit; it is still our #1 profit toy, so it is fading, not dead. Playfoam launched in mid-August 2023; at its September pace (2,847 units x $7 profit per unit) it earns about $20K a month. Weekly sales have held at roughly 600-720 units for six straight full weeks (no cooling yet); the August-to-September monthly jump is mostly a longer month, so do not call it growth. Colorbuds' monthly profit is about $44K lower than in Jan 2022 ((8,110 - 2,594) units x $8). Profit is estimated from current price and cost, not accounting figures.</a:t>
             </a:r>
           </a:p>
         </p:txBody>
@@ -1334,7 +1350,7 @@
           <a:lstStyle/>
           <a:p>
             <a:r>
-              <a:t>Playfoam launched Aug 17, 2023 and sold 4,158 units in about six weeks (1,311 in August from the 17th, 2,847 in September). It earns $7 per unit at a 64% margin, about $20K a month at the September pace. It is at zero stock in 13 stores; each store sells about 57 units a month, so empty shelves cost roughly $5K a month. It was the #5 profit toy in Q3 2023 despite only ~6 weeks on sale. Be honest: hot now, likely to cool (see the previous slide). Only six weeks of data; the $20K is a run-rate, not a forecast.</a:t>
+              <a:t>Playfoam launched Aug 17, 2023 and sold 4,158 units in about six weeks (1,311 in August from the 17th, 2,847 in September). Full weeks since launch: [718, 722, 646, 688, 679, 601], so demand is steady, not rising or fading yet. It earns $7 per unit at a 64% margin, about $20K a month at the September pace. It is at zero stock in 13 stores; each store sells about 57 units a month, so empty shelves cost roughly $5K a month. It was the #5 profit toy in Q3 2023 despite only ~6 weeks on sale. Be honest: hot now, likely to cool (see the previous slide). Only six weeks of data; the $20K is a run-rate, not a forecast.</a:t>
             </a:r>
           </a:p>
         </p:txBody>
@@ -5157,7 +5173,7 @@
                 </a:solidFill>
                 <a:latin typeface="Cambria"/>
               </a:rPr>
-              <a:t>$9K → $20K</a:t>
+              <a:t>$20K</a:t>
             </a:r>
           </a:p>
         </p:txBody>
@@ -5192,7 +5208,7 @@
                 </a:solidFill>
                 <a:latin typeface="Calibri"/>
               </a:rPr>
-              <a:t>1,311 → 2,847 units sold  |  Aug (from the 17th) to Sep</a:t>
+              <a:t>~680 units a week, six weeks running</a:t>
             </a:r>
           </a:p>
         </p:txBody>
@@ -6728,14 +6744,14 @@
                 </a:solidFill>
                 <a:latin typeface="Calibri"/>
               </a:rPr>
-              <a:t>PLAYFOAM UNITS SOLD PER MONTH</a:t>
+              <a:t>PLAYFOAM UNITS SOLD PER WEEK (WEEK STARTING)</a:t>
             </a:r>
           </a:p>
         </p:txBody>
       </p:sp>
       <p:graphicFrame>
         <p:nvGraphicFramePr>
-          <p:cNvPr id="6" name="Playfoam monthly units"/>
+          <p:cNvPr id="6" name="Playfoam weekly units"/>
           <p:cNvGraphicFramePr>
             <a:graphicFrameLocks noGrp="1"/>
           </p:cNvGraphicFramePr>
@@ -7012,22 +7028,22 @@
               <a:buChar char="•"/>
             </a:pPr>
             <a:r>
-              <a:rPr sz="1800" b="0">
+              <a:rPr sz="1800" b="1">
                 <a:solidFill>
                   <a:srgbClr val="1B2733"/>
                 </a:solidFill>
                 <a:latin typeface="Calibri"/>
               </a:rPr>
-              <a:t>Launched Aug 17 and already a </a:t>
-            </a:r>
-            <a:r>
-              <a:rPr sz="1800" b="1">
+              <a:t>~680 units a week</a:t>
+            </a:r>
+            <a:r>
+              <a:rPr sz="1800" b="0">
                 <a:solidFill>
                   <a:srgbClr val="1B2733"/>
                 </a:solidFill>
                 <a:latin typeface="Calibri"/>
               </a:rPr>
-              <a:t>top-5 profit toy</a:t>
+              <a:t>, every week since launch, with no cooling yet</a:t>
             </a:r>
           </a:p>
           <a:p>

</xml_diff>

<commit_message>
Deck: frame Playfoam by profit rank (#2 of 35) instead of raw units
Co-Authored-By: Claude Sonnet 5.5 <noreply@anthropic.com>
Claude-Session: https://claude.ai/code/session_01J6v5JYXB5XucuZ66TGAjVJ
</commit_message>
<xml_diff>
--- a/site/deck/Colorbuds_to_Playfoam.pptx
+++ b/site/deck/Colorbuds_to_Playfoam.pptx
@@ -498,7 +498,7 @@
     <c:autoTitleDeleted val="1"/>
     <c:plotArea>
       <c:barChart>
-        <c:barDir val="col"/>
+        <c:barDir val="bar"/>
         <c:grouping val="clustered"/>
         <c:ser>
           <c:idx val="0"/>
@@ -509,72 +509,74 @@
               <c:strCache>
                 <c:ptCount val="1"/>
                 <c:pt idx="0">
-                  <c:v>Playfoam units</c:v>
+                  <c:v>Profit</c:v>
                 </c:pt>
               </c:strCache>
             </c:strRef>
           </c:tx>
           <c:spPr>
             <a:solidFill>
-              <a:srgbClr val="1BAF7A"/>
+              <a:srgbClr val="D0D5DD"/>
             </a:solidFill>
           </c:spPr>
+          <c:dPt>
+            <c:idx val="1"/>
+            <c:spPr>
+              <a:solidFill>
+                <a:srgbClr val="1BAF7A"/>
+              </a:solidFill>
+            </c:spPr>
+          </c:dPt>
           <c:cat>
             <c:strRef>
-              <c:f>Sheet1!$A$2:$A$7</c:f>
+              <c:f>Sheet1!$A$2:$A$6</c:f>
               <c:strCache>
-                <c:ptCount val="6"/>
+                <c:ptCount val="5"/>
                 <c:pt idx="0">
-                  <c:v>Aug 20</c:v>
+                  <c:v>Colorbuds</c:v>
                 </c:pt>
                 <c:pt idx="1">
-                  <c:v>Aug 27</c:v>
+                  <c:v>Playfoam</c:v>
                 </c:pt>
                 <c:pt idx="2">
-                  <c:v>Sep 3</c:v>
+                  <c:v>Lego Bricks</c:v>
                 </c:pt>
                 <c:pt idx="3">
-                  <c:v>Sep 10</c:v>
+                  <c:v>Action Figure</c:v>
                 </c:pt>
                 <c:pt idx="4">
-                  <c:v>Sep 17</c:v>
-                </c:pt>
-                <c:pt idx="5">
-                  <c:v>Sep 24</c:v>
+                  <c:v>Nerf Gun</c:v>
                 </c:pt>
               </c:strCache>
             </c:strRef>
           </c:cat>
           <c:val>
             <c:numRef>
-              <c:f>Sheet1!$B$2:$B$7</c:f>
+              <c:f>Sheet1!$B$2:$B$6</c:f>
               <c:numCache>
                 <c:formatCode>General</c:formatCode>
-                <c:ptCount val="6"/>
+                <c:ptCount val="5"/>
                 <c:pt idx="0">
-                  <c:v>718</c:v>
+                  <c:v>30416.0</c:v>
                 </c:pt>
                 <c:pt idx="1">
-                  <c:v>722</c:v>
+                  <c:v>28378.0</c:v>
                 </c:pt>
                 <c:pt idx="2">
-                  <c:v>646</c:v>
+                  <c:v>15625.0</c:v>
                 </c:pt>
                 <c:pt idx="3">
-                  <c:v>688</c:v>
+                  <c:v>13908.0</c:v>
                 </c:pt>
                 <c:pt idx="4">
-                  <c:v>679</c:v>
-                </c:pt>
-                <c:pt idx="5">
-                  <c:v>601</c:v>
+                  <c:v>12914.999999999995</c:v>
                 </c:pt>
               </c:numCache>
             </c:numRef>
           </c:val>
         </c:ser>
         <c:dLbls>
-          <c:numFmt formatCode="#,##0" sourceLinked="0"/>
+          <c:numFmt formatCode="$#,##0,&quot;K&quot;" sourceLinked="0"/>
           <c:txPr>
             <a:bodyPr/>
             <a:lstStyle/>
@@ -605,10 +607,10 @@
       <c:catAx>
         <c:axId val="-2068027336"/>
         <c:scaling>
-          <c:orientation val="minMax"/>
+          <c:orientation val="maxMin"/>
         </c:scaling>
         <c:delete val="0"/>
-        <c:axPos val="b"/>
+        <c:axPos val="l"/>
         <c:majorTickMark val="out"/>
         <c:minorTickMark val="none"/>
         <c:tickLblPos val="nextTo"/>
@@ -624,9 +626,9 @@
           <a:lstStyle/>
           <a:p>
             <a:pPr>
-              <a:defRPr sz="1400">
-                <a:solidFill>
-                  <a:srgbClr val="5B6470"/>
+              <a:defRPr sz="1600">
+                <a:solidFill>
+                  <a:srgbClr val="1B2733"/>
                 </a:solidFill>
                 <a:latin typeface="Calibri"/>
               </a:defRPr>
@@ -643,11 +645,11 @@
       <c:valAx>
         <c:axId val="-2113994440"/>
         <c:scaling>
-          <c:max val="880.0"/>
+          <c:max val="37000.0"/>
           <c:min val="0.0"/>
         </c:scaling>
         <c:delete/>
-        <c:axPos val="l"/>
+        <c:axPos val="b"/>
         <c:majorTickMark val="out"/>
         <c:minorTickMark val="none"/>
         <c:tickLblPos val="nextTo"/>
@@ -1350,7 +1352,7 @@
           <a:lstStyle/>
           <a:p>
             <a:r>
-              <a:t>Playfoam launched Aug 17, 2023 and sold 4,158 units in about six weeks (1,311 in August from the 17th, 2,847 in September). Full weeks since launch: [718, 722, 646, 688, 679, 601], so demand is steady, not rising or fading yet. It earns $7 per unit at a 64% margin, about $20K a month at the September pace. It is at zero stock in 13 stores; each store sells about 57 units a month, so empty shelves cost roughly $5K a month. It was the #5 profit toy in Q3 2023 despite only ~6 weeks on sale. Be honest: hot now, likely to cool (see the previous slide). Only six weeks of data; the $20K is a run-rate, not a forecast.</a:t>
+              <a:t>Playfoam launched Aug 17, 2023 and sold 4,158 units in about six weeks (1,311 in August from the 17th, 2,847 in September). Estimated profit, first six full weeks (Aug 20 - Sep 30): Playfoam $28K vs Colorbuds $30K, #2 of 35 toys, and #1 in 2 of the 6 weeks. Weekly units were flat at about 680 ([718, 722, 646, 688, 679, 601]): steady, not rising or fading yet. It earns $7 per unit at a 64% margin, about $20K a month at the September pace. It is at zero stock in 13 stores; each store sells about 57 units a month, so empty shelves cost roughly $5K a month. It was the #5 profit toy in Q3 2023 despite only ~6 weeks on sale. Be honest: hot now, likely to cool (see the previous slide). Only six weeks of data; the $20K is a run-rate, not a forecast.</a:t>
             </a:r>
           </a:p>
         </p:txBody>
@@ -5138,7 +5140,7 @@
                 </a:solidFill>
                 <a:latin typeface="Calibri"/>
               </a:rPr>
-              <a:t>PLAYFOAM PROFIT PER MONTH</a:t>
+              <a:t>PLAYFOAM'S RANK AMONG ALL TOYS BY PROFIT</a:t>
             </a:r>
           </a:p>
         </p:txBody>
@@ -5173,7 +5175,7 @@
                 </a:solidFill>
                 <a:latin typeface="Cambria"/>
               </a:rPr>
-              <a:t>$20K</a:t>
+              <a:t>#2 of 35</a:t>
             </a:r>
           </a:p>
         </p:txBody>
@@ -5208,7 +5210,7 @@
                 </a:solidFill>
                 <a:latin typeface="Calibri"/>
               </a:rPr>
-              <a:t>~680 units a week, six weeks running</a:t>
+              <a:t>Behind only Colorbuds, in its first six full weeks on sale</a:t>
             </a:r>
           </a:p>
         </p:txBody>
@@ -5300,7 +5302,7 @@
                 </a:solidFill>
                 <a:latin typeface="Calibri"/>
               </a:rPr>
-              <a:t>Playfoam launched in mid-August and is already a </a:t>
+              <a:t>Playfoam launched in mid-August and is already our </a:t>
             </a:r>
             <a:r>
               <a:rPr sz="2000" b="1">
@@ -5309,7 +5311,7 @@
                 </a:solidFill>
                 <a:latin typeface="Calibri"/>
               </a:rPr>
-              <a:t>top-5 profit toy</a:t>
+              <a:t>#2 profit toy</a:t>
             </a:r>
           </a:p>
           <a:p>
@@ -5330,7 +5332,7 @@
                 </a:solidFill>
                 <a:latin typeface="Calibri"/>
               </a:rPr>
-              <a:t>Playfoam's September pace is </a:t>
+              <a:t>Playfoam earns about </a:t>
             </a:r>
             <a:r>
               <a:rPr sz="2000" b="1">
@@ -5339,7 +5341,7 @@
                 </a:solidFill>
                 <a:latin typeface="Calibri"/>
               </a:rPr>
-              <a:t>nearly half</a:t>
+              <a:t>$20K a month</a:t>
             </a:r>
             <a:r>
               <a:rPr sz="2000" b="0">
@@ -5348,7 +5350,7 @@
                 </a:solidFill>
                 <a:latin typeface="Calibri"/>
               </a:rPr>
-              <a:t> of the $44K a month Colorbuds has lost</a:t>
+              <a:t>, nearly half of the $44K Colorbuds has lost</a:t>
             </a:r>
           </a:p>
         </p:txBody>
@@ -6723,7 +6725,7 @@
         <p:spPr>
           <a:xfrm>
             <a:off x="548640" y="1691640"/>
-            <a:ext cx="5486400" cy="274320"/>
+            <a:ext cx="5852160" cy="274320"/>
           </a:xfrm>
           <a:prstGeom prst="rect">
             <a:avLst/>
@@ -6744,14 +6746,14 @@
                 </a:solidFill>
                 <a:latin typeface="Calibri"/>
               </a:rPr>
-              <a:t>PLAYFOAM UNITS SOLD PER WEEK (WEEK STARTING)</a:t>
+              <a:t>ESTIMATED PROFIT BY TOY, LAST SIX FULL WEEKS (AUG 20 - SEP 30)</a:t>
             </a:r>
           </a:p>
         </p:txBody>
       </p:sp>
       <p:graphicFrame>
         <p:nvGraphicFramePr>
-          <p:cNvPr id="6" name="Playfoam weekly units"/>
+          <p:cNvPr id="6" name="Top 5 toys by profit since Playfoam launched"/>
           <p:cNvGraphicFramePr>
             <a:graphicFrameLocks noGrp="1"/>
           </p:cNvGraphicFramePr>
@@ -7034,7 +7036,7 @@
                 </a:solidFill>
                 <a:latin typeface="Calibri"/>
               </a:rPr>
-              <a:t>~680 units a week</a:t>
+              <a:t>#1 profit toy in 2 of 6 weeks</a:t>
             </a:r>
             <a:r>
               <a:rPr sz="1800" b="0">
@@ -7043,7 +7045,7 @@
                 </a:solidFill>
                 <a:latin typeface="Calibri"/>
               </a:rPr>
-              <a:t>, every week since launch, with no cooling yet</a:t>
+              <a:t>, ahead of Colorbuds</a:t>
             </a:r>
           </a:p>
           <a:p>

</xml_diff>

<commit_message>
Deck slide 6: clearer goals, plain-language gains, pilot explained, extra review bullet
Co-Authored-By: Claude Sonnet 5.5 <noreply@anthropic.com>
Claude-Session: https://claude.ai/code/session_01J6v5JYXB5XucuZ66TGAjVJ
</commit_message>
<xml_diff>
--- a/site/deck/Colorbuds_to_Playfoam.pptx
+++ b/site/deck/Colorbuds_to_Playfoam.pptx
@@ -1422,7 +1422,7 @@
           <a:lstStyle/>
           <a:p>
             <a:r>
-              <a:t>1) Keep Playfoam in stock: refill the 13 stores at zero and keep every store above about two weeks of sales (roughly 26 units a store); check weekly. Worth about $5K a month now. 2) Test a Colorbuds refresh: the options to try are new colors, a bundle with Gamer Headphones, or a better shelf spot, in about 10 stores against 10 similar control stores for six weeks. Winning back a quarter of the lost sales is worth up to about $11K a month. 3) Review at week 8: if the test stores sold about 15% more Colorbuds, scale the fix; if not, stop. Pick the next newer, higher-margin toy to back at the same review. The 15% threshold is a suggestion to agree on in advance, not something from the data. Sizes are estimates; the data cannot show why Colorbuds fell.</a:t>
+              <a:t>1) Keep Playfoam in stock: refill the 13 stores that have zero, and keep every store above about two weeks of sales (roughly 26 units a store); check weekly. Each store sells about 57 Playfoam units a month at $7 profit, so 13 stores is about $5K a month. 2) Test a Colorbuds fix: the options to try are new colors, a bundle with Gamer Headphones, or a better shelf spot. Run it in 10 stores and compare against 10 similar stores that change nothing, for about six weeks, so we learn what works before spending chain-wide. Winning back a quarter of the lost sales (about $44K a month lost, so about $11K) is the prize if it works. 3) Review at week 8: if the pilot stores sold about 15% more Colorbuds than the comparison stores, scale the fix; if not, stop. Also check whether Playfoam is holding its weekly sales, and pick the next newer, higher-margin toy to back. The 15% threshold is a suggestion to agree on in advance, not something from the data. Sizes are estimates; the data cannot show why Colorbuds fell.</a:t>
             </a:r>
           </a:p>
         </p:txBody>
@@ -7136,7 +7136,7 @@
                 </a:solidFill>
                 <a:latin typeface="Cambria"/>
               </a:rPr>
-              <a:t>We recommend three moves: back newer, higher-margin toys, test a Colorbuds refresh, and review in 8 weeks</a:t>
+              <a:t>Next 8 weeks: keep Playfoam on shelves, test a Colorbuds fix, then back what works</a:t>
             </a:r>
           </a:p>
         </p:txBody>
@@ -7219,8 +7219,8 @@
         </p:nvSpPr>
         <p:spPr>
           <a:xfrm>
-            <a:off x="548640" y="1783080"/>
-            <a:ext cx="3515258" cy="3977639"/>
+            <a:off x="548640" y="1691640"/>
+            <a:ext cx="3515258" cy="4434840"/>
           </a:xfrm>
           <a:prstGeom prst="rect">
             <a:avLst/>
@@ -7263,8 +7263,8 @@
         </p:nvSpPr>
         <p:spPr>
           <a:xfrm>
-            <a:off x="914400" y="2103120"/>
-            <a:ext cx="640080" cy="640080"/>
+            <a:off x="914400" y="1920240"/>
+            <a:ext cx="548640" cy="548640"/>
           </a:xfrm>
           <a:prstGeom prst="rect">
             <a:avLst/>
@@ -7297,7 +7297,7 @@
           <a:p>
             <a:pPr algn="ctr"/>
             <a:r>
-              <a:rPr sz="2800" b="1">
+              <a:rPr sz="2400" b="1">
                 <a:solidFill>
                   <a:srgbClr val="FFFFFF"/>
                 </a:solidFill>
@@ -7316,8 +7316,8 @@
         </p:nvSpPr>
         <p:spPr>
           <a:xfrm>
-            <a:off x="914400" y="3017520"/>
-            <a:ext cx="2783738" cy="1005840"/>
+            <a:off x="914400" y="2606040"/>
+            <a:ext cx="2783738" cy="457200"/>
           </a:xfrm>
           <a:prstGeom prst="rect">
             <a:avLst/>
@@ -7332,27 +7332,62 @@
           <a:p>
             <a:pPr algn="l"/>
             <a:r>
-              <a:rPr sz="2400" b="1">
+              <a:rPr sz="2200" b="1">
                 <a:solidFill>
                   <a:srgbClr val="051C2C"/>
                 </a:solidFill>
                 <a:latin typeface="Cambria"/>
               </a:rPr>
-              <a:t>Keep Playfoam in stock</a:t>
-            </a:r>
-          </a:p>
-        </p:txBody>
-      </p:sp>
-      <p:sp>
-        <p:nvSpPr>
-          <p:cNvPr id="8" name="Step 1 details"/>
+              <a:t>Restock Playfoam</a:t>
+            </a:r>
+          </a:p>
+        </p:txBody>
+      </p:sp>
+      <p:sp>
+        <p:nvSpPr>
+          <p:cNvPr id="8" name="Goal 1"/>
           <p:cNvSpPr txBox="1"/>
           <p:nvPr/>
         </p:nvSpPr>
         <p:spPr>
           <a:xfrm>
-            <a:off x="914400" y="4114800"/>
-            <a:ext cx="2783738" cy="1737360"/>
+            <a:off x="914400" y="3108960"/>
+            <a:ext cx="2783738" cy="640080"/>
+          </a:xfrm>
+          <a:prstGeom prst="rect">
+            <a:avLst/>
+          </a:prstGeom>
+          <a:noFill/>
+        </p:spPr>
+        <p:txBody>
+          <a:bodyPr wrap="square" lIns="0" rIns="0" tIns="0" bIns="0" anchor="t">
+            <a:spAutoFit/>
+          </a:bodyPr>
+          <a:lstStyle/>
+          <a:p>
+            <a:pPr algn="l"/>
+            <a:r>
+              <a:rPr sz="1500" b="1">
+                <a:solidFill>
+                  <a:srgbClr val="0E8F63"/>
+                </a:solidFill>
+                <a:latin typeface="Calibri"/>
+              </a:rPr>
+              <a:t>Goal: stop losing Playfoam sales to empty shelves</a:t>
+            </a:r>
+          </a:p>
+        </p:txBody>
+      </p:sp>
+      <p:sp>
+        <p:nvSpPr>
+          <p:cNvPr id="9" name="Step 1 details"/>
+          <p:cNvSpPr txBox="1"/>
+          <p:nvPr/>
+        </p:nvSpPr>
+        <p:spPr>
+          <a:xfrm>
+            <a:off x="914400" y="3840480"/>
+            <a:ext cx="2783738" cy="2194560"/>
           </a:xfrm>
           <a:prstGeom prst="rect">
             <a:avLst/>
@@ -7376,7 +7411,7 @@
               <a:buChar char="•"/>
             </a:pPr>
             <a:r>
-              <a:rPr sz="1600" b="0">
+              <a:rPr sz="1500" b="0">
                 <a:solidFill>
                   <a:srgbClr val="1B2733"/>
                 </a:solidFill>
@@ -7385,13 +7420,22 @@
               <a:t>Refill the </a:t>
             </a:r>
             <a:r>
-              <a:rPr sz="1600" b="1">
+              <a:rPr sz="1500" b="1">
                 <a:solidFill>
                   <a:srgbClr val="1B2733"/>
                 </a:solidFill>
                 <a:latin typeface="Calibri"/>
               </a:rPr>
-              <a:t>13 empty stores</a:t>
+              <a:t>13 stores</a:t>
+            </a:r>
+            <a:r>
+              <a:rPr sz="1500" b="0">
+                <a:solidFill>
+                  <a:srgbClr val="1B2733"/>
+                </a:solidFill>
+                <a:latin typeface="Calibri"/>
+              </a:rPr>
+              <a:t> that have none</a:t>
             </a:r>
           </a:p>
           <a:p>
@@ -7406,36 +7450,66 @@
               <a:buChar char="•"/>
             </a:pPr>
             <a:r>
-              <a:rPr sz="1600" b="0">
+              <a:rPr sz="1500" b="0">
                 <a:solidFill>
                   <a:srgbClr val="1B2733"/>
                 </a:solidFill>
                 <a:latin typeface="Calibri"/>
               </a:rPr>
-              <a:t>Check weekly; worth about </a:t>
-            </a:r>
-            <a:r>
-              <a:rPr sz="1600" b="1">
+              <a:t>Gain: about </a:t>
+            </a:r>
+            <a:r>
+              <a:rPr sz="1500" b="1">
                 <a:solidFill>
                   <a:srgbClr val="1B2733"/>
                 </a:solidFill>
                 <a:latin typeface="Calibri"/>
               </a:rPr>
-              <a:t>$5K a month</a:t>
-            </a:r>
-          </a:p>
-        </p:txBody>
-      </p:sp>
-      <p:sp>
-        <p:nvSpPr>
-          <p:cNvPr id="9" name="Panel 2"/>
+              <a:t>$5K more profit a month</a:t>
+            </a:r>
+          </a:p>
+          <a:p>
+            <a:pPr marL="285750" indent="-285750">
+              <a:spcAft>
+                <a:spcPts val="800"/>
+              </a:spcAft>
+              <a:buClr>
+                <a:srgbClr val="2A78D6"/>
+              </a:buClr>
+              <a:buFont typeface="Arial"/>
+              <a:buChar char="•"/>
+            </a:pPr>
+            <a:r>
+              <a:rPr sz="1500" b="0">
+                <a:solidFill>
+                  <a:srgbClr val="1B2733"/>
+                </a:solidFill>
+                <a:latin typeface="Calibri"/>
+              </a:rPr>
+              <a:t>Check stock </a:t>
+            </a:r>
+            <a:r>
+              <a:rPr sz="1500" b="1">
+                <a:solidFill>
+                  <a:srgbClr val="1B2733"/>
+                </a:solidFill>
+                <a:latin typeface="Calibri"/>
+              </a:rPr>
+              <a:t>every week</a:t>
+            </a:r>
+          </a:p>
+        </p:txBody>
+      </p:sp>
+      <p:sp>
+        <p:nvSpPr>
+          <p:cNvPr id="10" name="Panel 2"/>
           <p:cNvSpPr/>
           <p:nvPr/>
         </p:nvSpPr>
         <p:spPr>
           <a:xfrm>
-            <a:off x="4338218" y="1783080"/>
-            <a:ext cx="3515258" cy="3977639"/>
+            <a:off x="4338218" y="1691640"/>
+            <a:ext cx="3515258" cy="4434840"/>
           </a:xfrm>
           <a:prstGeom prst="rect">
             <a:avLst/>
@@ -7472,14 +7546,14 @@
       </p:sp>
       <p:sp>
         <p:nvSpPr>
-          <p:cNvPr id="10" name="Number 2"/>
+          <p:cNvPr id="11" name="Number 2"/>
           <p:cNvSpPr/>
           <p:nvPr/>
         </p:nvSpPr>
         <p:spPr>
           <a:xfrm>
-            <a:off x="4703978" y="2103120"/>
-            <a:ext cx="640080" cy="640080"/>
+            <a:off x="4703978" y="1920240"/>
+            <a:ext cx="548640" cy="548640"/>
           </a:xfrm>
           <a:prstGeom prst="rect">
             <a:avLst/>
@@ -7512,7 +7586,7 @@
           <a:p>
             <a:pPr algn="ctr"/>
             <a:r>
-              <a:rPr sz="2800" b="1">
+              <a:rPr sz="2400" b="1">
                 <a:solidFill>
                   <a:srgbClr val="FFFFFF"/>
                 </a:solidFill>
@@ -7525,14 +7599,14 @@
       </p:sp>
       <p:sp>
         <p:nvSpPr>
-          <p:cNvPr id="11" name="Step 2"/>
+          <p:cNvPr id="12" name="Step 2"/>
           <p:cNvSpPr txBox="1"/>
           <p:nvPr/>
         </p:nvSpPr>
         <p:spPr>
           <a:xfrm>
-            <a:off x="4703978" y="3017520"/>
-            <a:ext cx="2783738" cy="1005840"/>
+            <a:off x="4703978" y="2606040"/>
+            <a:ext cx="2783738" cy="457200"/>
           </a:xfrm>
           <a:prstGeom prst="rect">
             <a:avLst/>
@@ -7547,27 +7621,62 @@
           <a:p>
             <a:pPr algn="l"/>
             <a:r>
-              <a:rPr sz="2400" b="1">
+              <a:rPr sz="2200" b="1">
                 <a:solidFill>
                   <a:srgbClr val="051C2C"/>
                 </a:solidFill>
                 <a:latin typeface="Cambria"/>
               </a:rPr>
-              <a:t>Test a Colorbuds refresh</a:t>
-            </a:r>
-          </a:p>
-        </p:txBody>
-      </p:sp>
-      <p:sp>
-        <p:nvSpPr>
-          <p:cNvPr id="12" name="Step 2 details"/>
+              <a:t>Test a Colorbuds fix</a:t>
+            </a:r>
+          </a:p>
+        </p:txBody>
+      </p:sp>
+      <p:sp>
+        <p:nvSpPr>
+          <p:cNvPr id="13" name="Goal 2"/>
           <p:cNvSpPr txBox="1"/>
           <p:nvPr/>
         </p:nvSpPr>
         <p:spPr>
           <a:xfrm>
-            <a:off x="4703978" y="4114800"/>
-            <a:ext cx="2783738" cy="1737360"/>
+            <a:off x="4703978" y="3108960"/>
+            <a:ext cx="2783738" cy="640080"/>
+          </a:xfrm>
+          <a:prstGeom prst="rect">
+            <a:avLst/>
+          </a:prstGeom>
+          <a:noFill/>
+        </p:spPr>
+        <p:txBody>
+          <a:bodyPr wrap="square" lIns="0" rIns="0" tIns="0" bIns="0" anchor="t">
+            <a:spAutoFit/>
+          </a:bodyPr>
+          <a:lstStyle/>
+          <a:p>
+            <a:pPr algn="l"/>
+            <a:r>
+              <a:rPr sz="1500" b="1">
+                <a:solidFill>
+                  <a:srgbClr val="D6336C"/>
+                </a:solidFill>
+                <a:latin typeface="Calibri"/>
+              </a:rPr>
+              <a:t>Goal: win back some of the lost Colorbuds sales</a:t>
+            </a:r>
+          </a:p>
+        </p:txBody>
+      </p:sp>
+      <p:sp>
+        <p:nvSpPr>
+          <p:cNvPr id="14" name="Step 2 details"/>
+          <p:cNvSpPr txBox="1"/>
+          <p:nvPr/>
+        </p:nvSpPr>
+        <p:spPr>
+          <a:xfrm>
+            <a:off x="4703978" y="3840480"/>
+            <a:ext cx="2783738" cy="2194560"/>
           </a:xfrm>
           <a:prstGeom prst="rect">
             <a:avLst/>
@@ -7591,7 +7700,7 @@
               <a:buChar char="•"/>
             </a:pPr>
             <a:r>
-              <a:rPr sz="1600" b="0">
+              <a:rPr sz="1500" b="0">
                 <a:solidFill>
                   <a:srgbClr val="1B2733"/>
                 </a:solidFill>
@@ -7600,22 +7709,49 @@
               <a:t>Try </a:t>
             </a:r>
             <a:r>
-              <a:rPr sz="1600" b="1">
+              <a:rPr sz="1500" b="1">
                 <a:solidFill>
                   <a:srgbClr val="1B2733"/>
                 </a:solidFill>
                 <a:latin typeface="Calibri"/>
               </a:rPr>
-              <a:t>new colors, a bundle with Gamer Headphones</a:t>
-            </a:r>
-            <a:r>
-              <a:rPr sz="1600" b="0">
+              <a:t>new colors</a:t>
+            </a:r>
+            <a:r>
+              <a:rPr sz="1500" b="0">
                 <a:solidFill>
                   <a:srgbClr val="1B2733"/>
                 </a:solidFill>
                 <a:latin typeface="Calibri"/>
               </a:rPr>
-              <a:t>, or a better shelf spot</a:t>
+              <a:t>, a </a:t>
+            </a:r>
+            <a:r>
+              <a:rPr sz="1500" b="1">
+                <a:solidFill>
+                  <a:srgbClr val="1B2733"/>
+                </a:solidFill>
+                <a:latin typeface="Calibri"/>
+              </a:rPr>
+              <a:t>bundle with Gamer Headphones</a:t>
+            </a:r>
+            <a:r>
+              <a:rPr sz="1500" b="0">
+                <a:solidFill>
+                  <a:srgbClr val="1B2733"/>
+                </a:solidFill>
+                <a:latin typeface="Calibri"/>
+              </a:rPr>
+              <a:t>, or a </a:t>
+            </a:r>
+            <a:r>
+              <a:rPr sz="1500" b="1">
+                <a:solidFill>
+                  <a:srgbClr val="1B2733"/>
+                </a:solidFill>
+                <a:latin typeface="Calibri"/>
+              </a:rPr>
+              <a:t>better shelf spot</a:t>
             </a:r>
           </a:p>
           <a:p>
@@ -7630,45 +7766,75 @@
               <a:buChar char="•"/>
             </a:pPr>
             <a:r>
-              <a:rPr sz="1600" b="1">
+              <a:rPr sz="1500" b="0">
                 <a:solidFill>
                   <a:srgbClr val="1B2733"/>
                 </a:solidFill>
                 <a:latin typeface="Calibri"/>
               </a:rPr>
-              <a:t>10 test stores</a:t>
-            </a:r>
-            <a:r>
-              <a:rPr sz="1600" b="0">
+              <a:t>Pilot in </a:t>
+            </a:r>
+            <a:r>
+              <a:rPr sz="1500" b="1">
                 <a:solidFill>
                   <a:srgbClr val="1B2733"/>
                 </a:solidFill>
                 <a:latin typeface="Calibri"/>
               </a:rPr>
-              <a:t> vs 10 similar; up to about </a:t>
-            </a:r>
-            <a:r>
-              <a:rPr sz="1600" b="1">
+              <a:t>10 stores</a:t>
+            </a:r>
+            <a:r>
+              <a:rPr sz="1500" b="0">
                 <a:solidFill>
                   <a:srgbClr val="1B2733"/>
                 </a:solidFill>
                 <a:latin typeface="Calibri"/>
               </a:rPr>
-              <a:t>$11K a month</a:t>
-            </a:r>
-          </a:p>
-        </p:txBody>
-      </p:sp>
-      <p:sp>
-        <p:nvSpPr>
-          <p:cNvPr id="13" name="Panel 3"/>
+              <a:t> vs 10 similar stores that change nothing</a:t>
+            </a:r>
+          </a:p>
+          <a:p>
+            <a:pPr marL="285750" indent="-285750">
+              <a:spcAft>
+                <a:spcPts val="800"/>
+              </a:spcAft>
+              <a:buClr>
+                <a:srgbClr val="2A78D6"/>
+              </a:buClr>
+              <a:buFont typeface="Arial"/>
+              <a:buChar char="•"/>
+            </a:pPr>
+            <a:r>
+              <a:rPr sz="1500" b="0">
+                <a:solidFill>
+                  <a:srgbClr val="1B2733"/>
+                </a:solidFill>
+                <a:latin typeface="Calibri"/>
+              </a:rPr>
+              <a:t>Prize: a quarter of lost sales back is </a:t>
+            </a:r>
+            <a:r>
+              <a:rPr sz="1500" b="1">
+                <a:solidFill>
+                  <a:srgbClr val="1B2733"/>
+                </a:solidFill>
+                <a:latin typeface="Calibri"/>
+              </a:rPr>
+              <a:t>$11K more profit a month</a:t>
+            </a:r>
+          </a:p>
+        </p:txBody>
+      </p:sp>
+      <p:sp>
+        <p:nvSpPr>
+          <p:cNvPr id="15" name="Panel 3"/>
           <p:cNvSpPr/>
           <p:nvPr/>
         </p:nvSpPr>
         <p:spPr>
           <a:xfrm>
-            <a:off x="8127796" y="1783080"/>
-            <a:ext cx="3515258" cy="3977639"/>
+            <a:off x="8127796" y="1691640"/>
+            <a:ext cx="3515258" cy="4434840"/>
           </a:xfrm>
           <a:prstGeom prst="rect">
             <a:avLst/>
@@ -7705,14 +7871,14 @@
       </p:sp>
       <p:sp>
         <p:nvSpPr>
-          <p:cNvPr id="14" name="Number 3"/>
+          <p:cNvPr id="16" name="Number 3"/>
           <p:cNvSpPr/>
           <p:nvPr/>
         </p:nvSpPr>
         <p:spPr>
           <a:xfrm>
-            <a:off x="8493556" y="2103120"/>
-            <a:ext cx="640080" cy="640080"/>
+            <a:off x="8493556" y="1920240"/>
+            <a:ext cx="548640" cy="548640"/>
           </a:xfrm>
           <a:prstGeom prst="rect">
             <a:avLst/>
@@ -7745,7 +7911,7 @@
           <a:p>
             <a:pPr algn="ctr"/>
             <a:r>
-              <a:rPr sz="2800" b="1">
+              <a:rPr sz="2400" b="1">
                 <a:solidFill>
                   <a:srgbClr val="FFFFFF"/>
                 </a:solidFill>
@@ -7758,14 +7924,14 @@
       </p:sp>
       <p:sp>
         <p:nvSpPr>
-          <p:cNvPr id="15" name="Step 3"/>
+          <p:cNvPr id="17" name="Step 3"/>
           <p:cNvSpPr txBox="1"/>
           <p:nvPr/>
         </p:nvSpPr>
         <p:spPr>
           <a:xfrm>
-            <a:off x="8493556" y="3017520"/>
-            <a:ext cx="2783738" cy="1005840"/>
+            <a:off x="8493556" y="2606040"/>
+            <a:ext cx="2783738" cy="457200"/>
           </a:xfrm>
           <a:prstGeom prst="rect">
             <a:avLst/>
@@ -7780,7 +7946,7 @@
           <a:p>
             <a:pPr algn="l"/>
             <a:r>
-              <a:rPr sz="2400" b="1">
+              <a:rPr sz="2200" b="1">
                 <a:solidFill>
                   <a:srgbClr val="051C2C"/>
                 </a:solidFill>
@@ -7793,14 +7959,49 @@
       </p:sp>
       <p:sp>
         <p:nvSpPr>
-          <p:cNvPr id="16" name="Step 3 details"/>
+          <p:cNvPr id="18" name="Goal 3"/>
           <p:cNvSpPr txBox="1"/>
           <p:nvPr/>
         </p:nvSpPr>
         <p:spPr>
           <a:xfrm>
-            <a:off x="8493556" y="4114800"/>
-            <a:ext cx="2783738" cy="1737360"/>
+            <a:off x="8493556" y="3108960"/>
+            <a:ext cx="2783738" cy="640080"/>
+          </a:xfrm>
+          <a:prstGeom prst="rect">
+            <a:avLst/>
+          </a:prstGeom>
+          <a:noFill/>
+        </p:spPr>
+        <p:txBody>
+          <a:bodyPr wrap="square" lIns="0" rIns="0" tIns="0" bIns="0" anchor="t">
+            <a:spAutoFit/>
+          </a:bodyPr>
+          <a:lstStyle/>
+          <a:p>
+            <a:pPr algn="l"/>
+            <a:r>
+              <a:rPr sz="1500" b="1">
+                <a:solidFill>
+                  <a:srgbClr val="2A78D6"/>
+                </a:solidFill>
+                <a:latin typeface="Calibri"/>
+              </a:rPr>
+              <a:t>Goal: put effort behind what works</a:t>
+            </a:r>
+          </a:p>
+        </p:txBody>
+      </p:sp>
+      <p:sp>
+        <p:nvSpPr>
+          <p:cNvPr id="19" name="Step 3 details"/>
+          <p:cNvSpPr txBox="1"/>
+          <p:nvPr/>
+        </p:nvSpPr>
+        <p:spPr>
+          <a:xfrm>
+            <a:off x="8493556" y="3840480"/>
+            <a:ext cx="2783738" cy="2194560"/>
           </a:xfrm>
           <a:prstGeom prst="rect">
             <a:avLst/>
@@ -7824,22 +8025,40 @@
               <a:buChar char="•"/>
             </a:pPr>
             <a:r>
-              <a:rPr sz="1600" b="1">
+              <a:rPr sz="1500" b="1">
                 <a:solidFill>
                   <a:srgbClr val="1B2733"/>
                 </a:solidFill>
                 <a:latin typeface="Calibri"/>
               </a:rPr>
-              <a:t>Scale what works</a:t>
-            </a:r>
-            <a:r>
-              <a:rPr sz="1600" b="0">
+              <a:t>Scale</a:t>
+            </a:r>
+            <a:r>
+              <a:rPr sz="1500" b="0">
                 <a:solidFill>
                   <a:srgbClr val="1B2733"/>
                 </a:solidFill>
                 <a:latin typeface="Calibri"/>
               </a:rPr>
-              <a:t>, stop what doesn't</a:t>
+              <a:t> the Colorbuds fix if pilot stores sold </a:t>
+            </a:r>
+            <a:r>
+              <a:rPr sz="1500" b="1">
+                <a:solidFill>
+                  <a:srgbClr val="1B2733"/>
+                </a:solidFill>
+                <a:latin typeface="Calibri"/>
+              </a:rPr>
+              <a:t>15% more</a:t>
+            </a:r>
+            <a:r>
+              <a:rPr sz="1500" b="0">
+                <a:solidFill>
+                  <a:srgbClr val="1B2733"/>
+                </a:solidFill>
+                <a:latin typeface="Calibri"/>
+              </a:rPr>
+              <a:t>, otherwise stop</a:t>
             </a:r>
           </a:p>
           <a:p>
@@ -7854,22 +8073,70 @@
               <a:buChar char="•"/>
             </a:pPr>
             <a:r>
-              <a:rPr sz="1600" b="0">
+              <a:rPr sz="1500" b="0">
                 <a:solidFill>
                   <a:srgbClr val="1B2733"/>
                 </a:solidFill>
                 <a:latin typeface="Calibri"/>
               </a:rPr>
+              <a:t>Check whether </a:t>
+            </a:r>
+            <a:r>
+              <a:rPr sz="1500" b="1">
+                <a:solidFill>
+                  <a:srgbClr val="1B2733"/>
+                </a:solidFill>
+                <a:latin typeface="Calibri"/>
+              </a:rPr>
+              <a:t>Playfoam is holding up</a:t>
+            </a:r>
+            <a:r>
+              <a:rPr sz="1500" b="0">
+                <a:solidFill>
+                  <a:srgbClr val="1B2733"/>
+                </a:solidFill>
+                <a:latin typeface="Calibri"/>
+              </a:rPr>
+              <a:t> or cooling off</a:t>
+            </a:r>
+          </a:p>
+          <a:p>
+            <a:pPr marL="285750" indent="-285750">
+              <a:spcAft>
+                <a:spcPts val="800"/>
+              </a:spcAft>
+              <a:buClr>
+                <a:srgbClr val="2A78D6"/>
+              </a:buClr>
+              <a:buFont typeface="Arial"/>
+              <a:buChar char="•"/>
+            </a:pPr>
+            <a:r>
+              <a:rPr sz="1500" b="0">
+                <a:solidFill>
+                  <a:srgbClr val="1B2733"/>
+                </a:solidFill>
+                <a:latin typeface="Calibri"/>
+              </a:rPr>
               <a:t>Pick the next </a:t>
             </a:r>
             <a:r>
-              <a:rPr sz="1600" b="1">
+              <a:rPr sz="1500" b="1">
                 <a:solidFill>
                   <a:srgbClr val="1B2733"/>
                 </a:solidFill>
                 <a:latin typeface="Calibri"/>
               </a:rPr>
               <a:t>higher-margin toy</a:t>
+            </a:r>
+            <a:r>
+              <a:rPr sz="1500" b="0">
+                <a:solidFill>
+                  <a:srgbClr val="1B2733"/>
+                </a:solidFill>
+                <a:latin typeface="Calibri"/>
+              </a:rPr>
+              <a:t> to back</a:t>
             </a:r>
           </a:p>
         </p:txBody>

</xml_diff>

<commit_message>
Deck slide 2: Playfoam is the strongest launch in the data
Co-Authored-By: Claude Sonnet 5.5 <noreply@anthropic.com>
Claude-Session: https://claude.ai/code/session_01J6v5JYXB5XucuZ66TGAjVJ
</commit_message>
<xml_diff>
--- a/site/deck/Colorbuds_to_Playfoam.pptx
+++ b/site/deck/Colorbuds_to_Playfoam.pptx
@@ -1352,7 +1352,7 @@
           <a:lstStyle/>
           <a:p>
             <a:r>
-              <a:t>Playfoam launched Aug 17, 2023 and sold 4,158 units in about six weeks (1,311 in August from the 17th, 2,847 in September). Estimated profit, first six full weeks (Aug 20 - Sep 30): Playfoam $28K vs Colorbuds $30K, #2 of 35 toys, and #1 in 2 of the 6 weeks. Weekly units were flat at about 680 ([718, 722, 646, 688, 679, 601]): steady, not rising or fading yet. It earns $7 per unit at a 64% margin, about $20K a month at the September pace. It is at zero stock in 13 stores; each store sells about 57 units a month, so empty shelves cost roughly $5K a month. It was the #5 profit toy in Q3 2023 despite only ~6 weeks on sale. Be honest: hot now, likely to cool (see the previous slide). Only six weeks of data; the $20K is a run-rate, not a forecast.</a:t>
+              <a:t>Playfoam launched Aug 17, 2023 and sold 4,158 units in about six weeks (1,311 in August from the 17th, 2,847 in September). Playfoam earned about $27K in its first 42 days, more than any of the 10 other toys launched in this data (next best: Etch A Sketch, about $20K, which later fell 56% from its peak, so a strong start is not proof of staying power). Estimated profit, first six full weeks (Aug 20 - Sep 30): Playfoam $28K vs Colorbuds $30K, #2 of 35 toys, and #1 in 2 of the 6 weeks. Weekly units were flat at about 680 ([718, 722, 646, 688, 679, 601]): steady, not rising or fading yet. It earns $7 per unit at a 64% margin, about $20K a month at the September pace. It is at zero stock in 13 stores; each store sells about 57 units a month, so empty shelves cost roughly $5K a month. It was the #5 profit toy in Q3 2023 despite only ~6 weeks on sale. Be honest: hot now, likely to cool (see the previous slide). Only six weeks of data; the $20K is a run-rate, not a forecast.</a:t>
             </a:r>
           </a:p>
         </p:txBody>
@@ -5302,7 +5302,7 @@
                 </a:solidFill>
                 <a:latin typeface="Calibri"/>
               </a:rPr>
-              <a:t>Playfoam launched in mid-August and is already our </a:t>
+              <a:t>Playfoam is our </a:t>
             </a:r>
             <a:r>
               <a:rPr sz="2000" b="1">
@@ -5311,7 +5311,16 @@
                 </a:solidFill>
                 <a:latin typeface="Calibri"/>
               </a:rPr>
-              <a:t>#2 profit toy</a:t>
+              <a:t>strongest launch yet</a:t>
+            </a:r>
+            <a:r>
+              <a:rPr sz="2000" b="0">
+                <a:solidFill>
+                  <a:srgbClr val="1B2733"/>
+                </a:solidFill>
+                <a:latin typeface="Calibri"/>
+              </a:rPr>
+              <a:t>: #2 in profit after six weeks, ahead of all 10 other new toys</a:t>
             </a:r>
           </a:p>
           <a:p>

</xml_diff>

<commit_message>
Deck slide 6: plain bullets, no bold, clearer gain wording
Co-Authored-By: Claude Sonnet 5.5 <noreply@anthropic.com>
Claude-Session: https://claude.ai/code/session_01J6v5JYXB5XucuZ66TGAjVJ
</commit_message>
<xml_diff>
--- a/site/deck/Colorbuds_to_Playfoam.pptx
+++ b/site/deck/Colorbuds_to_Playfoam.pptx
@@ -7229,7 +7229,7 @@
         <p:spPr>
           <a:xfrm>
             <a:off x="548640" y="1691640"/>
-            <a:ext cx="3515258" cy="4434840"/>
+            <a:ext cx="3515258" cy="4572000"/>
           </a:xfrm>
           <a:prstGeom prst="rect">
             <a:avLst/>
@@ -7395,8 +7395,8 @@
         </p:nvSpPr>
         <p:spPr>
           <a:xfrm>
-            <a:off x="914400" y="3840480"/>
-            <a:ext cx="2783738" cy="2194560"/>
+            <a:off x="914400" y="3703320"/>
+            <a:ext cx="2783738" cy="2468880"/>
           </a:xfrm>
           <a:prstGeom prst="rect">
             <a:avLst/>
@@ -7426,25 +7426,7 @@
                 </a:solidFill>
                 <a:latin typeface="Calibri"/>
               </a:rPr>
-              <a:t>Refill the </a:t>
-            </a:r>
-            <a:r>
-              <a:rPr sz="1500" b="1">
-                <a:solidFill>
-                  <a:srgbClr val="1B2733"/>
-                </a:solidFill>
-                <a:latin typeface="Calibri"/>
-              </a:rPr>
-              <a:t>13 stores</a:t>
-            </a:r>
-            <a:r>
-              <a:rPr sz="1500" b="0">
-                <a:solidFill>
-                  <a:srgbClr val="1B2733"/>
-                </a:solidFill>
-                <a:latin typeface="Calibri"/>
-              </a:rPr>
-              <a:t> that have none</a:t>
+              <a:t>Refill the 13 stores that have none</a:t>
             </a:r>
           </a:p>
           <a:p>
@@ -7465,16 +7447,7 @@
                 </a:solidFill>
                 <a:latin typeface="Calibri"/>
               </a:rPr>
-              <a:t>Gain: about </a:t>
-            </a:r>
-            <a:r>
-              <a:rPr sz="1500" b="1">
-                <a:solidFill>
-                  <a:srgbClr val="1B2733"/>
-                </a:solidFill>
-                <a:latin typeface="Calibri"/>
-              </a:rPr>
-              <a:t>$5K more profit a month</a:t>
+              <a:t>That adds about $5K in profit every month</a:t>
             </a:r>
           </a:p>
           <a:p>
@@ -7495,16 +7468,7 @@
                 </a:solidFill>
                 <a:latin typeface="Calibri"/>
               </a:rPr>
-              <a:t>Check stock </a:t>
-            </a:r>
-            <a:r>
-              <a:rPr sz="1500" b="1">
-                <a:solidFill>
-                  <a:srgbClr val="1B2733"/>
-                </a:solidFill>
-                <a:latin typeface="Calibri"/>
-              </a:rPr>
-              <a:t>every week</a:t>
+              <a:t>Check stock every week</a:t>
             </a:r>
           </a:p>
         </p:txBody>
@@ -7518,7 +7482,7 @@
         <p:spPr>
           <a:xfrm>
             <a:off x="4338218" y="1691640"/>
-            <a:ext cx="3515258" cy="4434840"/>
+            <a:ext cx="3515258" cy="4572000"/>
           </a:xfrm>
           <a:prstGeom prst="rect">
             <a:avLst/>
@@ -7684,8 +7648,8 @@
         </p:nvSpPr>
         <p:spPr>
           <a:xfrm>
-            <a:off x="4703978" y="3840480"/>
-            <a:ext cx="2783738" cy="2194560"/>
+            <a:off x="4703978" y="3703320"/>
+            <a:ext cx="2783738" cy="2468880"/>
           </a:xfrm>
           <a:prstGeom prst="rect">
             <a:avLst/>
@@ -7715,52 +7679,7 @@
                 </a:solidFill>
                 <a:latin typeface="Calibri"/>
               </a:rPr>
-              <a:t>Try </a:t>
-            </a:r>
-            <a:r>
-              <a:rPr sz="1500" b="1">
-                <a:solidFill>
-                  <a:srgbClr val="1B2733"/>
-                </a:solidFill>
-                <a:latin typeface="Calibri"/>
-              </a:rPr>
-              <a:t>new colors</a:t>
-            </a:r>
-            <a:r>
-              <a:rPr sz="1500" b="0">
-                <a:solidFill>
-                  <a:srgbClr val="1B2733"/>
-                </a:solidFill>
-                <a:latin typeface="Calibri"/>
-              </a:rPr>
-              <a:t>, a </a:t>
-            </a:r>
-            <a:r>
-              <a:rPr sz="1500" b="1">
-                <a:solidFill>
-                  <a:srgbClr val="1B2733"/>
-                </a:solidFill>
-                <a:latin typeface="Calibri"/>
-              </a:rPr>
-              <a:t>bundle with Gamer Headphones</a:t>
-            </a:r>
-            <a:r>
-              <a:rPr sz="1500" b="0">
-                <a:solidFill>
-                  <a:srgbClr val="1B2733"/>
-                </a:solidFill>
-                <a:latin typeface="Calibri"/>
-              </a:rPr>
-              <a:t>, or a </a:t>
-            </a:r>
-            <a:r>
-              <a:rPr sz="1500" b="1">
-                <a:solidFill>
-                  <a:srgbClr val="1B2733"/>
-                </a:solidFill>
-                <a:latin typeface="Calibri"/>
-              </a:rPr>
-              <a:t>better shelf spot</a:t>
+              <a:t>Try new colors, a bundle with Gamer Headphones, or a better shelf spot</a:t>
             </a:r>
           </a:p>
           <a:p>
@@ -7781,25 +7700,7 @@
                 </a:solidFill>
                 <a:latin typeface="Calibri"/>
               </a:rPr>
-              <a:t>Pilot in </a:t>
-            </a:r>
-            <a:r>
-              <a:rPr sz="1500" b="1">
-                <a:solidFill>
-                  <a:srgbClr val="1B2733"/>
-                </a:solidFill>
-                <a:latin typeface="Calibri"/>
-              </a:rPr>
-              <a:t>10 stores</a:t>
-            </a:r>
-            <a:r>
-              <a:rPr sz="1500" b="0">
-                <a:solidFill>
-                  <a:srgbClr val="1B2733"/>
-                </a:solidFill>
-                <a:latin typeface="Calibri"/>
-              </a:rPr>
-              <a:t> vs 10 similar stores that change nothing</a:t>
+              <a:t>Test it in 10 stores, against 10 similar stores that change nothing</a:t>
             </a:r>
           </a:p>
           <a:p>
@@ -7820,16 +7721,7 @@
                 </a:solidFill>
                 <a:latin typeface="Calibri"/>
               </a:rPr>
-              <a:t>Prize: a quarter of lost sales back is </a:t>
-            </a:r>
-            <a:r>
-              <a:rPr sz="1500" b="1">
-                <a:solidFill>
-                  <a:srgbClr val="1B2733"/>
-                </a:solidFill>
-                <a:latin typeface="Calibri"/>
-              </a:rPr>
-              <a:t>$11K more profit a month</a:t>
+              <a:t>Winning back a quarter of the lost sales adds $11K profit a month</a:t>
             </a:r>
           </a:p>
         </p:txBody>
@@ -7843,7 +7735,7 @@
         <p:spPr>
           <a:xfrm>
             <a:off x="8127796" y="1691640"/>
-            <a:ext cx="3515258" cy="4434840"/>
+            <a:ext cx="3515258" cy="4572000"/>
           </a:xfrm>
           <a:prstGeom prst="rect">
             <a:avLst/>
@@ -8009,8 +7901,8 @@
         </p:nvSpPr>
         <p:spPr>
           <a:xfrm>
-            <a:off x="8493556" y="3840480"/>
-            <a:ext cx="2783738" cy="2194560"/>
+            <a:off x="8493556" y="3703320"/>
+            <a:ext cx="2783738" cy="2468880"/>
           </a:xfrm>
           <a:prstGeom prst="rect">
             <a:avLst/>
@@ -8034,40 +7926,13 @@
               <a:buChar char="•"/>
             </a:pPr>
             <a:r>
-              <a:rPr sz="1500" b="1">
+              <a:rPr sz="1500" b="0">
                 <a:solidFill>
                   <a:srgbClr val="1B2733"/>
                 </a:solidFill>
                 <a:latin typeface="Calibri"/>
               </a:rPr>
-              <a:t>Scale</a:t>
-            </a:r>
-            <a:r>
-              <a:rPr sz="1500" b="0">
-                <a:solidFill>
-                  <a:srgbClr val="1B2733"/>
-                </a:solidFill>
-                <a:latin typeface="Calibri"/>
-              </a:rPr>
-              <a:t> the Colorbuds fix if pilot stores sold </a:t>
-            </a:r>
-            <a:r>
-              <a:rPr sz="1500" b="1">
-                <a:solidFill>
-                  <a:srgbClr val="1B2733"/>
-                </a:solidFill>
-                <a:latin typeface="Calibri"/>
-              </a:rPr>
-              <a:t>15% more</a:t>
-            </a:r>
-            <a:r>
-              <a:rPr sz="1500" b="0">
-                <a:solidFill>
-                  <a:srgbClr val="1B2733"/>
-                </a:solidFill>
-                <a:latin typeface="Calibri"/>
-              </a:rPr>
-              <a:t>, otherwise stop</a:t>
+              <a:t>Roll out the Colorbuds fix if the test stores sold 15% more, otherwise drop it</a:t>
             </a:r>
           </a:p>
           <a:p>
@@ -8088,25 +7953,7 @@
                 </a:solidFill>
                 <a:latin typeface="Calibri"/>
               </a:rPr>
-              <a:t>Check whether </a:t>
-            </a:r>
-            <a:r>
-              <a:rPr sz="1500" b="1">
-                <a:solidFill>
-                  <a:srgbClr val="1B2733"/>
-                </a:solidFill>
-                <a:latin typeface="Calibri"/>
-              </a:rPr>
-              <a:t>Playfoam is holding up</a:t>
-            </a:r>
-            <a:r>
-              <a:rPr sz="1500" b="0">
-                <a:solidFill>
-                  <a:srgbClr val="1B2733"/>
-                </a:solidFill>
-                <a:latin typeface="Calibri"/>
-              </a:rPr>
-              <a:t> or cooling off</a:t>
+              <a:t>Check whether Playfoam is holding up or cooling off</a:t>
             </a:r>
           </a:p>
           <a:p>
@@ -8127,25 +7974,7 @@
                 </a:solidFill>
                 <a:latin typeface="Calibri"/>
               </a:rPr>
-              <a:t>Pick the next </a:t>
-            </a:r>
-            <a:r>
-              <a:rPr sz="1500" b="1">
-                <a:solidFill>
-                  <a:srgbClr val="1B2733"/>
-                </a:solidFill>
-                <a:latin typeface="Calibri"/>
-              </a:rPr>
-              <a:t>higher-margin toy</a:t>
-            </a:r>
-            <a:r>
-              <a:rPr sz="1500" b="0">
-                <a:solidFill>
-                  <a:srgbClr val="1B2733"/>
-                </a:solidFill>
-                <a:latin typeface="Calibri"/>
-              </a:rPr>
-              <a:t> to back</a:t>
+              <a:t>Pick the next higher-margin toy to back</a:t>
             </a:r>
           </a:p>
         </p:txBody>

</xml_diff>

<commit_message>
Remove filter-bar icon; show the math behind the $5K Playfoam restock figure
Co-Authored-By: Claude Sonnet 5.5 <noreply@anthropic.com>
Claude-Session: https://claude.ai/code/session_01J6v5JYXB5XucuZ66TGAjVJ
</commit_message>
<xml_diff>
--- a/site/deck/Colorbuds_to_Playfoam.pptx
+++ b/site/deck/Colorbuds_to_Playfoam.pptx
@@ -1422,7 +1422,7 @@
           <a:lstStyle/>
           <a:p>
             <a:r>
-              <a:t>1) Keep Playfoam in stock: refill the 13 stores that have zero, and keep every store above about two weeks of sales (roughly 26 units a store); check weekly. Each store sells about 57 Playfoam units a month at $7 profit, so 13 stores is about $5K a month. 2) Test a Colorbuds fix: the options to try are new colors, a bundle with Gamer Headphones, or a better shelf spot. Run it in 10 stores and compare against 10 similar stores that change nothing, for about six weeks, so we learn what works before spending chain-wide. Winning back a quarter of the lost sales (about $44K a month lost, so about $11K) is the prize if it works. 3) Review at week 8: if the pilot stores sold about 15% more Colorbuds than the comparison stores, scale the fix; if not, stop. Also check whether Playfoam is holding its weekly sales, and pick the next newer, higher-margin toy to back. The 15% threshold is a suggestion to agree on in advance, not something from the data. Sizes are estimates; the data cannot show why Colorbuds fell.</a:t>
+              <a:t>1) Keep Playfoam in stock: refill the 13 stores that have zero, and keep every store above about two weeks of sales (roughly 26 units a store); check weekly. Where $5K comes from: the average store sold about 57 Playfoam units in September (2,847 units / 50 stores), each unit earns $7 profit, so 13 empty stores x 57 x $7 = about $5K a month. It is conservative: those 13 stores actually averaged about 71 units each in September before running out. 2) Test a Colorbuds fix: the options to try are new colors, a bundle with Gamer Headphones, or a better shelf spot. Run it in 10 stores and compare against 10 similar stores that change nothing, for about six weeks, so we learn what works before spending chain-wide. Winning back a quarter of the lost sales (about $44K a month lost, so about $11K) is the prize if it works. 3) Review at week 8: if the pilot stores sold about 15% more Colorbuds than the comparison stores, scale the fix; if not, stop. Also check whether Playfoam is holding its weekly sales, and pick the next newer, higher-margin toy to back. The 15% threshold is a suggestion to agree on in advance, not something from the data. Sizes are estimates; the data cannot show why Colorbuds fell.</a:t>
             </a:r>
           </a:p>
         </p:txBody>
@@ -7001,7 +7001,7 @@
                 </a:solidFill>
                 <a:latin typeface="Calibri"/>
               </a:rPr>
-              <a:t>about $5K a month left on the table</a:t>
+              <a:t>13 x 57 units x $7 profit = about $5K a month</a:t>
             </a:r>
           </a:p>
         </p:txBody>
@@ -7447,7 +7447,7 @@
                 </a:solidFill>
                 <a:latin typeface="Calibri"/>
               </a:rPr>
-              <a:t>That adds about $5K in profit every month</a:t>
+              <a:t>13 stores x 57 units a month x $7 profit per unit = about $5K more profit a month</a:t>
             </a:r>
           </a:p>
           <a:p>

</xml_diff>

<commit_message>
Deck: frame Playfoam restock as $20K to $25K a month, over half the Colorbuds gap
Co-Authored-By: Claude Sonnet 5.5 <noreply@anthropic.com>
Claude-Session: https://claude.ai/code/session_01J6v5JYXB5XucuZ66TGAjVJ
</commit_message>
<xml_diff>
--- a/site/deck/Colorbuds_to_Playfoam.pptx
+++ b/site/deck/Colorbuds_to_Playfoam.pptx
@@ -1422,7 +1422,7 @@
           <a:lstStyle/>
           <a:p>
             <a:r>
-              <a:t>1) Keep Playfoam in stock: refill the 13 stores that have zero, and keep every store above about two weeks of sales (roughly 26 units a store); check weekly. Where $5K comes from: the average store sold about 57 Playfoam units in September (2,847 units / 50 stores), each unit earns $7 profit, so 13 empty stores x 57 x $7 = about $5K a month. It is conservative: those 13 stores actually averaged about 71 units each in September before running out. 2) Test a Colorbuds fix: the options to try are new colors, a bundle with Gamer Headphones, or a better shelf spot. Run it in 10 stores and compare against 10 similar stores that change nothing, for about six weeks, so we learn what works before spending chain-wide. Winning back a quarter of the lost sales (about $44K a month lost, so about $11K) is the prize if it works. 3) Review at week 8: if the pilot stores sold about 15% more Colorbuds than the comparison stores, scale the fix; if not, stop. Also check whether Playfoam is holding its weekly sales, and pick the next newer, higher-margin toy to back. The 15% threshold is a suggestion to agree on in advance, not something from the data. Sizes are estimates; the data cannot show why Colorbuds fell.</a:t>
+              <a:t>1) Keep Playfoam in stock: refill the 13 stores that have zero, and keep every store above about two weeks of sales (roughly 26 units a store); check weekly. Where $5K comes from: the average store sold about 57 Playfoam units in September (2,847 units / 50 stores), each unit earns $7 profit, so 13 empty stores x 57 x $7 = about $5K a month, which lifts Playfoam from about $20K to about $25K a month, more than half of the $44K a month Colorbuds has lost. It is conservative: those 13 stores actually averaged about 71 units each in September before running out. 2) Test a Colorbuds fix: the options to try are new colors, a bundle with Gamer Headphones, or a better shelf spot. Run it in 10 stores and compare against 10 similar stores that change nothing, for about six weeks, so we learn what works before spending chain-wide. Winning back a quarter of the lost sales (about $44K a month lost, so about $11K) is the prize if it works. 3) Review at week 8: if the pilot stores sold about 15% more Colorbuds than the comparison stores, scale the fix; if not, stop. Also check whether Playfoam is holding its weekly sales, and pick the next newer, higher-margin toy to back. The 15% threshold is a suggestion to agree on in advance, not something from the data. Sizes are estimates; the data cannot show why Colorbuds fell.</a:t>
             </a:r>
           </a:p>
         </p:txBody>
@@ -6650,7 +6650,7 @@
                 </a:solidFill>
                 <a:latin typeface="Cambria"/>
               </a:rPr>
-              <a:t>Playfoam is the early bright spot, but 13 empty stores are costing us about $5K a month</a:t>
+              <a:t>Playfoam is the early bright spot, and full shelves could cover over half of Colorbuds' lost profit</a:t>
             </a:r>
           </a:p>
         </p:txBody>
@@ -7001,7 +7001,7 @@
                 </a:solidFill>
                 <a:latin typeface="Calibri"/>
               </a:rPr>
-              <a:t>13 x 57 units x $7 profit = about $5K a month</a:t>
+              <a:t>13 x 57 units x $7 = +$5K a month ($20K to $25K)</a:t>
             </a:r>
           </a:p>
         </p:txBody>
@@ -7447,7 +7447,7 @@
                 </a:solidFill>
                 <a:latin typeface="Calibri"/>
               </a:rPr>
-              <a:t>13 stores x 57 units a month x $7 profit per unit = about $5K more profit a month</a:t>
+              <a:t>Playfoam goes from $20K to about $25K profit a month, over half of what Colorbuds lost</a:t>
             </a:r>
           </a:p>
           <a:p>

</xml_diff>

<commit_message>
Deck cover: half-bleed pink panel with shadowless Colorbuds art
Co-Authored-By: Claude Sonnet 5.5 <noreply@anthropic.com>
Claude-Session: https://claude.ai/code/session_01J6v5JYXB5XucuZ66TGAjVJ
</commit_message>
<xml_diff>
--- a/site/deck/Colorbuds_to_Playfoam.pptx
+++ b/site/deck/Colorbuds_to_Playfoam.pptx
@@ -4611,14 +4611,14 @@
         </p:nvSpPr>
         <p:spPr>
           <a:xfrm>
-            <a:off x="7772400" y="1371600"/>
-            <a:ext cx="3867912" cy="3867912"/>
+            <a:off x="7863840" y="0"/>
+            <a:ext cx="4327855" cy="6858000"/>
           </a:xfrm>
           <a:prstGeom prst="rect">
             <a:avLst/>
           </a:prstGeom>
           <a:solidFill>
-            <a:srgbClr val="FFFFFF"/>
+            <a:srgbClr val="FBDDE9"/>
           </a:solidFill>
           <a:ln>
             <a:noFill/>
@@ -4663,8 +4663,8 @@
         </p:blipFill>
         <p:spPr>
           <a:xfrm>
-            <a:off x="7955279" y="1554480"/>
-            <a:ext cx="3502152" cy="3502152"/>
+            <a:off x="8183879" y="1371600"/>
+            <a:ext cx="3566160" cy="3855018"/>
           </a:xfrm>
           <a:prstGeom prst="rect">
             <a:avLst/>

</xml_diff>

<commit_message>
Deck cover: title and art cover both Colorbuds and Playfoam
Co-Authored-By: Claude Sonnet 5.5 <noreply@anthropic.com>
Claude-Session: https://claude.ai/code/session_01J6v5JYXB5XucuZ66TGAjVJ
</commit_message>
<xml_diff>
--- a/site/deck/Colorbuds_to_Playfoam.pptx
+++ b/site/deck/Colorbuds_to_Playfoam.pptx
@@ -1072,7 +1072,7 @@
           <a:lstStyle/>
           <a:p>
             <a:r>
-              <a:t>Open with the one-line answer: Colorbuds (our line of kids' wireless earbuds), our #1 profit toy, is in decline. The plan is simple: back newer, higher-margin toys, test one cheap fix for Colorbuds, and review in 8 weeks. Keep the intro under 20 seconds.</a:t>
+              <a:t>Open with the one-line answer: Colorbuds (our line of kids' wireless earbuds), our #1 profit toy, is in decline, and Playfoam, a new toy launched in August, is the next bet. The plan is simple: back newer, higher-margin toys, test one cheap fix for Colorbuds, and review in 8 weeks. Keep the intro under 20 seconds.</a:t>
             </a:r>
           </a:p>
         </p:txBody>
@@ -4663,8 +4663,8 @@
         </p:blipFill>
         <p:spPr>
           <a:xfrm>
-            <a:off x="8183879" y="1371600"/>
-            <a:ext cx="3566160" cy="3855018"/>
+            <a:off x="9178164" y="640080"/>
+            <a:ext cx="1699205" cy="2377440"/>
           </a:xfrm>
           <a:prstGeom prst="rect">
             <a:avLst/>
@@ -4673,7 +4673,75 @@
       </p:pic>
       <p:sp>
         <p:nvSpPr>
-          <p:cNvPr id="8" name="Title"/>
+          <p:cNvPr id="8" name="Arrow from Colorbuds to Playfoam"/>
+          <p:cNvSpPr/>
+          <p:nvPr/>
+        </p:nvSpPr>
+        <p:spPr>
+          <a:xfrm>
+            <a:off x="9799167" y="3108960"/>
+            <a:ext cx="457200" cy="502920"/>
+          </a:xfrm>
+          <a:prstGeom prst="downArrow">
+            <a:avLst/>
+          </a:prstGeom>
+          <a:solidFill>
+            <a:srgbClr val="E8457B"/>
+          </a:solidFill>
+          <a:ln>
+            <a:noFill/>
+          </a:ln>
+          <a:effectLst/>
+        </p:spPr>
+        <p:style>
+          <a:lnRef idx="1">
+            <a:schemeClr val="accent1"/>
+          </a:lnRef>
+          <a:fillRef idx="3">
+            <a:schemeClr val="accent1"/>
+          </a:fillRef>
+          <a:effectRef idx="0">
+            <a:schemeClr val="accent1"/>
+          </a:effectRef>
+          <a:fontRef idx="minor">
+            <a:schemeClr val="lt1"/>
+          </a:fontRef>
+        </p:style>
+        <p:txBody>
+          <a:bodyPr rtlCol="0" anchor="ctr"/>
+          <a:lstStyle/>
+          <a:p>
+            <a:pPr algn="ctr"/>
+          </a:p>
+        </p:txBody>
+      </p:sp>
+      <p:pic>
+        <p:nvPicPr>
+          <p:cNvPr id="9" name="Playfoam illustration" descr="Illustration of Playfoam: a purple tub heaped with tiny colorful beads"/>
+          <p:cNvPicPr>
+            <a:picLocks noChangeAspect="1"/>
+          </p:cNvPicPr>
+          <p:nvPr/>
+        </p:nvPicPr>
+        <p:blipFill>
+          <a:blip r:embed="rId3"/>
+          <a:stretch>
+            <a:fillRect/>
+          </a:stretch>
+        </p:blipFill>
+        <p:spPr>
+          <a:xfrm>
+            <a:off x="8941365" y="3794760"/>
+            <a:ext cx="2172805" cy="2423160"/>
+          </a:xfrm>
+          <a:prstGeom prst="rect">
+            <a:avLst/>
+          </a:prstGeom>
+        </p:spPr>
+      </p:pic>
+      <p:sp>
+        <p:nvSpPr>
+          <p:cNvPr id="10" name="Title"/>
           <p:cNvSpPr txBox="1"/>
           <p:nvPr/>
         </p:nvSpPr>
@@ -4701,7 +4769,7 @@
                 </a:solidFill>
                 <a:latin typeface="Cambria"/>
               </a:rPr>
-              <a:t>Colorbuds, our #1 profit toy,</a:t>
+              <a:t>Colorbuds is in decline.</a:t>
             </a:r>
             <a:br/>
             <a:r>
@@ -4711,14 +4779,14 @@
                 </a:solidFill>
                 <a:latin typeface="Cambria"/>
               </a:rPr>
-              <a:t>is in decline</a:t>
-            </a:r>
-          </a:p>
-        </p:txBody>
-      </p:sp>
-      <p:sp>
-        <p:nvSpPr>
-          <p:cNvPr id="9" name="Subtitle"/>
+              <a:t>Playfoam is the next bet.</a:t>
+            </a:r>
+          </a:p>
+        </p:txBody>
+      </p:sp>
+      <p:sp>
+        <p:nvSpPr>
+          <p:cNvPr id="11" name="Subtitle"/>
           <p:cNvSpPr txBox="1"/>
           <p:nvPr/>
         </p:nvSpPr>
@@ -4753,7 +4821,7 @@
       </p:sp>
       <p:sp>
         <p:nvSpPr>
-          <p:cNvPr id="10" name="Date line"/>
+          <p:cNvPr id="12" name="Date line"/>
           <p:cNvSpPr txBox="1"/>
           <p:nvPr/>
         </p:nvSpPr>

</xml_diff>

<commit_message>
Deck cover: navy layout with two product cards; title states Colorbuds is #1
Co-Authored-By: Claude Sonnet 5.5 <noreply@anthropic.com>
Claude-Session: https://claude.ai/code/session_01J6v5JYXB5XucuZ66TGAjVJ
</commit_message>
<xml_diff>
--- a/site/deck/Colorbuds_to_Playfoam.pptx
+++ b/site/deck/Colorbuds_to_Playfoam.pptx
@@ -4605,20 +4605,20 @@
       </p:sp>
       <p:sp>
         <p:nvSpPr>
-          <p:cNvPr id="6" name="Image panel"/>
+          <p:cNvPr id="6" name="Right panel"/>
           <p:cNvSpPr/>
           <p:nvPr/>
         </p:nvSpPr>
         <p:spPr>
           <a:xfrm>
-            <a:off x="7863840" y="0"/>
-            <a:ext cx="4327855" cy="6858000"/>
+            <a:off x="7680960" y="0"/>
+            <a:ext cx="4510735" cy="6858000"/>
           </a:xfrm>
           <a:prstGeom prst="rect">
             <a:avLst/>
           </a:prstGeom>
           <a:solidFill>
-            <a:srgbClr val="FBDDE9"/>
+            <a:srgbClr val="0B2B45"/>
           </a:solidFill>
           <a:ln>
             <a:noFill/>
@@ -4647,46 +4647,24 @@
           </a:p>
         </p:txBody>
       </p:sp>
-      <p:pic>
-        <p:nvPicPr>
-          <p:cNvPr id="7" name="Colorbuds illustration" descr="Illustration of Colorbuds: two colorful earbuds in an open charging case with a heart"/>
-          <p:cNvPicPr>
-            <a:picLocks noChangeAspect="1"/>
-          </p:cNvPicPr>
-          <p:nvPr/>
-        </p:nvPicPr>
-        <p:blipFill>
-          <a:blip r:embed="rId2"/>
-          <a:stretch>
-            <a:fillRect/>
-          </a:stretch>
-        </p:blipFill>
-        <p:spPr>
-          <a:xfrm>
-            <a:off x="9178164" y="640080"/>
-            <a:ext cx="1699205" cy="2377440"/>
-          </a:xfrm>
-          <a:prstGeom prst="rect">
-            <a:avLst/>
-          </a:prstGeom>
-        </p:spPr>
-      </p:pic>
-      <p:sp>
-        <p:nvSpPr>
-          <p:cNvPr id="8" name="Arrow from Colorbuds to Playfoam"/>
+      <p:sp>
+        <p:nvSpPr>
+          <p:cNvPr id="7" name="Colorbuds card"/>
           <p:cNvSpPr/>
           <p:nvPr/>
         </p:nvSpPr>
         <p:spPr>
           <a:xfrm>
-            <a:off x="9799167" y="3108960"/>
-            <a:ext cx="457200" cy="502920"/>
-          </a:xfrm>
-          <a:prstGeom prst="downArrow">
-            <a:avLst/>
+            <a:off x="8153247" y="777240"/>
+            <a:ext cx="3566160" cy="2514600"/>
+          </a:xfrm>
+          <a:prstGeom prst="roundRect">
+            <a:avLst>
+              <a:gd name="adj" fmla="val 7000"/>
+            </a:avLst>
           </a:prstGeom>
           <a:solidFill>
-            <a:srgbClr val="E8457B"/>
+            <a:srgbClr val="FBE6EE"/>
           </a:solidFill>
           <a:ln>
             <a:noFill/>
@@ -4717,7 +4695,191 @@
       </p:sp>
       <p:pic>
         <p:nvPicPr>
-          <p:cNvPr id="9" name="Playfoam illustration" descr="Illustration of Playfoam: a purple tub heaped with tiny colorful beads"/>
+          <p:cNvPr id="8" name="Colorbuds illustration" descr="Illustration of Colorbuds: two colorful earbuds in an open charging case with a heart"/>
+          <p:cNvPicPr>
+            <a:picLocks noChangeAspect="1"/>
+          </p:cNvPicPr>
+          <p:nvPr/>
+        </p:nvPicPr>
+        <p:blipFill>
+          <a:blip r:embed="rId2"/>
+          <a:stretch>
+            <a:fillRect/>
+          </a:stretch>
+        </p:blipFill>
+        <p:spPr>
+          <a:xfrm>
+            <a:off x="9413495" y="941832"/>
+            <a:ext cx="1045665" cy="1463040"/>
+          </a:xfrm>
+          <a:prstGeom prst="rect">
+            <a:avLst/>
+          </a:prstGeom>
+        </p:spPr>
+      </p:pic>
+      <p:sp>
+        <p:nvSpPr>
+          <p:cNvPr id="9" name="Colorbuds card title"/>
+          <p:cNvSpPr txBox="1"/>
+          <p:nvPr/>
+        </p:nvSpPr>
+        <p:spPr>
+          <a:xfrm>
+            <a:off x="8427567" y="2560320"/>
+            <a:ext cx="3017520" cy="347472"/>
+          </a:xfrm>
+          <a:prstGeom prst="rect">
+            <a:avLst/>
+          </a:prstGeom>
+          <a:noFill/>
+        </p:spPr>
+        <p:txBody>
+          <a:bodyPr wrap="square" lIns="0" rIns="0" tIns="0" bIns="0" anchor="t">
+            <a:spAutoFit/>
+          </a:bodyPr>
+          <a:lstStyle/>
+          <a:p>
+            <a:pPr algn="ctr"/>
+            <a:r>
+              <a:rPr sz="1700" b="1">
+                <a:solidFill>
+                  <a:srgbClr val="051C2C"/>
+                </a:solidFill>
+                <a:latin typeface="Cambria"/>
+              </a:rPr>
+              <a:t>Colorbuds</a:t>
+            </a:r>
+          </a:p>
+        </p:txBody>
+      </p:sp>
+      <p:sp>
+        <p:nvSpPr>
+          <p:cNvPr id="10" name="Colorbuds card caption"/>
+          <p:cNvSpPr txBox="1"/>
+          <p:nvPr/>
+        </p:nvSpPr>
+        <p:spPr>
+          <a:xfrm>
+            <a:off x="8427567" y="2880360"/>
+            <a:ext cx="3017520" cy="292608"/>
+          </a:xfrm>
+          <a:prstGeom prst="rect">
+            <a:avLst/>
+          </a:prstGeom>
+          <a:noFill/>
+        </p:spPr>
+        <p:txBody>
+          <a:bodyPr wrap="square" lIns="0" rIns="0" tIns="0" bIns="0" anchor="t">
+            <a:spAutoFit/>
+          </a:bodyPr>
+          <a:lstStyle/>
+          <a:p>
+            <a:pPr algn="ctr"/>
+            <a:r>
+              <a:rPr sz="1300" b="0">
+                <a:solidFill>
+                  <a:srgbClr val="5B6470"/>
+                </a:solidFill>
+                <a:latin typeface="Calibri"/>
+              </a:rPr>
+              <a:t>Our #1 profit toy, in decline</a:t>
+            </a:r>
+          </a:p>
+        </p:txBody>
+      </p:sp>
+      <p:sp>
+        <p:nvSpPr>
+          <p:cNvPr id="11" name="Arrow from Colorbuds to Playfoam"/>
+          <p:cNvSpPr/>
+          <p:nvPr/>
+        </p:nvSpPr>
+        <p:spPr>
+          <a:xfrm>
+            <a:off x="9753447" y="3383280"/>
+            <a:ext cx="365760" cy="365760"/>
+          </a:xfrm>
+          <a:prstGeom prst="downArrow">
+            <a:avLst/>
+          </a:prstGeom>
+          <a:solidFill>
+            <a:srgbClr val="1BAF7A"/>
+          </a:solidFill>
+          <a:ln>
+            <a:noFill/>
+          </a:ln>
+          <a:effectLst/>
+        </p:spPr>
+        <p:style>
+          <a:lnRef idx="1">
+            <a:schemeClr val="accent1"/>
+          </a:lnRef>
+          <a:fillRef idx="3">
+            <a:schemeClr val="accent1"/>
+          </a:fillRef>
+          <a:effectRef idx="0">
+            <a:schemeClr val="accent1"/>
+          </a:effectRef>
+          <a:fontRef idx="minor">
+            <a:schemeClr val="lt1"/>
+          </a:fontRef>
+        </p:style>
+        <p:txBody>
+          <a:bodyPr rtlCol="0" anchor="ctr"/>
+          <a:lstStyle/>
+          <a:p>
+            <a:pPr algn="ctr"/>
+          </a:p>
+        </p:txBody>
+      </p:sp>
+      <p:sp>
+        <p:nvSpPr>
+          <p:cNvPr id="12" name="Playfoam card"/>
+          <p:cNvSpPr/>
+          <p:nvPr/>
+        </p:nvSpPr>
+        <p:spPr>
+          <a:xfrm>
+            <a:off x="8153247" y="3977639"/>
+            <a:ext cx="3566160" cy="2514600"/>
+          </a:xfrm>
+          <a:prstGeom prst="roundRect">
+            <a:avLst>
+              <a:gd name="adj" fmla="val 7000"/>
+            </a:avLst>
+          </a:prstGeom>
+          <a:solidFill>
+            <a:srgbClr val="EAE6FF"/>
+          </a:solidFill>
+          <a:ln>
+            <a:noFill/>
+          </a:ln>
+          <a:effectLst/>
+        </p:spPr>
+        <p:style>
+          <a:lnRef idx="1">
+            <a:schemeClr val="accent1"/>
+          </a:lnRef>
+          <a:fillRef idx="3">
+            <a:schemeClr val="accent1"/>
+          </a:fillRef>
+          <a:effectRef idx="0">
+            <a:schemeClr val="accent1"/>
+          </a:effectRef>
+          <a:fontRef idx="minor">
+            <a:schemeClr val="lt1"/>
+          </a:fontRef>
+        </p:style>
+        <p:txBody>
+          <a:bodyPr rtlCol="0" anchor="ctr"/>
+          <a:lstStyle/>
+          <a:p>
+            <a:pPr algn="ctr"/>
+          </a:p>
+        </p:txBody>
+      </p:sp>
+      <p:pic>
+        <p:nvPicPr>
+          <p:cNvPr id="13" name="Playfoam illustration" descr="Illustration of Playfoam: a purple tub heaped with tiny colorful beads"/>
           <p:cNvPicPr>
             <a:picLocks noChangeAspect="1"/>
           </p:cNvPicPr>
@@ -4731,8 +4893,8 @@
         </p:blipFill>
         <p:spPr>
           <a:xfrm>
-            <a:off x="8941365" y="3794760"/>
-            <a:ext cx="2172805" cy="2423160"/>
+            <a:off x="9280386" y="4142231"/>
+            <a:ext cx="1311882" cy="1463040"/>
           </a:xfrm>
           <a:prstGeom prst="rect">
             <a:avLst/>
@@ -4741,14 +4903,84 @@
       </p:pic>
       <p:sp>
         <p:nvSpPr>
-          <p:cNvPr id="10" name="Title"/>
+          <p:cNvPr id="14" name="Playfoam card title"/>
           <p:cNvSpPr txBox="1"/>
           <p:nvPr/>
         </p:nvSpPr>
         <p:spPr>
           <a:xfrm>
-            <a:off x="548640" y="1463040"/>
-            <a:ext cx="7223760" cy="2468880"/>
+            <a:off x="8427567" y="5760720"/>
+            <a:ext cx="3017520" cy="347472"/>
+          </a:xfrm>
+          <a:prstGeom prst="rect">
+            <a:avLst/>
+          </a:prstGeom>
+          <a:noFill/>
+        </p:spPr>
+        <p:txBody>
+          <a:bodyPr wrap="square" lIns="0" rIns="0" tIns="0" bIns="0" anchor="t">
+            <a:spAutoFit/>
+          </a:bodyPr>
+          <a:lstStyle/>
+          <a:p>
+            <a:pPr algn="ctr"/>
+            <a:r>
+              <a:rPr sz="1700" b="1">
+                <a:solidFill>
+                  <a:srgbClr val="051C2C"/>
+                </a:solidFill>
+                <a:latin typeface="Cambria"/>
+              </a:rPr>
+              <a:t>Playfoam</a:t>
+            </a:r>
+          </a:p>
+        </p:txBody>
+      </p:sp>
+      <p:sp>
+        <p:nvSpPr>
+          <p:cNvPr id="15" name="Playfoam card caption"/>
+          <p:cNvSpPr txBox="1"/>
+          <p:nvPr/>
+        </p:nvSpPr>
+        <p:spPr>
+          <a:xfrm>
+            <a:off x="8427567" y="6080759"/>
+            <a:ext cx="3017520" cy="292608"/>
+          </a:xfrm>
+          <a:prstGeom prst="rect">
+            <a:avLst/>
+          </a:prstGeom>
+          <a:noFill/>
+        </p:spPr>
+        <p:txBody>
+          <a:bodyPr wrap="square" lIns="0" rIns="0" tIns="0" bIns="0" anchor="t">
+            <a:spAutoFit/>
+          </a:bodyPr>
+          <a:lstStyle/>
+          <a:p>
+            <a:pPr algn="ctr"/>
+            <a:r>
+              <a:rPr sz="1300" b="0">
+                <a:solidFill>
+                  <a:srgbClr val="5B6470"/>
+                </a:solidFill>
+                <a:latin typeface="Calibri"/>
+              </a:rPr>
+              <a:t>Launched Aug 2023, already our #2 profit toy</a:t>
+            </a:r>
+          </a:p>
+        </p:txBody>
+      </p:sp>
+      <p:sp>
+        <p:nvSpPr>
+          <p:cNvPr id="16" name="Title"/>
+          <p:cNvSpPr txBox="1"/>
+          <p:nvPr/>
+        </p:nvSpPr>
+        <p:spPr>
+          <a:xfrm>
+            <a:off x="548640" y="1371600"/>
+            <a:ext cx="7040880" cy="2651760"/>
           </a:xfrm>
           <a:prstGeom prst="rect">
             <a:avLst/>
@@ -4763,19 +4995,29 @@
           <a:p>
             <a:pPr algn="l"/>
             <a:r>
-              <a:rPr sz="4000" b="1">
+              <a:rPr sz="3800" b="1">
                 <a:solidFill>
                   <a:srgbClr val="FFFFFF"/>
                 </a:solidFill>
                 <a:latin typeface="Cambria"/>
               </a:rPr>
-              <a:t>Colorbuds is in decline.</a:t>
+              <a:t>Colorbuds, our #1 profit toy,</a:t>
             </a:r>
             <a:br/>
             <a:r>
-              <a:rPr sz="4000" b="1">
+              <a:rPr sz="3800" b="1">
                 <a:solidFill>
                   <a:srgbClr val="FFFFFF"/>
+                </a:solidFill>
+                <a:latin typeface="Cambria"/>
+              </a:rPr>
+              <a:t>is in decline.</a:t>
+            </a:r>
+            <a:br/>
+            <a:r>
+              <a:rPr sz="3800" b="1">
+                <a:solidFill>
+                  <a:srgbClr val="8FE3C3"/>
                 </a:solidFill>
                 <a:latin typeface="Cambria"/>
               </a:rPr>
@@ -4786,7 +5028,7 @@
       </p:sp>
       <p:sp>
         <p:nvSpPr>
-          <p:cNvPr id="11" name="Subtitle"/>
+          <p:cNvPr id="17" name="Subtitle"/>
           <p:cNvSpPr txBox="1"/>
           <p:nvPr/>
         </p:nvSpPr>
@@ -4821,7 +5063,7 @@
       </p:sp>
       <p:sp>
         <p:nvSpPr>
-          <p:cNvPr id="12" name="Date line"/>
+          <p:cNvPr id="18" name="Date line"/>
           <p:cNvSpPr txBox="1"/>
           <p:nvPr/>
         </p:nvSpPr>

</xml_diff>

<commit_message>
Deck cover: simplify title to 'From Colorbuds to Playfoam'
Co-Authored-By: Claude Sonnet 5.5 <noreply@anthropic.com>
Claude-Session: https://claude.ai/code/session_01J6v5JYXB5XucuZ66TGAjVJ
</commit_message>
<xml_diff>
--- a/site/deck/Colorbuds_to_Playfoam.pptx
+++ b/site/deck/Colorbuds_to_Playfoam.pptx
@@ -4979,8 +4979,8 @@
         </p:nvSpPr>
         <p:spPr>
           <a:xfrm>
-            <a:off x="548640" y="1371600"/>
-            <a:ext cx="7040880" cy="2651760"/>
+            <a:off x="548640" y="1463040"/>
+            <a:ext cx="7040880" cy="2468880"/>
           </a:xfrm>
           <a:prstGeom prst="rect">
             <a:avLst/>
@@ -4995,33 +4995,23 @@
           <a:p>
             <a:pPr algn="l"/>
             <a:r>
-              <a:rPr sz="3800" b="1">
+              <a:rPr sz="4600" b="1">
                 <a:solidFill>
                   <a:srgbClr val="FFFFFF"/>
                 </a:solidFill>
                 <a:latin typeface="Cambria"/>
               </a:rPr>
-              <a:t>Colorbuds, our #1 profit toy,</a:t>
+              <a:t>From Colorbuds</a:t>
             </a:r>
             <a:br/>
             <a:r>
-              <a:rPr sz="3800" b="1">
+              <a:rPr sz="4600" b="1">
                 <a:solidFill>
                   <a:srgbClr val="FFFFFF"/>
                 </a:solidFill>
                 <a:latin typeface="Cambria"/>
               </a:rPr>
-              <a:t>is in decline.</a:t>
-            </a:r>
-            <a:br/>
-            <a:r>
-              <a:rPr sz="3800" b="1">
-                <a:solidFill>
-                  <a:srgbClr val="8FE3C3"/>
-                </a:solidFill>
-                <a:latin typeface="Cambria"/>
-              </a:rPr>
-              <a:t>Playfoam is the next bet.</a:t>
+              <a:t>to Playfoam</a:t>
             </a:r>
           </a:p>
         </p:txBody>
@@ -5056,7 +5046,7 @@
                 </a:solidFill>
                 <a:latin typeface="Calibri"/>
               </a:rPr>
-              <a:t>A plan to protect profit by backing newer, higher-margin toys</a:t>
+              <a:t>Our #1 profit toy is in decline. Here is how we protect profit.</a:t>
             </a:r>
           </a:p>
         </p:txBody>

</xml_diff>

<commit_message>
Deck cover: restore title, calmer light panel with just the two toys
Co-Authored-By: Claude Sonnet 5.5 <noreply@anthropic.com>
Claude-Session: https://claude.ai/code/session_01J6v5JYXB5XucuZ66TGAjVJ
</commit_message>
<xml_diff>
--- a/site/deck/Colorbuds_to_Playfoam.pptx
+++ b/site/deck/Colorbuds_to_Playfoam.pptx
@@ -4618,7 +4618,7 @@
             <a:avLst/>
           </a:prstGeom>
           <a:solidFill>
-            <a:srgbClr val="0B2B45"/>
+            <a:srgbClr val="F2F4F7"/>
           </a:solidFill>
           <a:ln>
             <a:noFill/>
@@ -4647,55 +4647,9 @@
           </a:p>
         </p:txBody>
       </p:sp>
-      <p:sp>
-        <p:nvSpPr>
-          <p:cNvPr id="7" name="Colorbuds card"/>
-          <p:cNvSpPr/>
-          <p:nvPr/>
-        </p:nvSpPr>
-        <p:spPr>
-          <a:xfrm>
-            <a:off x="8153247" y="777240"/>
-            <a:ext cx="3566160" cy="2514600"/>
-          </a:xfrm>
-          <a:prstGeom prst="roundRect">
-            <a:avLst>
-              <a:gd name="adj" fmla="val 7000"/>
-            </a:avLst>
-          </a:prstGeom>
-          <a:solidFill>
-            <a:srgbClr val="FBE6EE"/>
-          </a:solidFill>
-          <a:ln>
-            <a:noFill/>
-          </a:ln>
-          <a:effectLst/>
-        </p:spPr>
-        <p:style>
-          <a:lnRef idx="1">
-            <a:schemeClr val="accent1"/>
-          </a:lnRef>
-          <a:fillRef idx="3">
-            <a:schemeClr val="accent1"/>
-          </a:fillRef>
-          <a:effectRef idx="0">
-            <a:schemeClr val="accent1"/>
-          </a:effectRef>
-          <a:fontRef idx="minor">
-            <a:schemeClr val="lt1"/>
-          </a:fontRef>
-        </p:style>
-        <p:txBody>
-          <a:bodyPr rtlCol="0" anchor="ctr"/>
-          <a:lstStyle/>
-          <a:p>
-            <a:pPr algn="ctr"/>
-          </a:p>
-        </p:txBody>
-      </p:sp>
       <p:pic>
         <p:nvPicPr>
-          <p:cNvPr id="8" name="Colorbuds illustration" descr="Illustration of Colorbuds: two colorful earbuds in an open charging case with a heart"/>
+          <p:cNvPr id="7" name="Colorbuds illustration" descr="Illustration of Colorbuds: two colorful earbuds in an open charging case with a heart"/>
           <p:cNvPicPr>
             <a:picLocks noChangeAspect="1"/>
           </p:cNvPicPr>
@@ -4709,8 +4663,8 @@
         </p:blipFill>
         <p:spPr>
           <a:xfrm>
-            <a:off x="9413495" y="941832"/>
-            <a:ext cx="1045665" cy="1463040"/>
+            <a:off x="9184755" y="731520"/>
+            <a:ext cx="1503143" cy="2103120"/>
           </a:xfrm>
           <a:prstGeom prst="rect">
             <a:avLst/>
@@ -4719,14 +4673,14 @@
       </p:pic>
       <p:sp>
         <p:nvSpPr>
-          <p:cNvPr id="9" name="Colorbuds card title"/>
+          <p:cNvPr id="8" name="Colorbuds label"/>
           <p:cNvSpPr txBox="1"/>
           <p:nvPr/>
         </p:nvSpPr>
         <p:spPr>
           <a:xfrm>
-            <a:off x="8427567" y="2560320"/>
-            <a:ext cx="3017520" cy="347472"/>
+            <a:off x="8138160" y="2926079"/>
+            <a:ext cx="3596335" cy="365760"/>
           </a:xfrm>
           <a:prstGeom prst="rect">
             <a:avLst/>
@@ -4741,7 +4695,7 @@
           <a:p>
             <a:pPr algn="ctr"/>
             <a:r>
-              <a:rPr sz="1700" b="1">
+              <a:rPr sz="1600" b="1">
                 <a:solidFill>
                   <a:srgbClr val="051C2C"/>
                 </a:solidFill>
@@ -4752,134 +4706,9 @@
           </a:p>
         </p:txBody>
       </p:sp>
-      <p:sp>
-        <p:nvSpPr>
-          <p:cNvPr id="10" name="Colorbuds card caption"/>
-          <p:cNvSpPr txBox="1"/>
-          <p:nvPr/>
-        </p:nvSpPr>
-        <p:spPr>
-          <a:xfrm>
-            <a:off x="8427567" y="2880360"/>
-            <a:ext cx="3017520" cy="292608"/>
-          </a:xfrm>
-          <a:prstGeom prst="rect">
-            <a:avLst/>
-          </a:prstGeom>
-          <a:noFill/>
-        </p:spPr>
-        <p:txBody>
-          <a:bodyPr wrap="square" lIns="0" rIns="0" tIns="0" bIns="0" anchor="t">
-            <a:spAutoFit/>
-          </a:bodyPr>
-          <a:lstStyle/>
-          <a:p>
-            <a:pPr algn="ctr"/>
-            <a:r>
-              <a:rPr sz="1300" b="0">
-                <a:solidFill>
-                  <a:srgbClr val="5B6470"/>
-                </a:solidFill>
-                <a:latin typeface="Calibri"/>
-              </a:rPr>
-              <a:t>Our #1 profit toy, in decline</a:t>
-            </a:r>
-          </a:p>
-        </p:txBody>
-      </p:sp>
-      <p:sp>
-        <p:nvSpPr>
-          <p:cNvPr id="11" name="Arrow from Colorbuds to Playfoam"/>
-          <p:cNvSpPr/>
-          <p:nvPr/>
-        </p:nvSpPr>
-        <p:spPr>
-          <a:xfrm>
-            <a:off x="9753447" y="3383280"/>
-            <a:ext cx="365760" cy="365760"/>
-          </a:xfrm>
-          <a:prstGeom prst="downArrow">
-            <a:avLst/>
-          </a:prstGeom>
-          <a:solidFill>
-            <a:srgbClr val="1BAF7A"/>
-          </a:solidFill>
-          <a:ln>
-            <a:noFill/>
-          </a:ln>
-          <a:effectLst/>
-        </p:spPr>
-        <p:style>
-          <a:lnRef idx="1">
-            <a:schemeClr val="accent1"/>
-          </a:lnRef>
-          <a:fillRef idx="3">
-            <a:schemeClr val="accent1"/>
-          </a:fillRef>
-          <a:effectRef idx="0">
-            <a:schemeClr val="accent1"/>
-          </a:effectRef>
-          <a:fontRef idx="minor">
-            <a:schemeClr val="lt1"/>
-          </a:fontRef>
-        </p:style>
-        <p:txBody>
-          <a:bodyPr rtlCol="0" anchor="ctr"/>
-          <a:lstStyle/>
-          <a:p>
-            <a:pPr algn="ctr"/>
-          </a:p>
-        </p:txBody>
-      </p:sp>
-      <p:sp>
-        <p:nvSpPr>
-          <p:cNvPr id="12" name="Playfoam card"/>
-          <p:cNvSpPr/>
-          <p:nvPr/>
-        </p:nvSpPr>
-        <p:spPr>
-          <a:xfrm>
-            <a:off x="8153247" y="3977639"/>
-            <a:ext cx="3566160" cy="2514600"/>
-          </a:xfrm>
-          <a:prstGeom prst="roundRect">
-            <a:avLst>
-              <a:gd name="adj" fmla="val 7000"/>
-            </a:avLst>
-          </a:prstGeom>
-          <a:solidFill>
-            <a:srgbClr val="EAE6FF"/>
-          </a:solidFill>
-          <a:ln>
-            <a:noFill/>
-          </a:ln>
-          <a:effectLst/>
-        </p:spPr>
-        <p:style>
-          <a:lnRef idx="1">
-            <a:schemeClr val="accent1"/>
-          </a:lnRef>
-          <a:fillRef idx="3">
-            <a:schemeClr val="accent1"/>
-          </a:fillRef>
-          <a:effectRef idx="0">
-            <a:schemeClr val="accent1"/>
-          </a:effectRef>
-          <a:fontRef idx="minor">
-            <a:schemeClr val="lt1"/>
-          </a:fontRef>
-        </p:style>
-        <p:txBody>
-          <a:bodyPr rtlCol="0" anchor="ctr"/>
-          <a:lstStyle/>
-          <a:p>
-            <a:pPr algn="ctr"/>
-          </a:p>
-        </p:txBody>
-      </p:sp>
       <p:pic>
         <p:nvPicPr>
-          <p:cNvPr id="13" name="Playfoam illustration" descr="Illustration of Playfoam: a purple tub heaped with tiny colorful beads"/>
+          <p:cNvPr id="9" name="Playfoam illustration" descr="Illustration of Playfoam: a purple tub heaped with tiny colorful beads"/>
           <p:cNvPicPr>
             <a:picLocks noChangeAspect="1"/>
           </p:cNvPicPr>
@@ -4893,8 +4722,8 @@
         </p:blipFill>
         <p:spPr>
           <a:xfrm>
-            <a:off x="9280386" y="4142231"/>
-            <a:ext cx="1311882" cy="1463040"/>
+            <a:off x="8993412" y="3703320"/>
+            <a:ext cx="1885830" cy="2103120"/>
           </a:xfrm>
           <a:prstGeom prst="rect">
             <a:avLst/>
@@ -4903,14 +4732,14 @@
       </p:pic>
       <p:sp>
         <p:nvSpPr>
-          <p:cNvPr id="14" name="Playfoam card title"/>
+          <p:cNvPr id="10" name="Playfoam label"/>
           <p:cNvSpPr txBox="1"/>
           <p:nvPr/>
         </p:nvSpPr>
         <p:spPr>
           <a:xfrm>
-            <a:off x="8427567" y="5760720"/>
-            <a:ext cx="3017520" cy="347472"/>
+            <a:off x="8138160" y="5897879"/>
+            <a:ext cx="3596335" cy="365760"/>
           </a:xfrm>
           <a:prstGeom prst="rect">
             <a:avLst/>
@@ -4925,7 +4754,7 @@
           <a:p>
             <a:pPr algn="ctr"/>
             <a:r>
-              <a:rPr sz="1700" b="1">
+              <a:rPr sz="1600" b="1">
                 <a:solidFill>
                   <a:srgbClr val="051C2C"/>
                 </a:solidFill>
@@ -4938,14 +4767,69 @@
       </p:sp>
       <p:sp>
         <p:nvSpPr>
-          <p:cNvPr id="15" name="Playfoam card caption"/>
+          <p:cNvPr id="11" name="Title"/>
           <p:cNvSpPr txBox="1"/>
           <p:nvPr/>
         </p:nvSpPr>
         <p:spPr>
           <a:xfrm>
-            <a:off x="8427567" y="6080759"/>
-            <a:ext cx="3017520" cy="292608"/>
+            <a:off x="548640" y="1371600"/>
+            <a:ext cx="7040880" cy="2651760"/>
+          </a:xfrm>
+          <a:prstGeom prst="rect">
+            <a:avLst/>
+          </a:prstGeom>
+          <a:noFill/>
+        </p:spPr>
+        <p:txBody>
+          <a:bodyPr wrap="square" lIns="0" rIns="0" tIns="0" bIns="0" anchor="b">
+            <a:spAutoFit/>
+          </a:bodyPr>
+          <a:lstStyle/>
+          <a:p>
+            <a:pPr algn="l"/>
+            <a:r>
+              <a:rPr sz="3800" b="1">
+                <a:solidFill>
+                  <a:srgbClr val="FFFFFF"/>
+                </a:solidFill>
+                <a:latin typeface="Cambria"/>
+              </a:rPr>
+              <a:t>Colorbuds, our #1 profit toy,</a:t>
+            </a:r>
+            <a:br/>
+            <a:r>
+              <a:rPr sz="3800" b="1">
+                <a:solidFill>
+                  <a:srgbClr val="FFFFFF"/>
+                </a:solidFill>
+                <a:latin typeface="Cambria"/>
+              </a:rPr>
+              <a:t>is in decline.</a:t>
+            </a:r>
+            <a:br/>
+            <a:r>
+              <a:rPr sz="3800" b="1">
+                <a:solidFill>
+                  <a:srgbClr val="8FE3C3"/>
+                </a:solidFill>
+                <a:latin typeface="Cambria"/>
+              </a:rPr>
+              <a:t>Playfoam is the next bet.</a:t>
+            </a:r>
+          </a:p>
+        </p:txBody>
+      </p:sp>
+      <p:sp>
+        <p:nvSpPr>
+          <p:cNvPr id="12" name="Subtitle"/>
+          <p:cNvSpPr txBox="1"/>
+          <p:nvPr/>
+        </p:nvSpPr>
+        <p:spPr>
+          <a:xfrm>
+            <a:off x="548640" y="4160520"/>
+            <a:ext cx="6949440" cy="822960"/>
           </a:xfrm>
           <a:prstGeom prst="rect">
             <a:avLst/>
@@ -4958,102 +4842,22 @@
           </a:bodyPr>
           <a:lstStyle/>
           <a:p>
-            <a:pPr algn="ctr"/>
-            <a:r>
-              <a:rPr sz="1300" b="0">
-                <a:solidFill>
-                  <a:srgbClr val="5B6470"/>
+            <a:pPr algn="l"/>
+            <a:r>
+              <a:rPr sz="2200" b="0">
+                <a:solidFill>
+                  <a:srgbClr val="D6E0EE"/>
                 </a:solidFill>
                 <a:latin typeface="Calibri"/>
               </a:rPr>
-              <a:t>Launched Aug 2023, already our #2 profit toy</a:t>
-            </a:r>
-          </a:p>
-        </p:txBody>
-      </p:sp>
-      <p:sp>
-        <p:nvSpPr>
-          <p:cNvPr id="16" name="Title"/>
-          <p:cNvSpPr txBox="1"/>
-          <p:nvPr/>
-        </p:nvSpPr>
-        <p:spPr>
-          <a:xfrm>
-            <a:off x="548640" y="1463040"/>
-            <a:ext cx="7040880" cy="2468880"/>
-          </a:xfrm>
-          <a:prstGeom prst="rect">
-            <a:avLst/>
-          </a:prstGeom>
-          <a:noFill/>
-        </p:spPr>
-        <p:txBody>
-          <a:bodyPr wrap="square" lIns="0" rIns="0" tIns="0" bIns="0" anchor="b">
-            <a:spAutoFit/>
-          </a:bodyPr>
-          <a:lstStyle/>
-          <a:p>
-            <a:pPr algn="l"/>
-            <a:r>
-              <a:rPr sz="4600" b="1">
-                <a:solidFill>
-                  <a:srgbClr val="FFFFFF"/>
-                </a:solidFill>
-                <a:latin typeface="Cambria"/>
-              </a:rPr>
-              <a:t>From Colorbuds</a:t>
-            </a:r>
-            <a:br/>
-            <a:r>
-              <a:rPr sz="4600" b="1">
-                <a:solidFill>
-                  <a:srgbClr val="FFFFFF"/>
-                </a:solidFill>
-                <a:latin typeface="Cambria"/>
-              </a:rPr>
-              <a:t>to Playfoam</a:t>
-            </a:r>
-          </a:p>
-        </p:txBody>
-      </p:sp>
-      <p:sp>
-        <p:nvSpPr>
-          <p:cNvPr id="17" name="Subtitle"/>
-          <p:cNvSpPr txBox="1"/>
-          <p:nvPr/>
-        </p:nvSpPr>
-        <p:spPr>
-          <a:xfrm>
-            <a:off x="548640" y="4160520"/>
-            <a:ext cx="6949440" cy="822960"/>
-          </a:xfrm>
-          <a:prstGeom prst="rect">
-            <a:avLst/>
-          </a:prstGeom>
-          <a:noFill/>
-        </p:spPr>
-        <p:txBody>
-          <a:bodyPr wrap="square" lIns="0" rIns="0" tIns="0" bIns="0" anchor="t">
-            <a:spAutoFit/>
-          </a:bodyPr>
-          <a:lstStyle/>
-          <a:p>
-            <a:pPr algn="l"/>
-            <a:r>
-              <a:rPr sz="2200" b="0">
-                <a:solidFill>
-                  <a:srgbClr val="D6E0EE"/>
-                </a:solidFill>
-                <a:latin typeface="Calibri"/>
-              </a:rPr>
-              <a:t>Our #1 profit toy is in decline. Here is how we protect profit.</a:t>
-            </a:r>
-          </a:p>
-        </p:txBody>
-      </p:sp>
-      <p:sp>
-        <p:nvSpPr>
-          <p:cNvPr id="18" name="Date line"/>
+              <a:t>A plan to protect profit by backing newer, higher-margin toys</a:t>
+            </a:r>
+          </a:p>
+        </p:txBody>
+      </p:sp>
+      <p:sp>
+        <p:nvSpPr>
+          <p:cNvPr id="13" name="Date line"/>
           <p:cNvSpPr txBox="1"/>
           <p:nvPr/>
         </p:nvSpPr>

</xml_diff>

<commit_message>
Cover: muted blue-gray cards; Playfoam beads one teal family with slate tub
Co-Authored-By: Claude Sonnet 5.5 <noreply@anthropic.com>
Claude-Session: https://claude.ai/code/session_01J6v5JYXB5XucuZ66TGAjVJ
</commit_message>
<xml_diff>
--- a/site/deck/Colorbuds_to_Playfoam.pptx
+++ b/site/deck/Colorbuds_to_Playfoam.pptx
@@ -4618,7 +4618,7 @@
             <a:avLst/>
           </a:prstGeom>
           <a:solidFill>
-            <a:srgbClr val="F2F4F7"/>
+            <a:srgbClr val="0B2B45"/>
           </a:solidFill>
           <a:ln>
             <a:noFill/>
@@ -4647,9 +4647,55 @@
           </a:p>
         </p:txBody>
       </p:sp>
+      <p:sp>
+        <p:nvSpPr>
+          <p:cNvPr id="7" name="Colorbuds card"/>
+          <p:cNvSpPr/>
+          <p:nvPr/>
+        </p:nvSpPr>
+        <p:spPr>
+          <a:xfrm>
+            <a:off x="8153247" y="777240"/>
+            <a:ext cx="3566160" cy="2514600"/>
+          </a:xfrm>
+          <a:prstGeom prst="roundRect">
+            <a:avLst>
+              <a:gd name="adj" fmla="val 7000"/>
+            </a:avLst>
+          </a:prstGeom>
+          <a:solidFill>
+            <a:srgbClr val="CDD6E0"/>
+          </a:solidFill>
+          <a:ln>
+            <a:noFill/>
+          </a:ln>
+          <a:effectLst/>
+        </p:spPr>
+        <p:style>
+          <a:lnRef idx="1">
+            <a:schemeClr val="accent1"/>
+          </a:lnRef>
+          <a:fillRef idx="3">
+            <a:schemeClr val="accent1"/>
+          </a:fillRef>
+          <a:effectRef idx="0">
+            <a:schemeClr val="accent1"/>
+          </a:effectRef>
+          <a:fontRef idx="minor">
+            <a:schemeClr val="lt1"/>
+          </a:fontRef>
+        </p:style>
+        <p:txBody>
+          <a:bodyPr rtlCol="0" anchor="ctr"/>
+          <a:lstStyle/>
+          <a:p>
+            <a:pPr algn="ctr"/>
+          </a:p>
+        </p:txBody>
+      </p:sp>
       <p:pic>
         <p:nvPicPr>
-          <p:cNvPr id="7" name="Colorbuds illustration" descr="Illustration of Colorbuds: two colorful earbuds in an open charging case with a heart"/>
+          <p:cNvPr id="8" name="Colorbuds illustration" descr="Illustration of Colorbuds: two colorful earbuds in an open charging case with a heart"/>
           <p:cNvPicPr>
             <a:picLocks noChangeAspect="1"/>
           </p:cNvPicPr>
@@ -4663,8 +4709,8 @@
         </p:blipFill>
         <p:spPr>
           <a:xfrm>
-            <a:off x="9184755" y="731520"/>
-            <a:ext cx="1503143" cy="2103120"/>
+            <a:off x="9413495" y="941832"/>
+            <a:ext cx="1045665" cy="1463040"/>
           </a:xfrm>
           <a:prstGeom prst="rect">
             <a:avLst/>
@@ -4673,14 +4719,14 @@
       </p:pic>
       <p:sp>
         <p:nvSpPr>
-          <p:cNvPr id="8" name="Colorbuds label"/>
+          <p:cNvPr id="9" name="Colorbuds card title"/>
           <p:cNvSpPr txBox="1"/>
           <p:nvPr/>
         </p:nvSpPr>
         <p:spPr>
           <a:xfrm>
-            <a:off x="8138160" y="2926079"/>
-            <a:ext cx="3596335" cy="365760"/>
+            <a:off x="8427567" y="2560320"/>
+            <a:ext cx="3017520" cy="347472"/>
           </a:xfrm>
           <a:prstGeom prst="rect">
             <a:avLst/>
@@ -4695,7 +4741,7 @@
           <a:p>
             <a:pPr algn="ctr"/>
             <a:r>
-              <a:rPr sz="1600" b="1">
+              <a:rPr sz="1700" b="1">
                 <a:solidFill>
                   <a:srgbClr val="051C2C"/>
                 </a:solidFill>
@@ -4706,9 +4752,134 @@
           </a:p>
         </p:txBody>
       </p:sp>
+      <p:sp>
+        <p:nvSpPr>
+          <p:cNvPr id="10" name="Colorbuds card caption"/>
+          <p:cNvSpPr txBox="1"/>
+          <p:nvPr/>
+        </p:nvSpPr>
+        <p:spPr>
+          <a:xfrm>
+            <a:off x="8427567" y="2880360"/>
+            <a:ext cx="3017520" cy="292608"/>
+          </a:xfrm>
+          <a:prstGeom prst="rect">
+            <a:avLst/>
+          </a:prstGeom>
+          <a:noFill/>
+        </p:spPr>
+        <p:txBody>
+          <a:bodyPr wrap="square" lIns="0" rIns="0" tIns="0" bIns="0" anchor="t">
+            <a:spAutoFit/>
+          </a:bodyPr>
+          <a:lstStyle/>
+          <a:p>
+            <a:pPr algn="ctr"/>
+            <a:r>
+              <a:rPr sz="1300" b="0">
+                <a:solidFill>
+                  <a:srgbClr val="3E4A5A"/>
+                </a:solidFill>
+                <a:latin typeface="Calibri"/>
+              </a:rPr>
+              <a:t>Our #1 profit toy, in decline</a:t>
+            </a:r>
+          </a:p>
+        </p:txBody>
+      </p:sp>
+      <p:sp>
+        <p:nvSpPr>
+          <p:cNvPr id="11" name="Arrow from Colorbuds to Playfoam"/>
+          <p:cNvSpPr/>
+          <p:nvPr/>
+        </p:nvSpPr>
+        <p:spPr>
+          <a:xfrm>
+            <a:off x="9753447" y="3383280"/>
+            <a:ext cx="365760" cy="365760"/>
+          </a:xfrm>
+          <a:prstGeom prst="downArrow">
+            <a:avLst/>
+          </a:prstGeom>
+          <a:solidFill>
+            <a:srgbClr val="5FA892"/>
+          </a:solidFill>
+          <a:ln>
+            <a:noFill/>
+          </a:ln>
+          <a:effectLst/>
+        </p:spPr>
+        <p:style>
+          <a:lnRef idx="1">
+            <a:schemeClr val="accent1"/>
+          </a:lnRef>
+          <a:fillRef idx="3">
+            <a:schemeClr val="accent1"/>
+          </a:fillRef>
+          <a:effectRef idx="0">
+            <a:schemeClr val="accent1"/>
+          </a:effectRef>
+          <a:fontRef idx="minor">
+            <a:schemeClr val="lt1"/>
+          </a:fontRef>
+        </p:style>
+        <p:txBody>
+          <a:bodyPr rtlCol="0" anchor="ctr"/>
+          <a:lstStyle/>
+          <a:p>
+            <a:pPr algn="ctr"/>
+          </a:p>
+        </p:txBody>
+      </p:sp>
+      <p:sp>
+        <p:nvSpPr>
+          <p:cNvPr id="12" name="Playfoam card"/>
+          <p:cNvSpPr/>
+          <p:nvPr/>
+        </p:nvSpPr>
+        <p:spPr>
+          <a:xfrm>
+            <a:off x="8153247" y="3977639"/>
+            <a:ext cx="3566160" cy="2514600"/>
+          </a:xfrm>
+          <a:prstGeom prst="roundRect">
+            <a:avLst>
+              <a:gd name="adj" fmla="val 7000"/>
+            </a:avLst>
+          </a:prstGeom>
+          <a:solidFill>
+            <a:srgbClr val="CDD6E0"/>
+          </a:solidFill>
+          <a:ln>
+            <a:noFill/>
+          </a:ln>
+          <a:effectLst/>
+        </p:spPr>
+        <p:style>
+          <a:lnRef idx="1">
+            <a:schemeClr val="accent1"/>
+          </a:lnRef>
+          <a:fillRef idx="3">
+            <a:schemeClr val="accent1"/>
+          </a:fillRef>
+          <a:effectRef idx="0">
+            <a:schemeClr val="accent1"/>
+          </a:effectRef>
+          <a:fontRef idx="minor">
+            <a:schemeClr val="lt1"/>
+          </a:fontRef>
+        </p:style>
+        <p:txBody>
+          <a:bodyPr rtlCol="0" anchor="ctr"/>
+          <a:lstStyle/>
+          <a:p>
+            <a:pPr algn="ctr"/>
+          </a:p>
+        </p:txBody>
+      </p:sp>
       <p:pic>
         <p:nvPicPr>
-          <p:cNvPr id="9" name="Playfoam illustration" descr="Illustration of Playfoam: a purple tub heaped with tiny colorful beads"/>
+          <p:cNvPr id="13" name="Playfoam illustration" descr="Illustration of Playfoam: a blue tub heaped with tiny teal beads"/>
           <p:cNvPicPr>
             <a:picLocks noChangeAspect="1"/>
           </p:cNvPicPr>
@@ -4722,8 +4893,8 @@
         </p:blipFill>
         <p:spPr>
           <a:xfrm>
-            <a:off x="8993412" y="3703320"/>
-            <a:ext cx="1885830" cy="2103120"/>
+            <a:off x="9280386" y="4142231"/>
+            <a:ext cx="1311882" cy="1463040"/>
           </a:xfrm>
           <a:prstGeom prst="rect">
             <a:avLst/>
@@ -4732,14 +4903,14 @@
       </p:pic>
       <p:sp>
         <p:nvSpPr>
-          <p:cNvPr id="10" name="Playfoam label"/>
+          <p:cNvPr id="14" name="Playfoam card title"/>
           <p:cNvSpPr txBox="1"/>
           <p:nvPr/>
         </p:nvSpPr>
         <p:spPr>
           <a:xfrm>
-            <a:off x="8138160" y="5897879"/>
-            <a:ext cx="3596335" cy="365760"/>
+            <a:off x="8427567" y="5760720"/>
+            <a:ext cx="3017520" cy="347472"/>
           </a:xfrm>
           <a:prstGeom prst="rect">
             <a:avLst/>
@@ -4754,7 +4925,7 @@
           <a:p>
             <a:pPr algn="ctr"/>
             <a:r>
-              <a:rPr sz="1600" b="1">
+              <a:rPr sz="1700" b="1">
                 <a:solidFill>
                   <a:srgbClr val="051C2C"/>
                 </a:solidFill>
@@ -4767,14 +4938,49 @@
       </p:sp>
       <p:sp>
         <p:nvSpPr>
-          <p:cNvPr id="11" name="Title"/>
+          <p:cNvPr id="15" name="Playfoam card caption"/>
           <p:cNvSpPr txBox="1"/>
           <p:nvPr/>
         </p:nvSpPr>
         <p:spPr>
           <a:xfrm>
-            <a:off x="548640" y="1371600"/>
-            <a:ext cx="7040880" cy="2651760"/>
+            <a:off x="8427567" y="6080759"/>
+            <a:ext cx="3017520" cy="292608"/>
+          </a:xfrm>
+          <a:prstGeom prst="rect">
+            <a:avLst/>
+          </a:prstGeom>
+          <a:noFill/>
+        </p:spPr>
+        <p:txBody>
+          <a:bodyPr wrap="square" lIns="0" rIns="0" tIns="0" bIns="0" anchor="t">
+            <a:spAutoFit/>
+          </a:bodyPr>
+          <a:lstStyle/>
+          <a:p>
+            <a:pPr algn="ctr"/>
+            <a:r>
+              <a:rPr sz="1300" b="0">
+                <a:solidFill>
+                  <a:srgbClr val="3E4A5A"/>
+                </a:solidFill>
+                <a:latin typeface="Calibri"/>
+              </a:rPr>
+              <a:t>Launched Aug 2023, already our #2 profit toy</a:t>
+            </a:r>
+          </a:p>
+        </p:txBody>
+      </p:sp>
+      <p:sp>
+        <p:nvSpPr>
+          <p:cNvPr id="16" name="Title"/>
+          <p:cNvSpPr txBox="1"/>
+          <p:nvPr/>
+        </p:nvSpPr>
+        <p:spPr>
+          <a:xfrm>
+            <a:off x="548640" y="1463040"/>
+            <a:ext cx="7040880" cy="2468880"/>
           </a:xfrm>
           <a:prstGeom prst="rect">
             <a:avLst/>
@@ -4789,40 +4995,30 @@
           <a:p>
             <a:pPr algn="l"/>
             <a:r>
-              <a:rPr sz="3800" b="1">
+              <a:rPr sz="4600" b="1">
                 <a:solidFill>
                   <a:srgbClr val="FFFFFF"/>
                 </a:solidFill>
                 <a:latin typeface="Cambria"/>
               </a:rPr>
-              <a:t>Colorbuds, our #1 profit toy,</a:t>
+              <a:t>From Colorbuds</a:t>
             </a:r>
             <a:br/>
             <a:r>
-              <a:rPr sz="3800" b="1">
+              <a:rPr sz="4600" b="1">
                 <a:solidFill>
                   <a:srgbClr val="FFFFFF"/>
                 </a:solidFill>
                 <a:latin typeface="Cambria"/>
               </a:rPr>
-              <a:t>is in decline.</a:t>
-            </a:r>
-            <a:br/>
-            <a:r>
-              <a:rPr sz="3800" b="1">
-                <a:solidFill>
-                  <a:srgbClr val="8FE3C3"/>
-                </a:solidFill>
-                <a:latin typeface="Cambria"/>
-              </a:rPr>
-              <a:t>Playfoam is the next bet.</a:t>
-            </a:r>
-          </a:p>
-        </p:txBody>
-      </p:sp>
-      <p:sp>
-        <p:nvSpPr>
-          <p:cNvPr id="12" name="Subtitle"/>
+              <a:t>to Playfoam</a:t>
+            </a:r>
+          </a:p>
+        </p:txBody>
+      </p:sp>
+      <p:sp>
+        <p:nvSpPr>
+          <p:cNvPr id="17" name="Subtitle"/>
           <p:cNvSpPr txBox="1"/>
           <p:nvPr/>
         </p:nvSpPr>
@@ -4850,14 +5046,14 @@
                 </a:solidFill>
                 <a:latin typeface="Calibri"/>
               </a:rPr>
-              <a:t>A plan to protect profit by backing newer, higher-margin toys</a:t>
-            </a:r>
-          </a:p>
-        </p:txBody>
-      </p:sp>
-      <p:sp>
-        <p:nvSpPr>
-          <p:cNvPr id="13" name="Date line"/>
+              <a:t>Our #1 profit toy is in decline. Here is how we protect profit.</a:t>
+            </a:r>
+          </a:p>
+        </p:txBody>
+      </p:sp>
+      <p:sp>
+        <p:nvSpPr>
+          <p:cNvPr id="18" name="Date line"/>
           <p:cNvSpPr txBox="1"/>
           <p:nvPr/>
         </p:nvSpPr>

</xml_diff>

<commit_message>
Teal earbuds, slimmer centered cover arrow
</commit_message>
<xml_diff>
--- a/site/deck/Colorbuds_to_Playfoam.pptx
+++ b/site/deck/Colorbuds_to_Playfoam.pptx
@@ -4795,14 +4795,17 @@
         </p:nvSpPr>
         <p:spPr>
           <a:xfrm>
-            <a:off x="9753447" y="3383280"/>
-            <a:ext cx="365760" cy="365760"/>
+            <a:off x="9780879" y="3406140"/>
+            <a:ext cx="310896" cy="457200"/>
           </a:xfrm>
           <a:prstGeom prst="downArrow">
-            <a:avLst/>
+            <a:avLst>
+              <a:gd name="adj1" fmla="val 38000"/>
+              <a:gd name="adj2" fmla="val 55000"/>
+            </a:avLst>
           </a:prstGeom>
           <a:solidFill>
-            <a:srgbClr val="5FA892"/>
+            <a:srgbClr val="62A6A0"/>
           </a:solidFill>
           <a:ln>
             <a:noFill/>

</xml_diff>